<commit_message>
reorder dataset generation into decoys and supported cryptics
Protein-coding base set, canonical split, exon removal on the deep-intronic
branch, then CLIP support split into decoys and cryptic sites. Cryptics are
kept when their intron's canonical 5'SS is bound by PRPF8 or SmB, using
canonical windows regenerated without the 400 nt SpliceAI flank offset.
Removes the Recount filtering and cross-species MAF scan scripts, and
ignores large regenerable intermediates in results/.

Co-Authored-By: Claude Opus 5 <noreply@anthropic.com>
</commit_message>
<xml_diff>
--- a/figures/datasetgenerationflowchart.pptx
+++ b/figures/datasetgenerationflowchart.pptx
@@ -6,6 +6,8 @@
   </p:sldMasterIdLst>
   <p:sldIdLst>
     <p:sldId id="256" r:id="rId2"/>
+    <p:sldId id="257" r:id="rId3"/>
+    <p:sldId id="258" r:id="rId4"/>
   </p:sldIdLst>
   <p:sldSz cx="6858000" cy="12192000"/>
   <p:notesSz cx="6858000" cy="9144000"/>
@@ -261,7 +263,7 @@
           <a:p>
             <a:fld id="{0DAF61AA-5A98-4049-A93E-477E5505141A}" type="datetimeFigureOut">
               <a:rPr lang="en-US" smtClean="0"/>
-              <a:t>8/20/2026</a:t>
+              <a:t>9/11/2026</a:t>
             </a:fld>
             <a:endParaRPr lang="en-US" dirty="0"/>
           </a:p>
@@ -461,7 +463,7 @@
           <a:p>
             <a:fld id="{0DAF61AA-5A98-4049-A93E-477E5505141A}" type="datetimeFigureOut">
               <a:rPr lang="en-US" smtClean="0"/>
-              <a:t>8/20/2026</a:t>
+              <a:t>9/11/2026</a:t>
             </a:fld>
             <a:endParaRPr lang="en-US"/>
           </a:p>
@@ -671,7 +673,7 @@
           <a:p>
             <a:fld id="{0DAF61AA-5A98-4049-A93E-477E5505141A}" type="datetimeFigureOut">
               <a:rPr lang="en-US" smtClean="0"/>
-              <a:t>8/20/2026</a:t>
+              <a:t>9/11/2026</a:t>
             </a:fld>
             <a:endParaRPr lang="en-US"/>
           </a:p>
@@ -871,7 +873,7 @@
           <a:p>
             <a:fld id="{0DAF61AA-5A98-4049-A93E-477E5505141A}" type="datetimeFigureOut">
               <a:rPr lang="en-US" smtClean="0"/>
-              <a:t>8/20/2026</a:t>
+              <a:t>9/11/2026</a:t>
             </a:fld>
             <a:endParaRPr lang="en-US"/>
           </a:p>
@@ -1147,7 +1149,7 @@
           <a:p>
             <a:fld id="{0DAF61AA-5A98-4049-A93E-477E5505141A}" type="datetimeFigureOut">
               <a:rPr lang="en-US" smtClean="0"/>
-              <a:t>8/20/2026</a:t>
+              <a:t>9/11/2026</a:t>
             </a:fld>
             <a:endParaRPr lang="en-US"/>
           </a:p>
@@ -1415,7 +1417,7 @@
           <a:p>
             <a:fld id="{0DAF61AA-5A98-4049-A93E-477E5505141A}" type="datetimeFigureOut">
               <a:rPr lang="en-US" smtClean="0"/>
-              <a:t>8/20/2026</a:t>
+              <a:t>9/11/2026</a:t>
             </a:fld>
             <a:endParaRPr lang="en-US"/>
           </a:p>
@@ -1830,7 +1832,7 @@
           <a:p>
             <a:fld id="{0DAF61AA-5A98-4049-A93E-477E5505141A}" type="datetimeFigureOut">
               <a:rPr lang="en-US" smtClean="0"/>
-              <a:t>8/20/2026</a:t>
+              <a:t>9/11/2026</a:t>
             </a:fld>
             <a:endParaRPr lang="en-US"/>
           </a:p>
@@ -1972,7 +1974,7 @@
           <a:p>
             <a:fld id="{0DAF61AA-5A98-4049-A93E-477E5505141A}" type="datetimeFigureOut">
               <a:rPr lang="en-US" smtClean="0"/>
-              <a:t>8/20/2026</a:t>
+              <a:t>9/11/2026</a:t>
             </a:fld>
             <a:endParaRPr lang="en-US"/>
           </a:p>
@@ -2085,7 +2087,7 @@
           <a:p>
             <a:fld id="{0DAF61AA-5A98-4049-A93E-477E5505141A}" type="datetimeFigureOut">
               <a:rPr lang="en-US" smtClean="0"/>
-              <a:t>8/20/2026</a:t>
+              <a:t>9/11/2026</a:t>
             </a:fld>
             <a:endParaRPr lang="en-US"/>
           </a:p>
@@ -2398,7 +2400,7 @@
           <a:p>
             <a:fld id="{0DAF61AA-5A98-4049-A93E-477E5505141A}" type="datetimeFigureOut">
               <a:rPr lang="en-US" smtClean="0"/>
-              <a:t>8/20/2026</a:t>
+              <a:t>9/11/2026</a:t>
             </a:fld>
             <a:endParaRPr lang="en-US"/>
           </a:p>
@@ -2691,7 +2693,7 @@
           <a:p>
             <a:fld id="{0DAF61AA-5A98-4049-A93E-477E5505141A}" type="datetimeFigureOut">
               <a:rPr lang="en-US" smtClean="0"/>
-              <a:t>8/20/2026</a:t>
+              <a:t>9/11/2026</a:t>
             </a:fld>
             <a:endParaRPr lang="en-US"/>
           </a:p>
@@ -6404,7 +6406,7 @@
             <a:fld id="{0DAF61AA-5A98-4049-A93E-477E5505141A}" type="datetimeFigureOut">
               <a:rPr lang="en-US" smtClean="0"/>
               <a:pPr/>
-              <a:t>8/20/2026</a:t>
+              <a:t>9/11/2026</a:t>
             </a:fld>
             <a:endParaRPr lang="en-US" dirty="0"/>
           </a:p>
@@ -6988,7 +6990,7 @@
         </p:nvSpPr>
         <p:spPr>
           <a:xfrm>
-            <a:off x="694592" y="2412999"/>
+            <a:off x="694592" y="4143828"/>
             <a:ext cx="5468816" cy="5762873"/>
           </a:xfrm>
           <a:prstGeom prst="rect">
@@ -7023,34 +7025,13 @@
           <a:p>
             <a:pPr algn="ctr"/>
             <a:r>
-              <a:rPr lang="en-US" sz="1600" dirty="0" err="1">
+              <a:rPr lang="en-US" sz="1600" dirty="0">
                 <a:solidFill>
                   <a:sysClr val="windowText" lastClr="000000"/>
                 </a:solidFill>
                 <a:latin typeface="Abadi" panose="020B0604020104020204" pitchFamily="34" charset="0"/>
               </a:rPr>
-              <a:t>RBPnet</a:t>
-            </a:r>
-            <a:r>
-              <a:rPr lang="en-US" sz="1600" dirty="0">
-                <a:solidFill>
-                  <a:sysClr val="windowText" lastClr="000000"/>
-                </a:solidFill>
-                <a:latin typeface="Abadi" panose="020B0604020104020204" pitchFamily="34" charset="0"/>
-              </a:rPr>
-              <a:t> PRPF8 predictions across introns 242,946 Peaks</a:t>
-            </a:r>
-          </a:p>
-          <a:p>
-            <a:pPr algn="ctr"/>
-            <a:r>
-              <a:rPr lang="en-US" sz="1600" dirty="0">
-                <a:solidFill>
-                  <a:sysClr val="windowText" lastClr="000000"/>
-                </a:solidFill>
-                <a:latin typeface="Abadi" panose="020B0604020104020204" pitchFamily="34" charset="0"/>
-              </a:rPr>
-              <a:t>rbpnet_clippy_f50_rollmean10_minHeightAdjust1.0_minPromAdjust1.0_minGeneCount5_Peaks.bed</a:t>
+              <a:t>Intersect –v to remove splice sites within 100 bp of canonical splice sites</a:t>
             </a:r>
           </a:p>
           <a:p>
@@ -7065,62 +7046,119 @@
           <a:p>
             <a:pPr algn="ctr"/>
             <a:r>
-              <a:rPr lang="en-US" sz="1600" dirty="0">
-                <a:solidFill>
-                  <a:sysClr val="windowText" lastClr="000000"/>
-                </a:solidFill>
-                <a:latin typeface="Abadi" panose="020B0604020104020204" pitchFamily="34" charset="0"/>
-              </a:rPr>
-              <a:t>Merged PRPF8 </a:t>
-            </a:r>
-            <a:r>
               <a:rPr lang="en-US" sz="1600" dirty="0" err="1">
                 <a:solidFill>
-                  <a:sysClr val="windowText" lastClr="000000"/>
-                </a:solidFill>
-                <a:latin typeface="Abadi" panose="020B0604020104020204" pitchFamily="34" charset="0"/>
-              </a:rPr>
-              <a:t>eCLIP</a:t>
-            </a:r>
-            <a:r>
-              <a:rPr lang="en-US" sz="1600" dirty="0">
-                <a:solidFill>
-                  <a:sysClr val="windowText" lastClr="000000"/>
-                </a:solidFill>
-                <a:latin typeface="Abadi" panose="020B0604020104020204" pitchFamily="34" charset="0"/>
-              </a:rPr>
-              <a:t> and </a:t>
-            </a:r>
-            <a:r>
-              <a:rPr lang="en-US" sz="1600" dirty="0" err="1">
-                <a:solidFill>
-                  <a:sysClr val="windowText" lastClr="000000"/>
-                </a:solidFill>
-                <a:latin typeface="Abadi" panose="020B0604020104020204" pitchFamily="34" charset="0"/>
-              </a:rPr>
-              <a:t>iCLIP</a:t>
-            </a:r>
-            <a:r>
-              <a:rPr lang="en-US" sz="1600" dirty="0">
-                <a:solidFill>
-                  <a:sysClr val="windowText" lastClr="000000"/>
-                </a:solidFill>
-                <a:latin typeface="Abadi" panose="020B0604020104020204" pitchFamily="34" charset="0"/>
-              </a:rPr>
-              <a:t> 227,651 Peaks</a:t>
-            </a:r>
+                  <a:schemeClr val="accent1"/>
+                </a:solidFill>
+                <a:latin typeface="Abadi" panose="020B0604020104020204" pitchFamily="34" charset="0"/>
+              </a:rPr>
+              <a:t>Wide_canonical_splice_sites.bed</a:t>
+            </a:r>
+            <a:endParaRPr lang="en-US" sz="1600" dirty="0">
+              <a:solidFill>
+                <a:schemeClr val="accent1"/>
+              </a:solidFill>
+              <a:latin typeface="Abadi" panose="020B0604020104020204" pitchFamily="34" charset="0"/>
+            </a:endParaRPr>
           </a:p>
           <a:p>
             <a:pPr algn="ctr"/>
-            <a:r>
-              <a:rPr lang="en-US" sz="1600" dirty="0">
-                <a:solidFill>
-                  <a:sysClr val="windowText" lastClr="000000"/>
-                </a:solidFill>
-                <a:latin typeface="Abadi" panose="020B0604020104020204" pitchFamily="34" charset="0"/>
-              </a:rPr>
-              <a:t>PRPF8_clippy_w0.5_rollmean80_minHeightAdjust3.0_minPromAdjust3.0_minGeneCount5_Peaks.bed</a:t>
-            </a:r>
+            <a:endParaRPr lang="en-US" sz="1600" dirty="0">
+              <a:solidFill>
+                <a:schemeClr val="accent1"/>
+              </a:solidFill>
+              <a:latin typeface="Abadi" panose="020B0604020104020204" pitchFamily="34" charset="0"/>
+            </a:endParaRPr>
+          </a:p>
+          <a:p>
+            <a:pPr algn="ctr"/>
+            <a:endParaRPr lang="en-US" sz="1600" dirty="0">
+              <a:solidFill>
+                <a:schemeClr val="accent1"/>
+              </a:solidFill>
+              <a:latin typeface="Abadi" panose="020B0604020104020204" pitchFamily="34" charset="0"/>
+            </a:endParaRPr>
+          </a:p>
+          <a:p>
+            <a:pPr algn="ctr"/>
+            <a:endParaRPr lang="en-US" sz="1600" dirty="0">
+              <a:solidFill>
+                <a:schemeClr val="accent1"/>
+              </a:solidFill>
+              <a:latin typeface="Abadi" panose="020B0604020104020204" pitchFamily="34" charset="0"/>
+            </a:endParaRPr>
+          </a:p>
+          <a:p>
+            <a:pPr algn="ctr"/>
+            <a:endParaRPr lang="en-US" sz="1600" dirty="0">
+              <a:solidFill>
+                <a:schemeClr val="accent1"/>
+              </a:solidFill>
+              <a:latin typeface="Abadi" panose="020B0604020104020204" pitchFamily="34" charset="0"/>
+            </a:endParaRPr>
+          </a:p>
+          <a:p>
+            <a:pPr algn="ctr"/>
+            <a:endParaRPr lang="en-US" sz="1600" dirty="0">
+              <a:solidFill>
+                <a:schemeClr val="accent1"/>
+              </a:solidFill>
+              <a:latin typeface="Abadi" panose="020B0604020104020204" pitchFamily="34" charset="0"/>
+            </a:endParaRPr>
+          </a:p>
+          <a:p>
+            <a:pPr algn="ctr"/>
+            <a:endParaRPr lang="en-US" sz="1600" dirty="0">
+              <a:solidFill>
+                <a:schemeClr val="accent1"/>
+              </a:solidFill>
+              <a:latin typeface="Abadi" panose="020B0604020104020204" pitchFamily="34" charset="0"/>
+            </a:endParaRPr>
+          </a:p>
+          <a:p>
+            <a:pPr algn="ctr"/>
+            <a:endParaRPr lang="en-US" sz="1600" dirty="0">
+              <a:solidFill>
+                <a:schemeClr val="accent1"/>
+              </a:solidFill>
+              <a:latin typeface="Abadi" panose="020B0604020104020204" pitchFamily="34" charset="0"/>
+            </a:endParaRPr>
+          </a:p>
+          <a:p>
+            <a:pPr algn="ctr"/>
+            <a:endParaRPr lang="en-US" sz="1600" dirty="0">
+              <a:solidFill>
+                <a:schemeClr val="accent1"/>
+              </a:solidFill>
+              <a:latin typeface="Abadi" panose="020B0604020104020204" pitchFamily="34" charset="0"/>
+            </a:endParaRPr>
+          </a:p>
+          <a:p>
+            <a:pPr algn="ctr"/>
+            <a:endParaRPr lang="en-US" sz="1600" dirty="0">
+              <a:solidFill>
+                <a:schemeClr val="accent1"/>
+              </a:solidFill>
+              <a:latin typeface="Abadi" panose="020B0604020104020204" pitchFamily="34" charset="0"/>
+            </a:endParaRPr>
+          </a:p>
+          <a:p>
+            <a:pPr algn="ctr"/>
+            <a:endParaRPr lang="en-US" sz="1600" dirty="0">
+              <a:solidFill>
+                <a:schemeClr val="accent1"/>
+              </a:solidFill>
+              <a:latin typeface="Abadi" panose="020B0604020104020204" pitchFamily="34" charset="0"/>
+            </a:endParaRPr>
+          </a:p>
+          <a:p>
+            <a:pPr algn="ctr"/>
+            <a:endParaRPr lang="en-US" sz="1600" dirty="0">
+              <a:solidFill>
+                <a:schemeClr val="accent1"/>
+              </a:solidFill>
+              <a:latin typeface="Abadi" panose="020B0604020104020204" pitchFamily="34" charset="0"/>
+            </a:endParaRPr>
           </a:p>
           <a:p>
             <a:pPr algn="ctr"/>
@@ -7134,6 +7172,111 @@
           <a:p>
             <a:pPr algn="ctr"/>
             <a:r>
+              <a:rPr lang="en-US" sz="1600" dirty="0" err="1">
+                <a:solidFill>
+                  <a:sysClr val="windowText" lastClr="000000"/>
+                </a:solidFill>
+                <a:latin typeface="Abadi" panose="020B0604020104020204" pitchFamily="34" charset="0"/>
+              </a:rPr>
+              <a:t>RBPnet</a:t>
+            </a:r>
+            <a:r>
+              <a:rPr lang="en-US" sz="1600" dirty="0">
+                <a:solidFill>
+                  <a:sysClr val="windowText" lastClr="000000"/>
+                </a:solidFill>
+                <a:latin typeface="Abadi" panose="020B0604020104020204" pitchFamily="34" charset="0"/>
+              </a:rPr>
+              <a:t> </a:t>
+            </a:r>
+            <a:r>
+              <a:rPr lang="en-US" sz="1600" dirty="0">
+                <a:solidFill>
+                  <a:schemeClr val="accent1"/>
+                </a:solidFill>
+                <a:latin typeface="Abadi" panose="020B0604020104020204" pitchFamily="34" charset="0"/>
+              </a:rPr>
+              <a:t>PRPF8</a:t>
+            </a:r>
+            <a:r>
+              <a:rPr lang="en-US" sz="1600" dirty="0">
+                <a:solidFill>
+                  <a:sysClr val="windowText" lastClr="000000"/>
+                </a:solidFill>
+                <a:latin typeface="Abadi" panose="020B0604020104020204" pitchFamily="34" charset="0"/>
+              </a:rPr>
+              <a:t> predictions across introns 242,946 Peaks</a:t>
+            </a:r>
+          </a:p>
+          <a:p>
+            <a:pPr algn="ctr"/>
+            <a:r>
+              <a:rPr lang="en-US" sz="1600" dirty="0">
+                <a:solidFill>
+                  <a:sysClr val="windowText" lastClr="000000"/>
+                </a:solidFill>
+                <a:latin typeface="Abadi" panose="020B0604020104020204" pitchFamily="34" charset="0"/>
+              </a:rPr>
+              <a:t>Merged </a:t>
+            </a:r>
+            <a:r>
+              <a:rPr lang="en-US" sz="1600" dirty="0">
+                <a:solidFill>
+                  <a:schemeClr val="accent1"/>
+                </a:solidFill>
+                <a:latin typeface="Abadi" panose="020B0604020104020204" pitchFamily="34" charset="0"/>
+              </a:rPr>
+              <a:t>PRPF8 </a:t>
+            </a:r>
+            <a:r>
+              <a:rPr lang="en-US" sz="1600" dirty="0" err="1">
+                <a:solidFill>
+                  <a:schemeClr val="accent1"/>
+                </a:solidFill>
+                <a:latin typeface="Abadi" panose="020B0604020104020204" pitchFamily="34" charset="0"/>
+              </a:rPr>
+              <a:t>eCLIP</a:t>
+            </a:r>
+            <a:r>
+              <a:rPr lang="en-US" sz="1600" dirty="0">
+                <a:solidFill>
+                  <a:schemeClr val="accent1"/>
+                </a:solidFill>
+                <a:latin typeface="Abadi" panose="020B0604020104020204" pitchFamily="34" charset="0"/>
+              </a:rPr>
+              <a:t> and </a:t>
+            </a:r>
+            <a:r>
+              <a:rPr lang="en-US" sz="1600" dirty="0" err="1">
+                <a:solidFill>
+                  <a:schemeClr val="accent1"/>
+                </a:solidFill>
+                <a:latin typeface="Abadi" panose="020B0604020104020204" pitchFamily="34" charset="0"/>
+              </a:rPr>
+              <a:t>iCLIP</a:t>
+            </a:r>
+            <a:r>
+              <a:rPr lang="en-US" sz="1600" dirty="0">
+                <a:solidFill>
+                  <a:schemeClr val="accent1"/>
+                </a:solidFill>
+                <a:latin typeface="Abadi" panose="020B0604020104020204" pitchFamily="34" charset="0"/>
+              </a:rPr>
+              <a:t> </a:t>
+            </a:r>
+            <a:r>
+              <a:rPr lang="en-US" sz="1600" dirty="0">
+                <a:solidFill>
+                  <a:sysClr val="windowText" lastClr="000000"/>
+                </a:solidFill>
+                <a:latin typeface="Abadi" panose="020B0604020104020204" pitchFamily="34" charset="0"/>
+              </a:rPr>
+              <a:t>227,651 Peaks</a:t>
+            </a:r>
+          </a:p>
+          <a:p>
+            <a:pPr algn="ctr"/>
+            <a:r>
               <a:rPr lang="en-GB" sz="1600" dirty="0">
                 <a:solidFill>
                   <a:sysClr val="windowText" lastClr="000000"/>
@@ -7145,50 +7288,47 @@
             <a:r>
               <a:rPr lang="en-GB" sz="1600" dirty="0" err="1">
                 <a:solidFill>
+                  <a:schemeClr val="accent1"/>
+                </a:solidFill>
+                <a:latin typeface="Abadi" panose="020B0604020104020204" pitchFamily="34" charset="0"/>
+              </a:rPr>
+              <a:t>SmB</a:t>
+            </a:r>
+            <a:r>
+              <a:rPr lang="en-GB" sz="1600" dirty="0">
+                <a:solidFill>
+                  <a:schemeClr val="accent1"/>
+                </a:solidFill>
+                <a:latin typeface="Abadi" panose="020B0604020104020204" pitchFamily="34" charset="0"/>
+              </a:rPr>
+              <a:t> </a:t>
+            </a:r>
+            <a:r>
+              <a:rPr lang="en-GB" sz="1600" dirty="0" err="1">
+                <a:solidFill>
+                  <a:schemeClr val="accent1"/>
+                </a:solidFill>
+                <a:latin typeface="Abadi" panose="020B0604020104020204" pitchFamily="34" charset="0"/>
+              </a:rPr>
+              <a:t>iCLIP</a:t>
+            </a:r>
+            <a:r>
+              <a:rPr lang="en-GB" sz="1600" dirty="0">
+                <a:solidFill>
+                  <a:schemeClr val="accent1"/>
+                </a:solidFill>
+                <a:latin typeface="Abadi" panose="020B0604020104020204" pitchFamily="34" charset="0"/>
+              </a:rPr>
+              <a:t> </a:t>
+            </a:r>
+            <a:r>
+              <a:rPr lang="en-GB" sz="1600" dirty="0">
+                <a:solidFill>
                   <a:sysClr val="windowText" lastClr="000000"/>
                 </a:solidFill>
                 <a:latin typeface="Abadi" panose="020B0604020104020204" pitchFamily="34" charset="0"/>
               </a:rPr>
-              <a:t>SmB</a:t>
-            </a:r>
-            <a:r>
-              <a:rPr lang="en-GB" sz="1600" dirty="0">
-                <a:solidFill>
-                  <a:sysClr val="windowText" lastClr="000000"/>
-                </a:solidFill>
-                <a:latin typeface="Abadi" panose="020B0604020104020204" pitchFamily="34" charset="0"/>
-              </a:rPr>
-              <a:t> </a:t>
-            </a:r>
-            <a:r>
-              <a:rPr lang="en-GB" sz="1600" dirty="0" err="1">
-                <a:solidFill>
-                  <a:sysClr val="windowText" lastClr="000000"/>
-                </a:solidFill>
-                <a:latin typeface="Abadi" panose="020B0604020104020204" pitchFamily="34" charset="0"/>
-              </a:rPr>
-              <a:t>iCLIP</a:t>
-            </a:r>
-            <a:r>
-              <a:rPr lang="en-GB" sz="1600" dirty="0">
-                <a:solidFill>
-                  <a:sysClr val="windowText" lastClr="000000"/>
-                </a:solidFill>
-                <a:latin typeface="Abadi" panose="020B0604020104020204" pitchFamily="34" charset="0"/>
-              </a:rPr>
-              <a:t> 152,983 Peaks </a:t>
-            </a:r>
-          </a:p>
-          <a:p>
-            <a:pPr algn="ctr"/>
-            <a:r>
-              <a:rPr lang="en-GB" sz="1600" dirty="0">
-                <a:solidFill>
-                  <a:sysClr val="windowText" lastClr="000000"/>
-                </a:solidFill>
-                <a:latin typeface="Abadi" panose="020B0604020104020204" pitchFamily="34" charset="0"/>
-              </a:rPr>
-              <a:t>SmB_clippy_n40_w0.5_rollmean40_minHeightAdjust8.0_minPromAdjust5.0_minGeneCount5_Peaks.bed</a:t>
+              <a:t>152,983 Peaks </a:t>
             </a:r>
           </a:p>
           <a:p>
@@ -7203,154 +7343,29 @@
           <a:p>
             <a:pPr algn="ctr"/>
             <a:r>
-              <a:rPr lang="en-GB" sz="1400" dirty="0">
+              <a:rPr lang="en-US" sz="1400" dirty="0">
                 <a:solidFill>
                   <a:sysClr val="windowText" lastClr="000000"/>
                 </a:solidFill>
-                <a:latin typeface="SimHei" panose="020B0503020204020204" pitchFamily="49" charset="-122"/>
-                <a:ea typeface="SimHei" panose="020B0503020204020204" pitchFamily="49" charset="-122"/>
-              </a:rPr>
-              <a:t>bedtools intersect \</a:t>
-            </a:r>
-          </a:p>
-          <a:p>
-            <a:pPr algn="ctr"/>
-            <a:r>
-              <a:rPr lang="en-GB" sz="1400" dirty="0">
+                <a:latin typeface="Abadi" panose="020B0604020104020204" pitchFamily="34" charset="0"/>
+              </a:rPr>
+              <a:t>Need to use Granges AGAIN, to remove exons from intronic regions in decoys/</a:t>
+            </a:r>
+            <a:r>
+              <a:rPr lang="en-US" sz="1400" dirty="0" err="1">
                 <a:solidFill>
                   <a:sysClr val="windowText" lastClr="000000"/>
                 </a:solidFill>
-                <a:latin typeface="SimHei" panose="020B0503020204020204" pitchFamily="49" charset="-122"/>
-                <a:ea typeface="SimHei" panose="020B0503020204020204" pitchFamily="49" charset="-122"/>
-              </a:rPr>
-              <a:t>-a \</a:t>
-            </a:r>
-          </a:p>
-          <a:p>
-            <a:pPr algn="ctr"/>
-            <a:r>
-              <a:rPr lang="en-GB" sz="1400" dirty="0">
-                <a:solidFill>
-                  <a:sysClr val="windowText" lastClr="000000"/>
-                </a:solidFill>
-                <a:latin typeface="SimHei" panose="020B0503020204020204" pitchFamily="49" charset="-122"/>
-                <a:ea typeface="SimHei" panose="020B0503020204020204" pitchFamily="49" charset="-122"/>
-              </a:rPr>
-              <a:t>-b \</a:t>
-            </a:r>
-            <a:br>
-              <a:rPr lang="en-GB" sz="1400" dirty="0">
-                <a:solidFill>
-                  <a:sysClr val="windowText" lastClr="000000"/>
-                </a:solidFill>
-                <a:latin typeface="SimHei" panose="020B0503020204020204" pitchFamily="49" charset="-122"/>
-                <a:ea typeface="SimHei" panose="020B0503020204020204" pitchFamily="49" charset="-122"/>
-              </a:rPr>
-            </a:br>
-            <a:r>
-              <a:rPr lang="en-GB" sz="1400" dirty="0">
-                <a:solidFill>
-                  <a:sysClr val="windowText" lastClr="000000"/>
-                </a:solidFill>
-                <a:latin typeface="SimHei" panose="020B0503020204020204" pitchFamily="49" charset="-122"/>
-                <a:ea typeface="SimHei" panose="020B0503020204020204" pitchFamily="49" charset="-122"/>
-              </a:rPr>
-              <a:t>-c \</a:t>
-            </a:r>
-          </a:p>
-          <a:p>
-            <a:pPr algn="ctr"/>
-            <a:r>
-              <a:rPr lang="en-GB" sz="1400" dirty="0">
-                <a:solidFill>
-                  <a:sysClr val="windowText" lastClr="000000"/>
-                </a:solidFill>
-                <a:latin typeface="SimHei" panose="020B0503020204020204" pitchFamily="49" charset="-122"/>
-                <a:ea typeface="SimHei" panose="020B0503020204020204" pitchFamily="49" charset="-122"/>
-              </a:rPr>
-              <a:t>-s \</a:t>
-            </a:r>
-          </a:p>
-          <a:p>
-            <a:pPr algn="ctr"/>
-            <a:r>
-              <a:rPr lang="en-GB" sz="1400" dirty="0">
-                <a:solidFill>
-                  <a:sysClr val="windowText" lastClr="000000"/>
-                </a:solidFill>
-                <a:latin typeface="SimHei" panose="020B0503020204020204" pitchFamily="49" charset="-122"/>
-                <a:ea typeface="SimHei" panose="020B0503020204020204" pitchFamily="49" charset="-122"/>
-              </a:rPr>
-              <a:t>| awk ‘$NF &gt; 0’ </a:t>
-            </a:r>
-            <a:r>
-              <a:rPr lang="en-GB" sz="1400" dirty="0" err="1">
-                <a:solidFill>
-                  <a:sysClr val="windowText" lastClr="000000"/>
-                </a:solidFill>
-                <a:latin typeface="SimHei" panose="020B0503020204020204" pitchFamily="49" charset="-122"/>
-                <a:ea typeface="SimHei" panose="020B0503020204020204" pitchFamily="49" charset="-122"/>
-              </a:rPr>
-              <a:t>SupportedSpliceSites.bed</a:t>
-            </a:r>
-            <a:endParaRPr lang="en-GB" sz="1600" dirty="0">
-              <a:solidFill>
-                <a:sysClr val="windowText" lastClr="000000"/>
-              </a:solidFill>
-              <a:latin typeface="SimHei" panose="020B0503020204020204" pitchFamily="49" charset="-122"/>
-              <a:ea typeface="SimHei" panose="020B0503020204020204" pitchFamily="49" charset="-122"/>
-            </a:endParaRPr>
-          </a:p>
-          <a:p>
-            <a:pPr algn="ctr"/>
-            <a:br>
-              <a:rPr lang="en-GB" sz="1600" dirty="0">
-                <a:solidFill>
-                  <a:sysClr val="windowText" lastClr="000000"/>
-                </a:solidFill>
-                <a:latin typeface="SimHei" panose="020B0503020204020204" pitchFamily="49" charset="-122"/>
-                <a:ea typeface="SimHei" panose="020B0503020204020204" pitchFamily="49" charset="-122"/>
-              </a:rPr>
-            </a:br>
-            <a:r>
-              <a:rPr lang="en-US" sz="1600" dirty="0">
-                <a:solidFill>
-                  <a:sysClr val="windowText" lastClr="000000"/>
-                </a:solidFill>
-                <a:latin typeface="Abadi" panose="020B0604020104020204" pitchFamily="34" charset="0"/>
-              </a:rPr>
-              <a:t>Repeat with –v to remove splice sites within 100 bp of canonical splice sites</a:t>
-            </a:r>
-          </a:p>
-          <a:p>
-            <a:pPr algn="ctr"/>
-            <a:r>
-              <a:rPr lang="en-US" sz="1600" dirty="0" err="1">
-                <a:solidFill>
-                  <a:sysClr val="windowText" lastClr="000000"/>
-                </a:solidFill>
-                <a:latin typeface="Abadi" panose="020B0604020104020204" pitchFamily="34" charset="0"/>
-              </a:rPr>
-              <a:t>Wide_canonical_splice_sites.bed</a:t>
-            </a:r>
-            <a:endParaRPr lang="en-US" sz="1600" dirty="0">
+                <a:latin typeface="Abadi" panose="020B0604020104020204" pitchFamily="34" charset="0"/>
+              </a:rPr>
+              <a:t>cryptics</a:t>
+            </a:r>
+            <a:endParaRPr lang="en-US" sz="1400" dirty="0">
               <a:solidFill>
                 <a:sysClr val="windowText" lastClr="000000"/>
               </a:solidFill>
               <a:latin typeface="Abadi" panose="020B0604020104020204" pitchFamily="34" charset="0"/>
             </a:endParaRPr>
-          </a:p>
-          <a:p>
-            <a:pPr algn="ctr"/>
-            <a:r>
-              <a:rPr lang="en-US" sz="1600" dirty="0">
-                <a:solidFill>
-                  <a:sysClr val="windowText" lastClr="000000"/>
-                </a:solidFill>
-                <a:latin typeface="Abadi" panose="020B0604020104020204" pitchFamily="34" charset="0"/>
-              </a:rPr>
-              <a:t>Total: 36,240 Predicted splice sites</a:t>
-            </a:r>
           </a:p>
         </p:txBody>
       </p:sp>
@@ -7427,7 +7442,7 @@
         </p:nvSpPr>
         <p:spPr>
           <a:xfrm>
-            <a:off x="2127250" y="2216150"/>
+            <a:off x="2127250" y="3946979"/>
             <a:ext cx="2603500" cy="393700"/>
           </a:xfrm>
           <a:prstGeom prst="rect">
@@ -7486,7 +7501,7 @@
         </p:nvSpPr>
         <p:spPr>
           <a:xfrm>
-            <a:off x="694592" y="8667998"/>
+            <a:off x="694592" y="2369514"/>
             <a:ext cx="5468816" cy="1280258"/>
           </a:xfrm>
           <a:prstGeom prst="rect">
@@ -7527,7 +7542,7 @@
                 </a:solidFill>
                 <a:latin typeface="Abadi" panose="020B0604020104020204" pitchFamily="34" charset="0"/>
               </a:rPr>
-              <a:t>Remove exon overlaps with Granges, keep only “</a:t>
+              <a:t>Using </a:t>
             </a:r>
             <a:r>
               <a:rPr lang="en-US" sz="1600" dirty="0" err="1">
@@ -7536,6 +7551,24 @@
                 </a:solidFill>
                 <a:latin typeface="Abadi" panose="020B0604020104020204" pitchFamily="34" charset="0"/>
               </a:rPr>
+              <a:t>GRanges</a:t>
+            </a:r>
+            <a:r>
+              <a:rPr lang="en-US" sz="1600" dirty="0">
+                <a:solidFill>
+                  <a:sysClr val="windowText" lastClr="000000"/>
+                </a:solidFill>
+                <a:latin typeface="Abadi" panose="020B0604020104020204" pitchFamily="34" charset="0"/>
+              </a:rPr>
+              <a:t>, keep only “</a:t>
+            </a:r>
+            <a:r>
+              <a:rPr lang="en-US" sz="1600" dirty="0" err="1">
+                <a:solidFill>
+                  <a:sysClr val="windowText" lastClr="000000"/>
+                </a:solidFill>
+                <a:latin typeface="Abadi" panose="020B0604020104020204" pitchFamily="34" charset="0"/>
+              </a:rPr>
               <a:t>protein_coding</a:t>
             </a:r>
             <a:r>
@@ -7545,7 +7578,7 @@
                 </a:solidFill>
                 <a:latin typeface="Abadi" panose="020B0604020104020204" pitchFamily="34" charset="0"/>
               </a:rPr>
-              <a:t>” introns in Gencode.v49.annotation.gtf</a:t>
+              <a:t>” regions in Gencode.v49.annotation.gtf</a:t>
             </a:r>
           </a:p>
           <a:p>
@@ -7557,7 +7590,7 @@
                 </a:solidFill>
                 <a:latin typeface="Abadi" panose="020B0604020104020204" pitchFamily="34" charset="0"/>
               </a:rPr>
-              <a:t>19,945 Predicted splice sites</a:t>
+              <a:t>* Predicted splice sites</a:t>
             </a:r>
           </a:p>
         </p:txBody>
@@ -7617,17 +7650,20 @@
                 </a:solidFill>
                 <a:latin typeface="Abadi" panose="020B0604020104020204" pitchFamily="34" charset="0"/>
               </a:rPr>
-              <a:t>Pull FASTA using BED coordinates using SpliceAI_Inference.py to re-score inferences over a ±24nt window surrounding the loci</a:t>
+              <a:t>Pull FASTA using BED coordinates with SpliceAI_Inference.py to re-score inferences over a ±24nt window surrounding the loci, filter to &gt; 0.1 Donor Score</a:t>
             </a:r>
           </a:p>
           <a:p>
             <a:pPr algn="ctr"/>
-            <a:endParaRPr lang="en-US" sz="1600" dirty="0">
-              <a:solidFill>
-                <a:sysClr val="windowText" lastClr="000000"/>
-              </a:solidFill>
-              <a:latin typeface="Abadi" panose="020B0604020104020204" pitchFamily="34" charset="0"/>
-            </a:endParaRPr>
+            <a:r>
+              <a:rPr lang="en-US" sz="1600" dirty="0">
+                <a:solidFill>
+                  <a:sysClr val="windowText" lastClr="000000"/>
+                </a:solidFill>
+                <a:latin typeface="Abadi" panose="020B0604020104020204" pitchFamily="34" charset="0"/>
+              </a:rPr>
+              <a:t>7022 Predicted Splice Sites</a:t>
+            </a:r>
           </a:p>
         </p:txBody>
       </p:sp>
@@ -7645,7 +7681,7 @@
         </p:nvSpPr>
         <p:spPr>
           <a:xfrm>
-            <a:off x="2127250" y="8471148"/>
+            <a:off x="2127250" y="2172664"/>
             <a:ext cx="2603500" cy="393700"/>
           </a:xfrm>
           <a:prstGeom prst="rect">
@@ -7704,7 +7740,7 @@
         </p:nvSpPr>
         <p:spPr>
           <a:xfrm>
-            <a:off x="5945663" y="2573839"/>
+            <a:off x="5945663" y="4304668"/>
             <a:ext cx="300349" cy="3014187"/>
           </a:xfrm>
           <a:prstGeom prst="rightBrace">
@@ -7807,7 +7843,7 @@
         </p:nvSpPr>
         <p:spPr>
           <a:xfrm>
-            <a:off x="6030438" y="3833283"/>
+            <a:off x="6030438" y="5564112"/>
             <a:ext cx="508000" cy="495300"/>
           </a:xfrm>
           <a:prstGeom prst="ellipse">
@@ -7841,10 +7877,4040 @@
           </a:p>
         </p:txBody>
       </p:sp>
+      <p:pic>
+        <p:nvPicPr>
+          <p:cNvPr id="6" name="Picture 5">
+            <a:extLst>
+              <a:ext uri="{FF2B5EF4-FFF2-40B4-BE49-F238E27FC236}">
+                <a16:creationId xmlns:a16="http://schemas.microsoft.com/office/drawing/2014/main" id="{9FB30D7F-2777-4174-C8AB-D0DE9459BC7E}"/>
+              </a:ext>
+            </a:extLst>
+          </p:cNvPr>
+          <p:cNvPicPr>
+            <a:picLocks noChangeAspect="1"/>
+          </p:cNvPicPr>
+          <p:nvPr/>
+        </p:nvPicPr>
+        <p:blipFill>
+          <a:blip r:embed="rId2"/>
+          <a:srcRect t="24837" r="20597"/>
+          <a:stretch>
+            <a:fillRect/>
+          </a:stretch>
+        </p:blipFill>
+        <p:spPr>
+          <a:xfrm>
+            <a:off x="402166" y="5403328"/>
+            <a:ext cx="5708780" cy="2855747"/>
+          </a:xfrm>
+          <a:prstGeom prst="rect">
+            <a:avLst/>
+          </a:prstGeom>
+          <a:ln w="19050">
+            <a:solidFill>
+              <a:schemeClr val="tx1"/>
+            </a:solidFill>
+          </a:ln>
+        </p:spPr>
+      </p:pic>
+      <p:cxnSp>
+        <p:nvCxnSpPr>
+          <p:cNvPr id="11" name="Straight Arrow Connector 10">
+            <a:extLst>
+              <a:ext uri="{FF2B5EF4-FFF2-40B4-BE49-F238E27FC236}">
+                <a16:creationId xmlns:a16="http://schemas.microsoft.com/office/drawing/2014/main" id="{5E99D58F-D8A1-36D1-08B2-D4B2D1CF4EA6}"/>
+              </a:ext>
+            </a:extLst>
+          </p:cNvPr>
+          <p:cNvCxnSpPr>
+            <a:cxnSpLocks/>
+          </p:cNvCxnSpPr>
+          <p:nvPr/>
+        </p:nvCxnSpPr>
+        <p:spPr>
+          <a:xfrm>
+            <a:off x="3971925" y="5403328"/>
+            <a:ext cx="457200" cy="892697"/>
+          </a:xfrm>
+          <a:prstGeom prst="straightConnector1">
+            <a:avLst/>
+          </a:prstGeom>
+          <a:ln>
+            <a:tailEnd type="triangle"/>
+          </a:ln>
+        </p:spPr>
+        <p:style>
+          <a:lnRef idx="3">
+            <a:schemeClr val="accent1"/>
+          </a:lnRef>
+          <a:fillRef idx="0">
+            <a:schemeClr val="accent1"/>
+          </a:fillRef>
+          <a:effectRef idx="2">
+            <a:schemeClr val="accent1"/>
+          </a:effectRef>
+          <a:fontRef idx="minor">
+            <a:schemeClr val="tx1"/>
+          </a:fontRef>
+        </p:style>
+      </p:cxnSp>
+      <p:cxnSp>
+        <p:nvCxnSpPr>
+          <p:cNvPr id="14" name="Straight Arrow Connector 13">
+            <a:extLst>
+              <a:ext uri="{FF2B5EF4-FFF2-40B4-BE49-F238E27FC236}">
+                <a16:creationId xmlns:a16="http://schemas.microsoft.com/office/drawing/2014/main" id="{9159153F-C10D-2CF6-4421-32D3C2D17193}"/>
+              </a:ext>
+            </a:extLst>
+          </p:cNvPr>
+          <p:cNvCxnSpPr>
+            <a:cxnSpLocks/>
+          </p:cNvCxnSpPr>
+          <p:nvPr/>
+        </p:nvCxnSpPr>
+        <p:spPr>
+          <a:xfrm>
+            <a:off x="4452938" y="6767513"/>
+            <a:ext cx="0" cy="1382185"/>
+          </a:xfrm>
+          <a:prstGeom prst="straightConnector1">
+            <a:avLst/>
+          </a:prstGeom>
+          <a:ln>
+            <a:tailEnd type="triangle"/>
+          </a:ln>
+        </p:spPr>
+        <p:style>
+          <a:lnRef idx="3">
+            <a:schemeClr val="accent1"/>
+          </a:lnRef>
+          <a:fillRef idx="0">
+            <a:schemeClr val="accent1"/>
+          </a:fillRef>
+          <a:effectRef idx="2">
+            <a:schemeClr val="accent1"/>
+          </a:effectRef>
+          <a:fontRef idx="minor">
+            <a:schemeClr val="tx1"/>
+          </a:fontRef>
+        </p:style>
+      </p:cxnSp>
+      <p:sp>
+        <p:nvSpPr>
+          <p:cNvPr id="3" name="TextBox 2">
+            <a:extLst>
+              <a:ext uri="{FF2B5EF4-FFF2-40B4-BE49-F238E27FC236}">
+                <a16:creationId xmlns:a16="http://schemas.microsoft.com/office/drawing/2014/main" id="{23254414-C9FD-7817-C8C3-17BE8AC59B65}"/>
+              </a:ext>
+            </a:extLst>
+          </p:cNvPr>
+          <p:cNvSpPr txBox="1"/>
+          <p:nvPr/>
+        </p:nvSpPr>
+        <p:spPr>
+          <a:xfrm>
+            <a:off x="0" y="0"/>
+            <a:ext cx="2127250" cy="523220"/>
+          </a:xfrm>
+          <a:prstGeom prst="rect">
+            <a:avLst/>
+          </a:prstGeom>
+          <a:noFill/>
+        </p:spPr>
+        <p:txBody>
+          <a:bodyPr wrap="square" rtlCol="0">
+            <a:spAutoFit/>
+          </a:bodyPr>
+          <a:lstStyle/>
+          <a:p>
+            <a:r>
+              <a:rPr lang="en-US" sz="2800" dirty="0"/>
+              <a:t>CURRENT</a:t>
+            </a:r>
+            <a:endParaRPr lang="en-GB" sz="2800" dirty="0"/>
+          </a:p>
+        </p:txBody>
+      </p:sp>
     </p:spTree>
     <p:extLst>
       <p:ext uri="{BB962C8B-B14F-4D97-AF65-F5344CB8AC3E}">
         <p14:creationId xmlns:p14="http://schemas.microsoft.com/office/powerpoint/2010/main" val="72113033"/>
+      </p:ext>
+    </p:extLst>
+  </p:cSld>
+  <p:clrMapOvr>
+    <a:masterClrMapping/>
+  </p:clrMapOvr>
+</p:sld>
+</file>
+
+<file path=ppt/slides/slide2.xml><?xml version="1.0" encoding="utf-8"?>
+<p:sld xmlns:a="http://schemas.openxmlformats.org/drawingml/2006/main" xmlns:r="http://schemas.openxmlformats.org/officeDocument/2006/relationships" xmlns:p="http://schemas.openxmlformats.org/presentationml/2006/main">
+  <p:cSld>
+    <p:spTree>
+      <p:nvGrpSpPr>
+        <p:cNvPr id="1" name="">
+          <a:extLst>
+            <a:ext uri="{FF2B5EF4-FFF2-40B4-BE49-F238E27FC236}">
+              <a16:creationId xmlns:a16="http://schemas.microsoft.com/office/drawing/2014/main" id="{7E346146-B82F-C9BA-9347-5B1D9E5F6438}"/>
+            </a:ext>
+          </a:extLst>
+        </p:cNvPr>
+        <p:cNvGrpSpPr/>
+        <p:nvPr/>
+      </p:nvGrpSpPr>
+      <p:grpSpPr>
+        <a:xfrm>
+          <a:off x="0" y="0"/>
+          <a:ext cx="0" cy="0"/>
+          <a:chOff x="0" y="0"/>
+          <a:chExt cx="0" cy="0"/>
+        </a:xfrm>
+      </p:grpSpPr>
+      <p:cxnSp>
+        <p:nvCxnSpPr>
+          <p:cNvPr id="50" name="Straight Arrow Connector 49">
+            <a:extLst>
+              <a:ext uri="{FF2B5EF4-FFF2-40B4-BE49-F238E27FC236}">
+                <a16:creationId xmlns:a16="http://schemas.microsoft.com/office/drawing/2014/main" id="{81F23D2E-2079-4704-8564-AA968031C0D2}"/>
+              </a:ext>
+            </a:extLst>
+          </p:cNvPr>
+          <p:cNvCxnSpPr>
+            <a:cxnSpLocks/>
+          </p:cNvCxnSpPr>
+          <p:nvPr/>
+        </p:nvCxnSpPr>
+        <p:spPr>
+          <a:xfrm>
+            <a:off x="1133475" y="9953343"/>
+            <a:ext cx="3193248" cy="1351291"/>
+          </a:xfrm>
+          <a:prstGeom prst="straightConnector1">
+            <a:avLst/>
+          </a:prstGeom>
+          <a:ln>
+            <a:tailEnd type="triangle"/>
+          </a:ln>
+        </p:spPr>
+        <p:style>
+          <a:lnRef idx="3">
+            <a:schemeClr val="accent1"/>
+          </a:lnRef>
+          <a:fillRef idx="0">
+            <a:schemeClr val="accent1"/>
+          </a:fillRef>
+          <a:effectRef idx="2">
+            <a:schemeClr val="accent1"/>
+          </a:effectRef>
+          <a:fontRef idx="minor">
+            <a:schemeClr val="tx1"/>
+          </a:fontRef>
+        </p:style>
+      </p:cxnSp>
+      <p:sp>
+        <p:nvSpPr>
+          <p:cNvPr id="4" name="Rectangle 3">
+            <a:extLst>
+              <a:ext uri="{FF2B5EF4-FFF2-40B4-BE49-F238E27FC236}">
+                <a16:creationId xmlns:a16="http://schemas.microsoft.com/office/drawing/2014/main" id="{F36FDDD2-8D43-A135-5329-ED20464B5E0F}"/>
+              </a:ext>
+            </a:extLst>
+          </p:cNvPr>
+          <p:cNvSpPr/>
+          <p:nvPr/>
+        </p:nvSpPr>
+        <p:spPr>
+          <a:xfrm>
+            <a:off x="694592" y="618391"/>
+            <a:ext cx="5468816" cy="1014525"/>
+          </a:xfrm>
+          <a:prstGeom prst="rect">
+            <a:avLst/>
+          </a:prstGeom>
+          <a:solidFill>
+            <a:schemeClr val="accent1">
+              <a:lumMod val="40000"/>
+              <a:lumOff val="60000"/>
+            </a:schemeClr>
+          </a:solidFill>
+        </p:spPr>
+        <p:style>
+          <a:lnRef idx="2">
+            <a:schemeClr val="accent1">
+              <a:shade val="15000"/>
+            </a:schemeClr>
+          </a:lnRef>
+          <a:fillRef idx="1">
+            <a:schemeClr val="accent1"/>
+          </a:fillRef>
+          <a:effectRef idx="0">
+            <a:schemeClr val="accent1"/>
+          </a:effectRef>
+          <a:fontRef idx="minor">
+            <a:schemeClr val="lt1"/>
+          </a:fontRef>
+        </p:style>
+        <p:txBody>
+          <a:bodyPr rtlCol="0" anchor="ctr"/>
+          <a:lstStyle/>
+          <a:p>
+            <a:pPr algn="ctr"/>
+            <a:r>
+              <a:rPr lang="en-US" sz="1400" dirty="0" err="1">
+                <a:solidFill>
+                  <a:sysClr val="windowText" lastClr="000000"/>
+                </a:solidFill>
+                <a:latin typeface="Abadi" panose="020B0604020104020204" pitchFamily="34" charset="0"/>
+              </a:rPr>
+              <a:t>SpliceAI</a:t>
+            </a:r>
+            <a:r>
+              <a:rPr lang="en-US" sz="1400" dirty="0">
+                <a:solidFill>
+                  <a:sysClr val="windowText" lastClr="000000"/>
+                </a:solidFill>
+                <a:latin typeface="Abadi" panose="020B0604020104020204" pitchFamily="34" charset="0"/>
+              </a:rPr>
+              <a:t> inferences generated across whole introns and filtered to remove signal below 0.05</a:t>
+            </a:r>
+          </a:p>
+          <a:p>
+            <a:pPr algn="ctr"/>
+            <a:r>
+              <a:rPr lang="en-US" sz="1400" dirty="0">
+                <a:solidFill>
+                  <a:sysClr val="windowText" lastClr="000000"/>
+                </a:solidFill>
+                <a:latin typeface="Abadi" panose="020B0604020104020204" pitchFamily="34" charset="0"/>
+              </a:rPr>
+              <a:t>794,192 splice site inferences</a:t>
+            </a:r>
+            <a:endParaRPr lang="en-GB" sz="1400" dirty="0">
+              <a:solidFill>
+                <a:sysClr val="windowText" lastClr="000000"/>
+              </a:solidFill>
+              <a:latin typeface="Abadi" panose="020B0604020104020204" pitchFamily="34" charset="0"/>
+            </a:endParaRPr>
+          </a:p>
+        </p:txBody>
+      </p:sp>
+      <p:sp>
+        <p:nvSpPr>
+          <p:cNvPr id="7" name="Rectangle 6">
+            <a:extLst>
+              <a:ext uri="{FF2B5EF4-FFF2-40B4-BE49-F238E27FC236}">
+                <a16:creationId xmlns:a16="http://schemas.microsoft.com/office/drawing/2014/main" id="{01EF1563-0C33-BE4B-F0E6-CE5448F4BE4F}"/>
+              </a:ext>
+            </a:extLst>
+          </p:cNvPr>
+          <p:cNvSpPr/>
+          <p:nvPr/>
+        </p:nvSpPr>
+        <p:spPr>
+          <a:xfrm>
+            <a:off x="694592" y="3464631"/>
+            <a:ext cx="5468816" cy="1015181"/>
+          </a:xfrm>
+          <a:prstGeom prst="rect">
+            <a:avLst/>
+          </a:prstGeom>
+          <a:solidFill>
+            <a:schemeClr val="accent1">
+              <a:lumMod val="40000"/>
+              <a:lumOff val="60000"/>
+            </a:schemeClr>
+          </a:solidFill>
+        </p:spPr>
+        <p:style>
+          <a:lnRef idx="2">
+            <a:schemeClr val="accent1">
+              <a:shade val="15000"/>
+            </a:schemeClr>
+          </a:lnRef>
+          <a:fillRef idx="1">
+            <a:schemeClr val="accent1"/>
+          </a:fillRef>
+          <a:effectRef idx="0">
+            <a:schemeClr val="accent1"/>
+          </a:effectRef>
+          <a:fontRef idx="minor">
+            <a:schemeClr val="lt1"/>
+          </a:fontRef>
+        </p:style>
+        <p:txBody>
+          <a:bodyPr rtlCol="0" anchor="ctr"/>
+          <a:lstStyle/>
+          <a:p>
+            <a:pPr algn="ctr"/>
+            <a:r>
+              <a:rPr lang="en-US" sz="1400" dirty="0">
+                <a:solidFill>
+                  <a:sysClr val="windowText" lastClr="000000"/>
+                </a:solidFill>
+                <a:latin typeface="Abadi" panose="020B0604020104020204" pitchFamily="34" charset="0"/>
+              </a:rPr>
+              <a:t>Create a new exonic bed to filter splice sites within 100 bp of exon boundaries</a:t>
+            </a:r>
+          </a:p>
+          <a:p>
+            <a:pPr algn="ctr"/>
+            <a:r>
+              <a:rPr lang="en-US" sz="1400" dirty="0">
+                <a:solidFill>
+                  <a:schemeClr val="accent1"/>
+                </a:solidFill>
+                <a:latin typeface="Abadi" panose="020B0604020104020204" pitchFamily="34" charset="0"/>
+              </a:rPr>
+              <a:t>50nt_exonic_loci.bed</a:t>
+            </a:r>
+          </a:p>
+        </p:txBody>
+      </p:sp>
+      <p:sp>
+        <p:nvSpPr>
+          <p:cNvPr id="8" name="Rectangle 7">
+            <a:extLst>
+              <a:ext uri="{FF2B5EF4-FFF2-40B4-BE49-F238E27FC236}">
+                <a16:creationId xmlns:a16="http://schemas.microsoft.com/office/drawing/2014/main" id="{855B8832-A681-E024-AF34-09BED346DF87}"/>
+              </a:ext>
+            </a:extLst>
+          </p:cNvPr>
+          <p:cNvSpPr/>
+          <p:nvPr/>
+        </p:nvSpPr>
+        <p:spPr>
+          <a:xfrm>
+            <a:off x="2127250" y="421541"/>
+            <a:ext cx="2603500" cy="393700"/>
+          </a:xfrm>
+          <a:prstGeom prst="rect">
+            <a:avLst/>
+          </a:prstGeom>
+          <a:ln w="19050">
+            <a:solidFill>
+              <a:schemeClr val="tx1"/>
+            </a:solidFill>
+          </a:ln>
+        </p:spPr>
+        <p:style>
+          <a:lnRef idx="2">
+            <a:schemeClr val="accent1"/>
+          </a:lnRef>
+          <a:fillRef idx="1">
+            <a:schemeClr val="lt1"/>
+          </a:fillRef>
+          <a:effectRef idx="0">
+            <a:schemeClr val="accent1"/>
+          </a:effectRef>
+          <a:fontRef idx="minor">
+            <a:schemeClr val="dk1"/>
+          </a:fontRef>
+        </p:style>
+        <p:txBody>
+          <a:bodyPr rtlCol="0" anchor="ctr"/>
+          <a:lstStyle/>
+          <a:p>
+            <a:pPr algn="ctr"/>
+            <a:r>
+              <a:rPr lang="en-US" b="1" dirty="0" err="1">
+                <a:latin typeface="Raleway" pitchFamily="2" charset="0"/>
+                <a:cs typeface="Posterama" panose="020B0504020200020000" pitchFamily="34" charset="0"/>
+              </a:rPr>
+              <a:t>SpliceAI</a:t>
+            </a:r>
+            <a:endParaRPr lang="en-GB" b="1" dirty="0">
+              <a:latin typeface="Raleway" pitchFamily="2" charset="0"/>
+              <a:cs typeface="Posterama" panose="020B0504020200020000" pitchFamily="34" charset="0"/>
+            </a:endParaRPr>
+          </a:p>
+        </p:txBody>
+      </p:sp>
+      <p:sp>
+        <p:nvSpPr>
+          <p:cNvPr id="20" name="Rectangle 19">
+            <a:extLst>
+              <a:ext uri="{FF2B5EF4-FFF2-40B4-BE49-F238E27FC236}">
+                <a16:creationId xmlns:a16="http://schemas.microsoft.com/office/drawing/2014/main" id="{827BB162-2D86-44A6-4FAC-AF1178C52E17}"/>
+              </a:ext>
+            </a:extLst>
+          </p:cNvPr>
+          <p:cNvSpPr/>
+          <p:nvPr/>
+        </p:nvSpPr>
+        <p:spPr>
+          <a:xfrm>
+            <a:off x="694592" y="1975814"/>
+            <a:ext cx="5468816" cy="1130298"/>
+          </a:xfrm>
+          <a:prstGeom prst="rect">
+            <a:avLst/>
+          </a:prstGeom>
+          <a:solidFill>
+            <a:schemeClr val="accent1">
+              <a:lumMod val="40000"/>
+              <a:lumOff val="60000"/>
+            </a:schemeClr>
+          </a:solidFill>
+        </p:spPr>
+        <p:style>
+          <a:lnRef idx="2">
+            <a:schemeClr val="accent1">
+              <a:shade val="15000"/>
+            </a:schemeClr>
+          </a:lnRef>
+          <a:fillRef idx="1">
+            <a:schemeClr val="accent1"/>
+          </a:fillRef>
+          <a:effectRef idx="0">
+            <a:schemeClr val="accent1"/>
+          </a:effectRef>
+          <a:fontRef idx="minor">
+            <a:schemeClr val="lt1"/>
+          </a:fontRef>
+        </p:style>
+        <p:txBody>
+          <a:bodyPr rtlCol="0" anchor="ctr"/>
+          <a:lstStyle/>
+          <a:p>
+            <a:pPr algn="ctr"/>
+            <a:r>
+              <a:rPr lang="en-US" sz="1400" dirty="0">
+                <a:solidFill>
+                  <a:sysClr val="windowText" lastClr="000000"/>
+                </a:solidFill>
+                <a:latin typeface="Abadi" panose="020B0604020104020204" pitchFamily="34" charset="0"/>
+              </a:rPr>
+              <a:t>Using </a:t>
+            </a:r>
+            <a:r>
+              <a:rPr lang="en-US" sz="1400" dirty="0" err="1">
+                <a:solidFill>
+                  <a:sysClr val="windowText" lastClr="000000"/>
+                </a:solidFill>
+                <a:latin typeface="Abadi" panose="020B0604020104020204" pitchFamily="34" charset="0"/>
+              </a:rPr>
+              <a:t>GRanges</a:t>
+            </a:r>
+            <a:r>
+              <a:rPr lang="en-US" sz="1400" dirty="0">
+                <a:solidFill>
+                  <a:sysClr val="windowText" lastClr="000000"/>
+                </a:solidFill>
+                <a:latin typeface="Abadi" panose="020B0604020104020204" pitchFamily="34" charset="0"/>
+              </a:rPr>
+              <a:t>, keep only “</a:t>
+            </a:r>
+            <a:r>
+              <a:rPr lang="en-US" sz="1400" dirty="0" err="1">
+                <a:solidFill>
+                  <a:sysClr val="windowText" lastClr="000000"/>
+                </a:solidFill>
+                <a:latin typeface="Abadi" panose="020B0604020104020204" pitchFamily="34" charset="0"/>
+              </a:rPr>
+              <a:t>protein_coding</a:t>
+            </a:r>
+            <a:r>
+              <a:rPr lang="en-US" sz="1400" dirty="0">
+                <a:solidFill>
+                  <a:sysClr val="windowText" lastClr="000000"/>
+                </a:solidFill>
+                <a:latin typeface="Abadi" panose="020B0604020104020204" pitchFamily="34" charset="0"/>
+              </a:rPr>
+              <a:t>” regions in Gencode.v49.annotation.gtf</a:t>
+            </a:r>
+          </a:p>
+          <a:p>
+            <a:pPr algn="ctr"/>
+            <a:r>
+              <a:rPr lang="en-US" sz="1400" dirty="0" err="1">
+                <a:solidFill>
+                  <a:schemeClr val="accent1"/>
+                </a:solidFill>
+                <a:latin typeface="Abadi" panose="020B0604020104020204" pitchFamily="34" charset="0"/>
+              </a:rPr>
+              <a:t>Protein_coding_sites.bed</a:t>
+            </a:r>
+            <a:endParaRPr lang="en-US" sz="1400" dirty="0">
+              <a:solidFill>
+                <a:schemeClr val="accent1"/>
+              </a:solidFill>
+              <a:latin typeface="Abadi" panose="020B0604020104020204" pitchFamily="34" charset="0"/>
+            </a:endParaRPr>
+          </a:p>
+        </p:txBody>
+      </p:sp>
+      <p:sp>
+        <p:nvSpPr>
+          <p:cNvPr id="24" name="Rectangle 23">
+            <a:extLst>
+              <a:ext uri="{FF2B5EF4-FFF2-40B4-BE49-F238E27FC236}">
+                <a16:creationId xmlns:a16="http://schemas.microsoft.com/office/drawing/2014/main" id="{B4CD350F-DE7C-600B-2C59-379360BFA161}"/>
+              </a:ext>
+            </a:extLst>
+          </p:cNvPr>
+          <p:cNvSpPr/>
+          <p:nvPr/>
+        </p:nvSpPr>
+        <p:spPr>
+          <a:xfrm>
+            <a:off x="2127250" y="1778964"/>
+            <a:ext cx="2603500" cy="393700"/>
+          </a:xfrm>
+          <a:prstGeom prst="rect">
+            <a:avLst/>
+          </a:prstGeom>
+          <a:ln w="19050">
+            <a:solidFill>
+              <a:schemeClr val="tx1"/>
+            </a:solidFill>
+          </a:ln>
+        </p:spPr>
+        <p:style>
+          <a:lnRef idx="2">
+            <a:schemeClr val="accent1"/>
+          </a:lnRef>
+          <a:fillRef idx="1">
+            <a:schemeClr val="lt1"/>
+          </a:fillRef>
+          <a:effectRef idx="0">
+            <a:schemeClr val="accent1"/>
+          </a:effectRef>
+          <a:fontRef idx="minor">
+            <a:schemeClr val="dk1"/>
+          </a:fontRef>
+        </p:style>
+        <p:txBody>
+          <a:bodyPr rtlCol="0" anchor="ctr"/>
+          <a:lstStyle/>
+          <a:p>
+            <a:pPr algn="ctr"/>
+            <a:r>
+              <a:rPr lang="en-US" b="1" dirty="0">
+                <a:latin typeface="Raleway" pitchFamily="2" charset="0"/>
+                <a:cs typeface="Posterama" panose="020B0504020200020000" pitchFamily="34" charset="0"/>
+              </a:rPr>
+              <a:t>Genomic Ranges</a:t>
+            </a:r>
+            <a:endParaRPr lang="en-GB" b="1" dirty="0">
+              <a:latin typeface="Raleway" pitchFamily="2" charset="0"/>
+              <a:cs typeface="Posterama" panose="020B0504020200020000" pitchFamily="34" charset="0"/>
+            </a:endParaRPr>
+          </a:p>
+        </p:txBody>
+      </p:sp>
+      <p:pic>
+        <p:nvPicPr>
+          <p:cNvPr id="6" name="Picture 5">
+            <a:extLst>
+              <a:ext uri="{FF2B5EF4-FFF2-40B4-BE49-F238E27FC236}">
+                <a16:creationId xmlns:a16="http://schemas.microsoft.com/office/drawing/2014/main" id="{3F9560D4-C02F-4894-8EAD-C2116003F603}"/>
+              </a:ext>
+            </a:extLst>
+          </p:cNvPr>
+          <p:cNvPicPr>
+            <a:picLocks noChangeAspect="1"/>
+          </p:cNvPicPr>
+          <p:nvPr/>
+        </p:nvPicPr>
+        <p:blipFill>
+          <a:blip r:embed="rId2"/>
+          <a:srcRect t="39377" r="20597"/>
+          <a:stretch>
+            <a:fillRect/>
+          </a:stretch>
+        </p:blipFill>
+        <p:spPr>
+          <a:xfrm>
+            <a:off x="574610" y="4838331"/>
+            <a:ext cx="5708780" cy="2303297"/>
+          </a:xfrm>
+          <a:prstGeom prst="rect">
+            <a:avLst/>
+          </a:prstGeom>
+          <a:ln w="19050">
+            <a:solidFill>
+              <a:schemeClr val="tx1"/>
+            </a:solidFill>
+          </a:ln>
+        </p:spPr>
+      </p:pic>
+      <p:cxnSp>
+        <p:nvCxnSpPr>
+          <p:cNvPr id="11" name="Straight Arrow Connector 10">
+            <a:extLst>
+              <a:ext uri="{FF2B5EF4-FFF2-40B4-BE49-F238E27FC236}">
+                <a16:creationId xmlns:a16="http://schemas.microsoft.com/office/drawing/2014/main" id="{88C74F9B-5EE0-B602-61CE-8304D5B4E442}"/>
+              </a:ext>
+            </a:extLst>
+          </p:cNvPr>
+          <p:cNvCxnSpPr>
+            <a:cxnSpLocks/>
+          </p:cNvCxnSpPr>
+          <p:nvPr/>
+        </p:nvCxnSpPr>
+        <p:spPr>
+          <a:xfrm>
+            <a:off x="4326723" y="4301330"/>
+            <a:ext cx="525671" cy="895520"/>
+          </a:xfrm>
+          <a:prstGeom prst="straightConnector1">
+            <a:avLst/>
+          </a:prstGeom>
+          <a:ln>
+            <a:tailEnd type="triangle"/>
+          </a:ln>
+        </p:spPr>
+        <p:style>
+          <a:lnRef idx="3">
+            <a:schemeClr val="accent1"/>
+          </a:lnRef>
+          <a:fillRef idx="0">
+            <a:schemeClr val="accent1"/>
+          </a:fillRef>
+          <a:effectRef idx="2">
+            <a:schemeClr val="accent1"/>
+          </a:effectRef>
+          <a:fontRef idx="minor">
+            <a:schemeClr val="tx1"/>
+          </a:fontRef>
+        </p:style>
+      </p:cxnSp>
+      <p:cxnSp>
+        <p:nvCxnSpPr>
+          <p:cNvPr id="14" name="Straight Arrow Connector 13">
+            <a:extLst>
+              <a:ext uri="{FF2B5EF4-FFF2-40B4-BE49-F238E27FC236}">
+                <a16:creationId xmlns:a16="http://schemas.microsoft.com/office/drawing/2014/main" id="{B939BD0A-E98E-7F5F-546D-DD10B661AE50}"/>
+              </a:ext>
+            </a:extLst>
+          </p:cNvPr>
+          <p:cNvCxnSpPr>
+            <a:cxnSpLocks/>
+          </p:cNvCxnSpPr>
+          <p:nvPr/>
+        </p:nvCxnSpPr>
+        <p:spPr>
+          <a:xfrm>
+            <a:off x="4625382" y="5650066"/>
+            <a:ext cx="0" cy="1382185"/>
+          </a:xfrm>
+          <a:prstGeom prst="straightConnector1">
+            <a:avLst/>
+          </a:prstGeom>
+          <a:ln>
+            <a:tailEnd type="triangle"/>
+          </a:ln>
+        </p:spPr>
+        <p:style>
+          <a:lnRef idx="3">
+            <a:schemeClr val="accent1"/>
+          </a:lnRef>
+          <a:fillRef idx="0">
+            <a:schemeClr val="accent1"/>
+          </a:fillRef>
+          <a:effectRef idx="2">
+            <a:schemeClr val="accent1"/>
+          </a:effectRef>
+          <a:fontRef idx="minor">
+            <a:schemeClr val="tx1"/>
+          </a:fontRef>
+        </p:style>
+      </p:cxnSp>
+      <p:sp>
+        <p:nvSpPr>
+          <p:cNvPr id="3" name="Rectangle 2">
+            <a:extLst>
+              <a:ext uri="{FF2B5EF4-FFF2-40B4-BE49-F238E27FC236}">
+                <a16:creationId xmlns:a16="http://schemas.microsoft.com/office/drawing/2014/main" id="{50C5DF0C-5B73-6093-285E-5B4DE3EA7FBF}"/>
+              </a:ext>
+            </a:extLst>
+          </p:cNvPr>
+          <p:cNvSpPr/>
+          <p:nvPr/>
+        </p:nvSpPr>
+        <p:spPr>
+          <a:xfrm>
+            <a:off x="4852394" y="5296053"/>
+            <a:ext cx="525671" cy="110969"/>
+          </a:xfrm>
+          <a:prstGeom prst="rect">
+            <a:avLst/>
+          </a:prstGeom>
+        </p:spPr>
+        <p:style>
+          <a:lnRef idx="2">
+            <a:schemeClr val="accent1">
+              <a:shade val="15000"/>
+            </a:schemeClr>
+          </a:lnRef>
+          <a:fillRef idx="1">
+            <a:schemeClr val="accent1"/>
+          </a:fillRef>
+          <a:effectRef idx="0">
+            <a:schemeClr val="accent1"/>
+          </a:effectRef>
+          <a:fontRef idx="minor">
+            <a:schemeClr val="lt1"/>
+          </a:fontRef>
+        </p:style>
+        <p:txBody>
+          <a:bodyPr rtlCol="0" anchor="ctr"/>
+          <a:lstStyle/>
+          <a:p>
+            <a:pPr algn="ctr"/>
+            <a:endParaRPr lang="en-GB"/>
+          </a:p>
+        </p:txBody>
+      </p:sp>
+      <p:cxnSp>
+        <p:nvCxnSpPr>
+          <p:cNvPr id="9" name="Straight Arrow Connector 8">
+            <a:extLst>
+              <a:ext uri="{FF2B5EF4-FFF2-40B4-BE49-F238E27FC236}">
+                <a16:creationId xmlns:a16="http://schemas.microsoft.com/office/drawing/2014/main" id="{AD512864-D50D-2AD6-7FBE-43E8FD8FE5D0}"/>
+              </a:ext>
+            </a:extLst>
+          </p:cNvPr>
+          <p:cNvCxnSpPr>
+            <a:cxnSpLocks/>
+          </p:cNvCxnSpPr>
+          <p:nvPr/>
+        </p:nvCxnSpPr>
+        <p:spPr>
+          <a:xfrm>
+            <a:off x="5234982" y="5650066"/>
+            <a:ext cx="0" cy="1382185"/>
+          </a:xfrm>
+          <a:prstGeom prst="straightConnector1">
+            <a:avLst/>
+          </a:prstGeom>
+          <a:ln>
+            <a:tailEnd type="triangle"/>
+          </a:ln>
+        </p:spPr>
+        <p:style>
+          <a:lnRef idx="3">
+            <a:schemeClr val="accent1"/>
+          </a:lnRef>
+          <a:fillRef idx="0">
+            <a:schemeClr val="accent1"/>
+          </a:fillRef>
+          <a:effectRef idx="2">
+            <a:schemeClr val="accent1"/>
+          </a:effectRef>
+          <a:fontRef idx="minor">
+            <a:schemeClr val="tx1"/>
+          </a:fontRef>
+        </p:style>
+      </p:cxnSp>
+      <p:sp>
+        <p:nvSpPr>
+          <p:cNvPr id="16" name="Rectangle 15">
+            <a:extLst>
+              <a:ext uri="{FF2B5EF4-FFF2-40B4-BE49-F238E27FC236}">
+                <a16:creationId xmlns:a16="http://schemas.microsoft.com/office/drawing/2014/main" id="{1A203446-C53A-CA4E-ED61-017C4703609F}"/>
+              </a:ext>
+            </a:extLst>
+          </p:cNvPr>
+          <p:cNvSpPr/>
+          <p:nvPr/>
+        </p:nvSpPr>
+        <p:spPr>
+          <a:xfrm>
+            <a:off x="114297" y="7537530"/>
+            <a:ext cx="6619875" cy="909119"/>
+          </a:xfrm>
+          <a:prstGeom prst="rect">
+            <a:avLst/>
+          </a:prstGeom>
+          <a:solidFill>
+            <a:schemeClr val="accent1">
+              <a:lumMod val="40000"/>
+              <a:lumOff val="60000"/>
+            </a:schemeClr>
+          </a:solidFill>
+        </p:spPr>
+        <p:style>
+          <a:lnRef idx="2">
+            <a:schemeClr val="accent1">
+              <a:shade val="15000"/>
+            </a:schemeClr>
+          </a:lnRef>
+          <a:fillRef idx="1">
+            <a:schemeClr val="accent1"/>
+          </a:fillRef>
+          <a:effectRef idx="0">
+            <a:schemeClr val="accent1"/>
+          </a:effectRef>
+          <a:fontRef idx="minor">
+            <a:schemeClr val="lt1"/>
+          </a:fontRef>
+        </p:style>
+        <p:txBody>
+          <a:bodyPr numCol="2" rtlCol="0" anchor="ctr"/>
+          <a:lstStyle/>
+          <a:p>
+            <a:pPr algn="ctr"/>
+            <a:endParaRPr lang="en-GB" sz="1400" dirty="0">
+              <a:solidFill>
+                <a:sysClr val="windowText" lastClr="000000"/>
+              </a:solidFill>
+              <a:latin typeface="SimHei" panose="020B0503020204020204" pitchFamily="49" charset="-122"/>
+              <a:ea typeface="SimHei" panose="020B0503020204020204" pitchFamily="49" charset="-122"/>
+            </a:endParaRPr>
+          </a:p>
+          <a:p>
+            <a:pPr algn="ctr"/>
+            <a:r>
+              <a:rPr lang="en-GB" sz="1400" dirty="0">
+                <a:solidFill>
+                  <a:sysClr val="windowText" lastClr="000000"/>
+                </a:solidFill>
+                <a:latin typeface="SimHei" panose="020B0503020204020204" pitchFamily="49" charset="-122"/>
+                <a:ea typeface="SimHei" panose="020B0503020204020204" pitchFamily="49" charset="-122"/>
+              </a:rPr>
+              <a:t>bedtools intersect -v (does not overlap) 50nt_exonic_loci.bed</a:t>
+            </a:r>
+            <a:br>
+              <a:rPr lang="en-GB" sz="1400" dirty="0">
+                <a:solidFill>
+                  <a:sysClr val="windowText" lastClr="000000"/>
+                </a:solidFill>
+                <a:latin typeface="SimHei" panose="020B0503020204020204" pitchFamily="49" charset="-122"/>
+                <a:ea typeface="SimHei" panose="020B0503020204020204" pitchFamily="49" charset="-122"/>
+              </a:rPr>
+            </a:br>
+            <a:r>
+              <a:rPr lang="en-GB" sz="1400" dirty="0">
+                <a:solidFill>
+                  <a:sysClr val="windowText" lastClr="000000"/>
+                </a:solidFill>
+                <a:latin typeface="SimHei" panose="020B0503020204020204" pitchFamily="49" charset="-122"/>
+                <a:ea typeface="SimHei" panose="020B0503020204020204" pitchFamily="49" charset="-122"/>
+              </a:rPr>
+              <a:t>== </a:t>
+            </a:r>
+            <a:r>
+              <a:rPr lang="en-GB" sz="1400" dirty="0" err="1">
+                <a:solidFill>
+                  <a:schemeClr val="accent1"/>
+                </a:solidFill>
+                <a:latin typeface="SimHei" panose="020B0503020204020204" pitchFamily="49" charset="-122"/>
+                <a:ea typeface="SimHei" panose="020B0503020204020204" pitchFamily="49" charset="-122"/>
+              </a:rPr>
+              <a:t>deep_intronic_sites.bed</a:t>
+            </a:r>
+            <a:endParaRPr lang="en-GB" sz="1400" dirty="0">
+              <a:solidFill>
+                <a:schemeClr val="accent1"/>
+              </a:solidFill>
+              <a:latin typeface="SimHei" panose="020B0503020204020204" pitchFamily="49" charset="-122"/>
+              <a:ea typeface="SimHei" panose="020B0503020204020204" pitchFamily="49" charset="-122"/>
+            </a:endParaRPr>
+          </a:p>
+          <a:p>
+            <a:pPr algn="ctr"/>
+            <a:endParaRPr lang="en-GB" sz="1400" dirty="0">
+              <a:solidFill>
+                <a:sysClr val="windowText" lastClr="000000"/>
+              </a:solidFill>
+              <a:latin typeface="SimHei" panose="020B0503020204020204" pitchFamily="49" charset="-122"/>
+              <a:ea typeface="SimHei" panose="020B0503020204020204" pitchFamily="49" charset="-122"/>
+            </a:endParaRPr>
+          </a:p>
+          <a:p>
+            <a:pPr algn="ctr"/>
+            <a:endParaRPr lang="en-GB" sz="1400" dirty="0">
+              <a:solidFill>
+                <a:sysClr val="windowText" lastClr="000000"/>
+              </a:solidFill>
+              <a:latin typeface="SimHei" panose="020B0503020204020204" pitchFamily="49" charset="-122"/>
+              <a:ea typeface="SimHei" panose="020B0503020204020204" pitchFamily="49" charset="-122"/>
+            </a:endParaRPr>
+          </a:p>
+          <a:p>
+            <a:pPr algn="ctr"/>
+            <a:endParaRPr lang="en-GB" sz="1400" dirty="0">
+              <a:solidFill>
+                <a:sysClr val="windowText" lastClr="000000"/>
+              </a:solidFill>
+              <a:latin typeface="SimHei" panose="020B0503020204020204" pitchFamily="49" charset="-122"/>
+              <a:ea typeface="SimHei" panose="020B0503020204020204" pitchFamily="49" charset="-122"/>
+            </a:endParaRPr>
+          </a:p>
+          <a:p>
+            <a:pPr algn="ctr"/>
+            <a:r>
+              <a:rPr lang="en-GB" sz="1400" dirty="0">
+                <a:solidFill>
+                  <a:sysClr val="windowText" lastClr="000000"/>
+                </a:solidFill>
+                <a:latin typeface="SimHei" panose="020B0503020204020204" pitchFamily="49" charset="-122"/>
+                <a:ea typeface="SimHei" panose="020B0503020204020204" pitchFamily="49" charset="-122"/>
+              </a:rPr>
+              <a:t>bedtools intersect -c (does overlap) 50nt_exonic_loci.bed</a:t>
+            </a:r>
+            <a:br>
+              <a:rPr lang="en-GB" sz="1400" dirty="0">
+                <a:solidFill>
+                  <a:sysClr val="windowText" lastClr="000000"/>
+                </a:solidFill>
+                <a:latin typeface="SimHei" panose="020B0503020204020204" pitchFamily="49" charset="-122"/>
+                <a:ea typeface="SimHei" panose="020B0503020204020204" pitchFamily="49" charset="-122"/>
+              </a:rPr>
+            </a:br>
+            <a:r>
+              <a:rPr lang="en-GB" sz="1400" dirty="0">
+                <a:solidFill>
+                  <a:sysClr val="windowText" lastClr="000000"/>
+                </a:solidFill>
+                <a:latin typeface="SimHei" panose="020B0503020204020204" pitchFamily="49" charset="-122"/>
+                <a:ea typeface="SimHei" panose="020B0503020204020204" pitchFamily="49" charset="-122"/>
+              </a:rPr>
+              <a:t>== </a:t>
+            </a:r>
+            <a:r>
+              <a:rPr lang="en-GB" sz="1400" dirty="0" err="1">
+                <a:solidFill>
+                  <a:schemeClr val="accent1"/>
+                </a:solidFill>
+                <a:latin typeface="SimHei" panose="020B0503020204020204" pitchFamily="49" charset="-122"/>
+                <a:ea typeface="SimHei" panose="020B0503020204020204" pitchFamily="49" charset="-122"/>
+              </a:rPr>
+              <a:t>exonic.bed</a:t>
+            </a:r>
+            <a:endParaRPr lang="en-US" sz="1400" dirty="0">
+              <a:solidFill>
+                <a:schemeClr val="accent1"/>
+              </a:solidFill>
+              <a:latin typeface="Abadi" panose="020B0604020104020204" pitchFamily="34" charset="0"/>
+            </a:endParaRPr>
+          </a:p>
+          <a:p>
+            <a:pPr algn="ctr"/>
+            <a:endParaRPr lang="en-US" dirty="0">
+              <a:solidFill>
+                <a:sysClr val="windowText" lastClr="000000"/>
+              </a:solidFill>
+              <a:latin typeface="Abadi" panose="020B0604020104020204" pitchFamily="34" charset="0"/>
+            </a:endParaRPr>
+          </a:p>
+        </p:txBody>
+      </p:sp>
+      <p:sp>
+        <p:nvSpPr>
+          <p:cNvPr id="10" name="Rectangle 9">
+            <a:extLst>
+              <a:ext uri="{FF2B5EF4-FFF2-40B4-BE49-F238E27FC236}">
+                <a16:creationId xmlns:a16="http://schemas.microsoft.com/office/drawing/2014/main" id="{7986058C-5F08-E956-A26E-19F8D99BD785}"/>
+              </a:ext>
+            </a:extLst>
+          </p:cNvPr>
+          <p:cNvSpPr/>
+          <p:nvPr/>
+        </p:nvSpPr>
+        <p:spPr>
+          <a:xfrm>
+            <a:off x="2127250" y="7221972"/>
+            <a:ext cx="2603500" cy="393700"/>
+          </a:xfrm>
+          <a:prstGeom prst="rect">
+            <a:avLst/>
+          </a:prstGeom>
+          <a:ln w="19050">
+            <a:solidFill>
+              <a:schemeClr val="tx1"/>
+            </a:solidFill>
+          </a:ln>
+        </p:spPr>
+        <p:style>
+          <a:lnRef idx="2">
+            <a:schemeClr val="accent1"/>
+          </a:lnRef>
+          <a:fillRef idx="1">
+            <a:schemeClr val="lt1"/>
+          </a:fillRef>
+          <a:effectRef idx="0">
+            <a:schemeClr val="accent1"/>
+          </a:effectRef>
+          <a:fontRef idx="minor">
+            <a:schemeClr val="dk1"/>
+          </a:fontRef>
+        </p:style>
+        <p:txBody>
+          <a:bodyPr rtlCol="0" anchor="ctr"/>
+          <a:lstStyle/>
+          <a:p>
+            <a:pPr algn="ctr"/>
+            <a:r>
+              <a:rPr lang="en-US" b="1" dirty="0">
+                <a:latin typeface="Raleway" pitchFamily="2" charset="0"/>
+                <a:cs typeface="Posterama" panose="020B0504020200020000" pitchFamily="34" charset="0"/>
+              </a:rPr>
+              <a:t>Bedtools intersect</a:t>
+            </a:r>
+            <a:endParaRPr lang="en-GB" b="1" dirty="0">
+              <a:latin typeface="Raleway" pitchFamily="2" charset="0"/>
+              <a:cs typeface="Posterama" panose="020B0504020200020000" pitchFamily="34" charset="0"/>
+            </a:endParaRPr>
+          </a:p>
+        </p:txBody>
+      </p:sp>
+      <p:sp>
+        <p:nvSpPr>
+          <p:cNvPr id="21" name="Rectangle 20">
+            <a:extLst>
+              <a:ext uri="{FF2B5EF4-FFF2-40B4-BE49-F238E27FC236}">
+                <a16:creationId xmlns:a16="http://schemas.microsoft.com/office/drawing/2014/main" id="{A78BE0AB-C7A5-4A64-AB8A-3FDFA8307852}"/>
+              </a:ext>
+            </a:extLst>
+          </p:cNvPr>
+          <p:cNvSpPr/>
+          <p:nvPr/>
+        </p:nvSpPr>
+        <p:spPr>
+          <a:xfrm>
+            <a:off x="1847054" y="3227259"/>
+            <a:ext cx="3154360" cy="393700"/>
+          </a:xfrm>
+          <a:prstGeom prst="rect">
+            <a:avLst/>
+          </a:prstGeom>
+          <a:ln w="19050">
+            <a:solidFill>
+              <a:schemeClr val="tx1"/>
+            </a:solidFill>
+          </a:ln>
+        </p:spPr>
+        <p:style>
+          <a:lnRef idx="2">
+            <a:schemeClr val="accent1"/>
+          </a:lnRef>
+          <a:fillRef idx="1">
+            <a:schemeClr val="lt1"/>
+          </a:fillRef>
+          <a:effectRef idx="0">
+            <a:schemeClr val="accent1"/>
+          </a:effectRef>
+          <a:fontRef idx="minor">
+            <a:schemeClr val="dk1"/>
+          </a:fontRef>
+        </p:style>
+        <p:txBody>
+          <a:bodyPr rtlCol="0" anchor="ctr"/>
+          <a:lstStyle/>
+          <a:p>
+            <a:pPr algn="ctr"/>
+            <a:r>
+              <a:rPr lang="en-US" b="1" dirty="0">
+                <a:latin typeface="Raleway" pitchFamily="2" charset="0"/>
+                <a:cs typeface="Posterama" panose="020B0504020200020000" pitchFamily="34" charset="0"/>
+              </a:rPr>
+              <a:t>VAST-DB MAIN-PSI-TABLE</a:t>
+            </a:r>
+            <a:endParaRPr lang="en-GB" b="1" dirty="0">
+              <a:latin typeface="Raleway" pitchFamily="2" charset="0"/>
+              <a:cs typeface="Posterama" panose="020B0504020200020000" pitchFamily="34" charset="0"/>
+            </a:endParaRPr>
+          </a:p>
+        </p:txBody>
+      </p:sp>
+      <p:sp>
+        <p:nvSpPr>
+          <p:cNvPr id="25" name="Rectangle 24">
+            <a:extLst>
+              <a:ext uri="{FF2B5EF4-FFF2-40B4-BE49-F238E27FC236}">
+                <a16:creationId xmlns:a16="http://schemas.microsoft.com/office/drawing/2014/main" id="{0639E164-C200-CA46-95AD-8E6D551016C1}"/>
+              </a:ext>
+            </a:extLst>
+          </p:cNvPr>
+          <p:cNvSpPr/>
+          <p:nvPr/>
+        </p:nvSpPr>
+        <p:spPr>
+          <a:xfrm>
+            <a:off x="114298" y="8522406"/>
+            <a:ext cx="3314702" cy="1488369"/>
+          </a:xfrm>
+          <a:prstGeom prst="rect">
+            <a:avLst/>
+          </a:prstGeom>
+          <a:solidFill>
+            <a:schemeClr val="accent1">
+              <a:lumMod val="40000"/>
+              <a:lumOff val="60000"/>
+            </a:schemeClr>
+          </a:solidFill>
+        </p:spPr>
+        <p:style>
+          <a:lnRef idx="2">
+            <a:schemeClr val="accent1">
+              <a:shade val="15000"/>
+            </a:schemeClr>
+          </a:lnRef>
+          <a:fillRef idx="1">
+            <a:schemeClr val="accent1"/>
+          </a:fillRef>
+          <a:effectRef idx="0">
+            <a:schemeClr val="accent1"/>
+          </a:effectRef>
+          <a:fontRef idx="minor">
+            <a:schemeClr val="lt1"/>
+          </a:fontRef>
+        </p:style>
+        <p:txBody>
+          <a:bodyPr numCol="2" rtlCol="0" anchor="ctr"/>
+          <a:lstStyle/>
+          <a:p>
+            <a:pPr algn="ctr"/>
+            <a:r>
+              <a:rPr lang="en-US" sz="1200" dirty="0">
+                <a:solidFill>
+                  <a:schemeClr val="tx1"/>
+                </a:solidFill>
+                <a:latin typeface="Abadi" panose="020B0604020104020204" pitchFamily="34" charset="0"/>
+              </a:rPr>
+              <a:t>Intersect </a:t>
+            </a:r>
+            <a:r>
+              <a:rPr lang="en-US" sz="1200" dirty="0" err="1">
+                <a:solidFill>
+                  <a:schemeClr val="tx1"/>
+                </a:solidFill>
+                <a:latin typeface="Abadi" panose="020B0604020104020204" pitchFamily="34" charset="0"/>
+              </a:rPr>
+              <a:t>deep_intronic_sites.bed</a:t>
+            </a:r>
+            <a:r>
+              <a:rPr lang="en-US" sz="1200" dirty="0">
+                <a:solidFill>
+                  <a:schemeClr val="tx1"/>
+                </a:solidFill>
+                <a:latin typeface="Abadi" panose="020B0604020104020204" pitchFamily="34" charset="0"/>
+              </a:rPr>
+              <a:t> </a:t>
+            </a:r>
+            <a:br>
+              <a:rPr lang="en-US" sz="1200" dirty="0">
+                <a:solidFill>
+                  <a:schemeClr val="accent1"/>
+                </a:solidFill>
+                <a:latin typeface="Abadi" panose="020B0604020104020204" pitchFamily="34" charset="0"/>
+              </a:rPr>
+            </a:br>
+            <a:r>
+              <a:rPr lang="en-US" sz="1200" dirty="0" err="1">
+                <a:solidFill>
+                  <a:schemeClr val="accent1"/>
+                </a:solidFill>
+                <a:latin typeface="Abadi" panose="020B0604020104020204" pitchFamily="34" charset="0"/>
+              </a:rPr>
+              <a:t>RBPnet</a:t>
+            </a:r>
+            <a:r>
+              <a:rPr lang="en-US" sz="1200" dirty="0">
+                <a:solidFill>
+                  <a:schemeClr val="accent1"/>
+                </a:solidFill>
+                <a:latin typeface="Abadi" panose="020B0604020104020204" pitchFamily="34" charset="0"/>
+              </a:rPr>
+              <a:t> PRPF8 predictions </a:t>
+            </a:r>
+          </a:p>
+          <a:p>
+            <a:pPr algn="ctr"/>
+            <a:r>
+              <a:rPr lang="en-US" sz="1200" dirty="0">
+                <a:solidFill>
+                  <a:schemeClr val="tx1"/>
+                </a:solidFill>
+                <a:latin typeface="Abadi" panose="020B0604020104020204" pitchFamily="34" charset="0"/>
+              </a:rPr>
+              <a:t>and/or </a:t>
+            </a:r>
+            <a:r>
+              <a:rPr lang="en-US" sz="1200" dirty="0">
+                <a:solidFill>
+                  <a:schemeClr val="accent1"/>
+                </a:solidFill>
+                <a:latin typeface="Abadi" panose="020B0604020104020204" pitchFamily="34" charset="0"/>
+              </a:rPr>
+              <a:t>PRPF8 Peaks </a:t>
+            </a:r>
+          </a:p>
+          <a:p>
+            <a:pPr algn="ctr"/>
+            <a:r>
+              <a:rPr lang="en-US" sz="1200" dirty="0">
+                <a:solidFill>
+                  <a:schemeClr val="tx1"/>
+                </a:solidFill>
+                <a:latin typeface="Abadi" panose="020B0604020104020204" pitchFamily="34" charset="0"/>
+              </a:rPr>
+              <a:t>and/or </a:t>
+            </a:r>
+            <a:r>
+              <a:rPr lang="en-US" sz="1200" dirty="0" err="1">
+                <a:solidFill>
+                  <a:schemeClr val="accent1"/>
+                </a:solidFill>
+                <a:latin typeface="Abadi" panose="020B0604020104020204" pitchFamily="34" charset="0"/>
+              </a:rPr>
+              <a:t>SmB</a:t>
+            </a:r>
+            <a:r>
+              <a:rPr lang="en-US" sz="1200" dirty="0">
+                <a:solidFill>
+                  <a:schemeClr val="accent1"/>
+                </a:solidFill>
+                <a:latin typeface="Abadi" panose="020B0604020104020204" pitchFamily="34" charset="0"/>
+              </a:rPr>
+              <a:t> Peaks</a:t>
+            </a:r>
+          </a:p>
+          <a:p>
+            <a:pPr algn="ctr"/>
+            <a:r>
+              <a:rPr lang="en-US" sz="1200" dirty="0">
+                <a:solidFill>
+                  <a:schemeClr val="tx1"/>
+                </a:solidFill>
+                <a:latin typeface="Abadi" panose="020B0604020104020204" pitchFamily="34" charset="0"/>
+              </a:rPr>
+              <a:t>== </a:t>
+            </a:r>
+            <a:r>
+              <a:rPr lang="en-US" sz="1200" dirty="0" err="1">
+                <a:solidFill>
+                  <a:schemeClr val="tx1"/>
+                </a:solidFill>
+                <a:latin typeface="Abadi" panose="020B0604020104020204" pitchFamily="34" charset="0"/>
+              </a:rPr>
+              <a:t>decoys.bed</a:t>
+            </a:r>
+            <a:br>
+              <a:rPr lang="en-US" sz="1200" dirty="0">
+                <a:solidFill>
+                  <a:schemeClr val="tx1"/>
+                </a:solidFill>
+                <a:latin typeface="Abadi" panose="020B0604020104020204" pitchFamily="34" charset="0"/>
+              </a:rPr>
+            </a:br>
+            <a:r>
+              <a:rPr lang="en-US" sz="1200" dirty="0">
+                <a:solidFill>
+                  <a:schemeClr val="tx1"/>
+                </a:solidFill>
+                <a:latin typeface="Abadi" panose="020B0604020104020204" pitchFamily="34" charset="0"/>
+              </a:rPr>
+              <a:t>Intersect </a:t>
+            </a:r>
+            <a:r>
+              <a:rPr lang="en-US" sz="1200" dirty="0" err="1">
+                <a:solidFill>
+                  <a:schemeClr val="tx1"/>
+                </a:solidFill>
+                <a:latin typeface="Abadi" panose="020B0604020104020204" pitchFamily="34" charset="0"/>
+              </a:rPr>
+              <a:t>deep_intronic_sites.bed</a:t>
+            </a:r>
+            <a:br>
+              <a:rPr lang="en-US" sz="1200" dirty="0">
+                <a:solidFill>
+                  <a:schemeClr val="tx1"/>
+                </a:solidFill>
+                <a:latin typeface="Abadi" panose="020B0604020104020204" pitchFamily="34" charset="0"/>
+              </a:rPr>
+            </a:br>
+            <a:r>
+              <a:rPr lang="en-US" sz="1200" dirty="0">
+                <a:solidFill>
+                  <a:schemeClr val="tx1"/>
+                </a:solidFill>
+                <a:latin typeface="Abadi" panose="020B0604020104020204" pitchFamily="34" charset="0"/>
+              </a:rPr>
+              <a:t>None of </a:t>
+            </a:r>
+            <a:r>
+              <a:rPr lang="en-US" sz="1200" dirty="0" err="1">
+                <a:solidFill>
+                  <a:schemeClr val="accent1"/>
+                </a:solidFill>
+                <a:latin typeface="Abadi" panose="020B0604020104020204" pitchFamily="34" charset="0"/>
+              </a:rPr>
+              <a:t>RBPnet</a:t>
+            </a:r>
+            <a:r>
+              <a:rPr lang="en-US" sz="1200" dirty="0">
+                <a:solidFill>
+                  <a:schemeClr val="accent1"/>
+                </a:solidFill>
+                <a:latin typeface="Abadi" panose="020B0604020104020204" pitchFamily="34" charset="0"/>
+              </a:rPr>
+              <a:t> PRPF8 predictions </a:t>
+            </a:r>
+          </a:p>
+          <a:p>
+            <a:pPr algn="ctr"/>
+            <a:r>
+              <a:rPr lang="en-US" sz="1200" dirty="0">
+                <a:solidFill>
+                  <a:schemeClr val="tx1"/>
+                </a:solidFill>
+                <a:latin typeface="Abadi" panose="020B0604020104020204" pitchFamily="34" charset="0"/>
+              </a:rPr>
+              <a:t>or </a:t>
+            </a:r>
+            <a:r>
+              <a:rPr lang="en-US" sz="1200" dirty="0">
+                <a:solidFill>
+                  <a:schemeClr val="accent1"/>
+                </a:solidFill>
+                <a:latin typeface="Abadi" panose="020B0604020104020204" pitchFamily="34" charset="0"/>
+              </a:rPr>
+              <a:t>PRPF8 Peaks </a:t>
+            </a:r>
+          </a:p>
+          <a:p>
+            <a:pPr algn="ctr"/>
+            <a:r>
+              <a:rPr lang="en-US" sz="1200" dirty="0">
+                <a:solidFill>
+                  <a:schemeClr val="tx1"/>
+                </a:solidFill>
+                <a:latin typeface="Abadi" panose="020B0604020104020204" pitchFamily="34" charset="0"/>
+              </a:rPr>
+              <a:t>or </a:t>
+            </a:r>
+            <a:r>
+              <a:rPr lang="en-US" sz="1200" dirty="0" err="1">
+                <a:solidFill>
+                  <a:schemeClr val="accent1"/>
+                </a:solidFill>
+                <a:latin typeface="Abadi" panose="020B0604020104020204" pitchFamily="34" charset="0"/>
+              </a:rPr>
+              <a:t>SmB</a:t>
+            </a:r>
+            <a:r>
+              <a:rPr lang="en-US" sz="1200" dirty="0">
+                <a:solidFill>
+                  <a:schemeClr val="accent1"/>
+                </a:solidFill>
+                <a:latin typeface="Abadi" panose="020B0604020104020204" pitchFamily="34" charset="0"/>
+              </a:rPr>
+              <a:t> Peaks</a:t>
+            </a:r>
+          </a:p>
+          <a:p>
+            <a:pPr algn="ctr"/>
+            <a:r>
+              <a:rPr lang="en-US" sz="1200" dirty="0">
+                <a:solidFill>
+                  <a:schemeClr val="tx1"/>
+                </a:solidFill>
+                <a:latin typeface="Abadi" panose="020B0604020104020204" pitchFamily="34" charset="0"/>
+              </a:rPr>
+              <a:t>== </a:t>
+            </a:r>
+            <a:r>
+              <a:rPr lang="en-US" sz="1200" dirty="0" err="1">
+                <a:solidFill>
+                  <a:schemeClr val="tx1"/>
+                </a:solidFill>
+                <a:latin typeface="Abadi" panose="020B0604020104020204" pitchFamily="34" charset="0"/>
+              </a:rPr>
+              <a:t>cryptic_sites.bed</a:t>
+            </a:r>
+            <a:endParaRPr lang="en-US" sz="1200" dirty="0">
+              <a:solidFill>
+                <a:schemeClr val="tx1"/>
+              </a:solidFill>
+              <a:latin typeface="Abadi" panose="020B0604020104020204" pitchFamily="34" charset="0"/>
+            </a:endParaRPr>
+          </a:p>
+        </p:txBody>
+      </p:sp>
+      <p:sp>
+        <p:nvSpPr>
+          <p:cNvPr id="28" name="Rectangle 27">
+            <a:extLst>
+              <a:ext uri="{FF2B5EF4-FFF2-40B4-BE49-F238E27FC236}">
+                <a16:creationId xmlns:a16="http://schemas.microsoft.com/office/drawing/2014/main" id="{8E9C454C-497A-EEF9-9806-1AD272B5DBF2}"/>
+              </a:ext>
+            </a:extLst>
+          </p:cNvPr>
+          <p:cNvSpPr/>
+          <p:nvPr/>
+        </p:nvSpPr>
+        <p:spPr>
+          <a:xfrm>
+            <a:off x="4051997" y="8656821"/>
+            <a:ext cx="2346918" cy="909119"/>
+          </a:xfrm>
+          <a:prstGeom prst="rect">
+            <a:avLst/>
+          </a:prstGeom>
+          <a:solidFill>
+            <a:schemeClr val="accent1">
+              <a:lumMod val="40000"/>
+              <a:lumOff val="60000"/>
+            </a:schemeClr>
+          </a:solidFill>
+        </p:spPr>
+        <p:style>
+          <a:lnRef idx="2">
+            <a:schemeClr val="accent1">
+              <a:shade val="15000"/>
+            </a:schemeClr>
+          </a:lnRef>
+          <a:fillRef idx="1">
+            <a:schemeClr val="accent1"/>
+          </a:fillRef>
+          <a:effectRef idx="0">
+            <a:schemeClr val="accent1"/>
+          </a:effectRef>
+          <a:fontRef idx="minor">
+            <a:schemeClr val="lt1"/>
+          </a:fontRef>
+        </p:style>
+        <p:txBody>
+          <a:bodyPr numCol="1" rtlCol="0" anchor="ctr"/>
+          <a:lstStyle/>
+          <a:p>
+            <a:pPr algn="ctr"/>
+            <a:r>
+              <a:rPr lang="en-US" sz="1200" dirty="0">
+                <a:solidFill>
+                  <a:schemeClr val="tx1"/>
+                </a:solidFill>
+                <a:latin typeface="Abadi" panose="020B0604020104020204" pitchFamily="34" charset="0"/>
+              </a:rPr>
+              <a:t>Intersect </a:t>
+            </a:r>
+            <a:r>
+              <a:rPr lang="en-US" sz="1200" dirty="0" err="1">
+                <a:solidFill>
+                  <a:schemeClr val="tx1"/>
+                </a:solidFill>
+                <a:latin typeface="Abadi" panose="020B0604020104020204" pitchFamily="34" charset="0"/>
+              </a:rPr>
+              <a:t>exonic.bed</a:t>
+            </a:r>
+            <a:r>
+              <a:rPr lang="en-US" sz="1200" dirty="0">
+                <a:solidFill>
+                  <a:schemeClr val="tx1"/>
+                </a:solidFill>
+                <a:latin typeface="Abadi" panose="020B0604020104020204" pitchFamily="34" charset="0"/>
+              </a:rPr>
+              <a:t> -v</a:t>
+            </a:r>
+            <a:br>
+              <a:rPr lang="en-US" sz="1200" dirty="0">
+                <a:solidFill>
+                  <a:schemeClr val="accent1"/>
+                </a:solidFill>
+                <a:latin typeface="Abadi" panose="020B0604020104020204" pitchFamily="34" charset="0"/>
+              </a:rPr>
+            </a:br>
+            <a:r>
+              <a:rPr lang="en-US" sz="1200" dirty="0" err="1">
+                <a:solidFill>
+                  <a:schemeClr val="accent1"/>
+                </a:solidFill>
+                <a:latin typeface="Abadi" panose="020B0604020104020204" pitchFamily="34" charset="0"/>
+              </a:rPr>
+              <a:t>canonical_splice_sites.bed</a:t>
+            </a:r>
+            <a:endParaRPr lang="en-US" sz="1200" dirty="0">
+              <a:solidFill>
+                <a:schemeClr val="accent1"/>
+              </a:solidFill>
+              <a:latin typeface="Abadi" panose="020B0604020104020204" pitchFamily="34" charset="0"/>
+            </a:endParaRPr>
+          </a:p>
+          <a:p>
+            <a:pPr algn="ctr"/>
+            <a:r>
+              <a:rPr lang="en-US" sz="1200" dirty="0">
+                <a:solidFill>
+                  <a:schemeClr val="tx1"/>
+                </a:solidFill>
+                <a:latin typeface="Abadi" panose="020B0604020104020204" pitchFamily="34" charset="0"/>
+              </a:rPr>
+              <a:t>== alt5_splice_sites.bed</a:t>
+            </a:r>
+          </a:p>
+        </p:txBody>
+      </p:sp>
+      <p:sp>
+        <p:nvSpPr>
+          <p:cNvPr id="30" name="Rectangle 29">
+            <a:extLst>
+              <a:ext uri="{FF2B5EF4-FFF2-40B4-BE49-F238E27FC236}">
+                <a16:creationId xmlns:a16="http://schemas.microsoft.com/office/drawing/2014/main" id="{BBCDD2FF-01BE-CB9E-D112-F3133CBDA1A6}"/>
+              </a:ext>
+            </a:extLst>
+          </p:cNvPr>
+          <p:cNvSpPr/>
+          <p:nvPr/>
+        </p:nvSpPr>
+        <p:spPr>
+          <a:xfrm>
+            <a:off x="114297" y="10167597"/>
+            <a:ext cx="3879434" cy="1778964"/>
+          </a:xfrm>
+          <a:prstGeom prst="rect">
+            <a:avLst/>
+          </a:prstGeom>
+          <a:solidFill>
+            <a:schemeClr val="accent1">
+              <a:lumMod val="40000"/>
+              <a:lumOff val="60000"/>
+            </a:schemeClr>
+          </a:solidFill>
+        </p:spPr>
+        <p:style>
+          <a:lnRef idx="2">
+            <a:schemeClr val="accent1">
+              <a:shade val="15000"/>
+            </a:schemeClr>
+          </a:lnRef>
+          <a:fillRef idx="1">
+            <a:schemeClr val="accent1"/>
+          </a:fillRef>
+          <a:effectRef idx="0">
+            <a:schemeClr val="accent1"/>
+          </a:effectRef>
+          <a:fontRef idx="minor">
+            <a:schemeClr val="lt1"/>
+          </a:fontRef>
+        </p:style>
+        <p:txBody>
+          <a:bodyPr numCol="1" rtlCol="0" anchor="ctr"/>
+          <a:lstStyle/>
+          <a:p>
+            <a:pPr algn="ctr"/>
+            <a:r>
+              <a:rPr lang="en-US" sz="1200" dirty="0">
+                <a:solidFill>
+                  <a:schemeClr val="tx1"/>
+                </a:solidFill>
+                <a:latin typeface="Abadi" panose="020B0604020104020204" pitchFamily="34" charset="0"/>
+              </a:rPr>
+              <a:t>Create new dataset, intersect </a:t>
+            </a:r>
+            <a:r>
+              <a:rPr lang="en-US" sz="1200" dirty="0" err="1">
+                <a:solidFill>
+                  <a:schemeClr val="tx1"/>
+                </a:solidFill>
+                <a:latin typeface="Abadi" panose="020B0604020104020204" pitchFamily="34" charset="0"/>
+              </a:rPr>
+              <a:t>Canonical_splice_sites.bed</a:t>
+            </a:r>
+            <a:endParaRPr lang="en-US" sz="1200" dirty="0">
+              <a:solidFill>
+                <a:schemeClr val="tx1"/>
+              </a:solidFill>
+              <a:latin typeface="Abadi" panose="020B0604020104020204" pitchFamily="34" charset="0"/>
+            </a:endParaRPr>
+          </a:p>
+          <a:p>
+            <a:pPr algn="ctr"/>
+            <a:r>
+              <a:rPr lang="en-US" sz="1200" dirty="0" err="1">
+                <a:solidFill>
+                  <a:schemeClr val="accent1"/>
+                </a:solidFill>
+                <a:latin typeface="Abadi" panose="020B0604020104020204" pitchFamily="34" charset="0"/>
+              </a:rPr>
+              <a:t>RBPnet</a:t>
+            </a:r>
+            <a:r>
+              <a:rPr lang="en-US" sz="1200" dirty="0">
+                <a:solidFill>
+                  <a:schemeClr val="accent1"/>
+                </a:solidFill>
+                <a:latin typeface="Abadi" panose="020B0604020104020204" pitchFamily="34" charset="0"/>
+              </a:rPr>
+              <a:t> PRPF8 predictions </a:t>
+            </a:r>
+          </a:p>
+          <a:p>
+            <a:pPr algn="ctr"/>
+            <a:r>
+              <a:rPr lang="en-US" sz="1200" dirty="0">
+                <a:solidFill>
+                  <a:schemeClr val="tx1"/>
+                </a:solidFill>
+                <a:latin typeface="Abadi" panose="020B0604020104020204" pitchFamily="34" charset="0"/>
+              </a:rPr>
+              <a:t>and/or </a:t>
+            </a:r>
+            <a:r>
+              <a:rPr lang="en-US" sz="1200" dirty="0">
+                <a:solidFill>
+                  <a:schemeClr val="accent1"/>
+                </a:solidFill>
+                <a:latin typeface="Abadi" panose="020B0604020104020204" pitchFamily="34" charset="0"/>
+              </a:rPr>
+              <a:t>PRPF8 Peaks </a:t>
+            </a:r>
+          </a:p>
+          <a:p>
+            <a:pPr algn="ctr"/>
+            <a:r>
+              <a:rPr lang="en-US" sz="1200" dirty="0">
+                <a:solidFill>
+                  <a:schemeClr val="tx1"/>
+                </a:solidFill>
+                <a:latin typeface="Abadi" panose="020B0604020104020204" pitchFamily="34" charset="0"/>
+              </a:rPr>
+              <a:t>and/or </a:t>
+            </a:r>
+            <a:r>
+              <a:rPr lang="en-US" sz="1200" dirty="0" err="1">
+                <a:solidFill>
+                  <a:schemeClr val="accent1"/>
+                </a:solidFill>
+                <a:latin typeface="Abadi" panose="020B0604020104020204" pitchFamily="34" charset="0"/>
+              </a:rPr>
+              <a:t>SmB</a:t>
+            </a:r>
+            <a:r>
+              <a:rPr lang="en-US" sz="1200" dirty="0">
+                <a:solidFill>
+                  <a:schemeClr val="accent1"/>
+                </a:solidFill>
+                <a:latin typeface="Abadi" panose="020B0604020104020204" pitchFamily="34" charset="0"/>
+              </a:rPr>
+              <a:t> Peaks</a:t>
+            </a:r>
+          </a:p>
+          <a:p>
+            <a:pPr algn="ctr"/>
+            <a:br>
+              <a:rPr lang="en-US" sz="1200" dirty="0">
+                <a:solidFill>
+                  <a:schemeClr val="tx1"/>
+                </a:solidFill>
+                <a:latin typeface="Abadi" panose="020B0604020104020204" pitchFamily="34" charset="0"/>
+              </a:rPr>
+            </a:br>
+            <a:r>
+              <a:rPr lang="en-US" sz="1200" dirty="0">
+                <a:solidFill>
+                  <a:schemeClr val="tx1"/>
+                </a:solidFill>
+                <a:latin typeface="Abadi" panose="020B0604020104020204" pitchFamily="34" charset="0"/>
+              </a:rPr>
+              <a:t>Build overlap with introns and </a:t>
+            </a:r>
+            <a:r>
+              <a:rPr lang="en-US" sz="1200" dirty="0" err="1">
+                <a:solidFill>
+                  <a:schemeClr val="tx1"/>
+                </a:solidFill>
+                <a:latin typeface="Abadi" panose="020B0604020104020204" pitchFamily="34" charset="0"/>
+              </a:rPr>
+              <a:t>GRanges</a:t>
+            </a:r>
+            <a:r>
+              <a:rPr lang="en-US" sz="1200" dirty="0">
+                <a:solidFill>
+                  <a:schemeClr val="tx1"/>
+                </a:solidFill>
+                <a:latin typeface="Abadi" panose="020B0604020104020204" pitchFamily="34" charset="0"/>
+              </a:rPr>
+              <a:t> for </a:t>
+            </a:r>
+            <a:r>
+              <a:rPr lang="en-US" sz="1200" dirty="0" err="1">
+                <a:solidFill>
+                  <a:schemeClr val="tx1"/>
+                </a:solidFill>
+                <a:latin typeface="Abadi" panose="020B0604020104020204" pitchFamily="34" charset="0"/>
+              </a:rPr>
+              <a:t>cryptic_sites.bed</a:t>
+            </a:r>
+            <a:r>
+              <a:rPr lang="en-US" sz="1200" dirty="0">
+                <a:solidFill>
+                  <a:schemeClr val="tx1"/>
+                </a:solidFill>
+                <a:latin typeface="Abadi" panose="020B0604020104020204" pitchFamily="34" charset="0"/>
+              </a:rPr>
+              <a:t> </a:t>
+            </a:r>
+            <a:br>
+              <a:rPr lang="en-US" sz="1200" dirty="0">
+                <a:solidFill>
+                  <a:schemeClr val="accent1"/>
+                </a:solidFill>
+                <a:latin typeface="Abadi" panose="020B0604020104020204" pitchFamily="34" charset="0"/>
+              </a:rPr>
+            </a:br>
+            <a:r>
+              <a:rPr lang="en-US" sz="1200" dirty="0">
+                <a:solidFill>
+                  <a:schemeClr val="tx1">
+                    <a:lumMod val="95000"/>
+                    <a:lumOff val="5000"/>
+                  </a:schemeClr>
+                </a:solidFill>
+                <a:latin typeface="Abadi" panose="020B0604020104020204" pitchFamily="34" charset="0"/>
+              </a:rPr>
+              <a:t>with</a:t>
+            </a:r>
+            <a:r>
+              <a:rPr lang="en-US" sz="1200" dirty="0">
+                <a:solidFill>
+                  <a:schemeClr val="accent1"/>
+                </a:solidFill>
+                <a:latin typeface="Abadi" panose="020B0604020104020204" pitchFamily="34" charset="0"/>
+              </a:rPr>
+              <a:t> </a:t>
+            </a:r>
+            <a:r>
+              <a:rPr lang="en-US" sz="1200" dirty="0" err="1">
+                <a:solidFill>
+                  <a:schemeClr val="accent1"/>
+                </a:solidFill>
+                <a:latin typeface="Abadi" panose="020B0604020104020204" pitchFamily="34" charset="0"/>
+              </a:rPr>
+              <a:t>canonical_supported_sites.bed</a:t>
+            </a:r>
+            <a:endParaRPr lang="en-US" sz="1200" dirty="0">
+              <a:solidFill>
+                <a:schemeClr val="accent1"/>
+              </a:solidFill>
+              <a:latin typeface="Abadi" panose="020B0604020104020204" pitchFamily="34" charset="0"/>
+            </a:endParaRPr>
+          </a:p>
+          <a:p>
+            <a:pPr algn="ctr"/>
+            <a:r>
+              <a:rPr lang="en-US" sz="1200" dirty="0">
+                <a:solidFill>
+                  <a:schemeClr val="accent1"/>
+                </a:solidFill>
+                <a:latin typeface="Abadi" panose="020B0604020104020204" pitchFamily="34" charset="0"/>
+              </a:rPr>
+              <a:t>== </a:t>
+            </a:r>
+            <a:r>
+              <a:rPr lang="en-US" sz="1200" dirty="0" err="1">
+                <a:solidFill>
+                  <a:schemeClr val="accent1"/>
+                </a:solidFill>
+                <a:latin typeface="Abadi" panose="020B0604020104020204" pitchFamily="34" charset="0"/>
+              </a:rPr>
+              <a:t>cryptics_supported.bed</a:t>
+            </a:r>
+            <a:endParaRPr lang="en-US" sz="1200" dirty="0">
+              <a:solidFill>
+                <a:schemeClr val="accent1"/>
+              </a:solidFill>
+              <a:latin typeface="Abadi" panose="020B0604020104020204" pitchFamily="34" charset="0"/>
+            </a:endParaRPr>
+          </a:p>
+        </p:txBody>
+      </p:sp>
+      <p:cxnSp>
+        <p:nvCxnSpPr>
+          <p:cNvPr id="32" name="Connector: Curved 31">
+            <a:extLst>
+              <a:ext uri="{FF2B5EF4-FFF2-40B4-BE49-F238E27FC236}">
+                <a16:creationId xmlns:a16="http://schemas.microsoft.com/office/drawing/2014/main" id="{0F39E967-6144-B1AE-9CD6-F5523B6FE432}"/>
+              </a:ext>
+            </a:extLst>
+          </p:cNvPr>
+          <p:cNvCxnSpPr>
+            <a:cxnSpLocks/>
+          </p:cNvCxnSpPr>
+          <p:nvPr/>
+        </p:nvCxnSpPr>
+        <p:spPr>
+          <a:xfrm rot="16200000" flipH="1">
+            <a:off x="2441276" y="10369849"/>
+            <a:ext cx="1209679" cy="491531"/>
+          </a:xfrm>
+          <a:prstGeom prst="curvedConnector3">
+            <a:avLst>
+              <a:gd name="adj1" fmla="val 50000"/>
+            </a:avLst>
+          </a:prstGeom>
+          <a:ln>
+            <a:tailEnd type="triangle"/>
+          </a:ln>
+        </p:spPr>
+        <p:style>
+          <a:lnRef idx="3">
+            <a:schemeClr val="accent1"/>
+          </a:lnRef>
+          <a:fillRef idx="0">
+            <a:schemeClr val="accent1"/>
+          </a:fillRef>
+          <a:effectRef idx="2">
+            <a:schemeClr val="accent1"/>
+          </a:effectRef>
+          <a:fontRef idx="minor">
+            <a:schemeClr val="tx1"/>
+          </a:fontRef>
+        </p:style>
+      </p:cxnSp>
+      <p:cxnSp>
+        <p:nvCxnSpPr>
+          <p:cNvPr id="40" name="Straight Arrow Connector 39">
+            <a:extLst>
+              <a:ext uri="{FF2B5EF4-FFF2-40B4-BE49-F238E27FC236}">
+                <a16:creationId xmlns:a16="http://schemas.microsoft.com/office/drawing/2014/main" id="{4F7900BE-0022-626E-D64B-2254BD0F9118}"/>
+              </a:ext>
+            </a:extLst>
+          </p:cNvPr>
+          <p:cNvCxnSpPr>
+            <a:cxnSpLocks/>
+          </p:cNvCxnSpPr>
+          <p:nvPr/>
+        </p:nvCxnSpPr>
+        <p:spPr>
+          <a:xfrm>
+            <a:off x="1771649" y="8334375"/>
+            <a:ext cx="0" cy="349301"/>
+          </a:xfrm>
+          <a:prstGeom prst="straightConnector1">
+            <a:avLst/>
+          </a:prstGeom>
+          <a:ln>
+            <a:tailEnd type="triangle"/>
+          </a:ln>
+        </p:spPr>
+        <p:style>
+          <a:lnRef idx="3">
+            <a:schemeClr val="accent1"/>
+          </a:lnRef>
+          <a:fillRef idx="0">
+            <a:schemeClr val="accent1"/>
+          </a:fillRef>
+          <a:effectRef idx="2">
+            <a:schemeClr val="accent1"/>
+          </a:effectRef>
+          <a:fontRef idx="minor">
+            <a:schemeClr val="tx1"/>
+          </a:fontRef>
+        </p:style>
+      </p:cxnSp>
+      <p:cxnSp>
+        <p:nvCxnSpPr>
+          <p:cNvPr id="42" name="Straight Arrow Connector 41">
+            <a:extLst>
+              <a:ext uri="{FF2B5EF4-FFF2-40B4-BE49-F238E27FC236}">
+                <a16:creationId xmlns:a16="http://schemas.microsoft.com/office/drawing/2014/main" id="{DADC1EF0-6792-562E-8FCC-7100A09C72A9}"/>
+              </a:ext>
+            </a:extLst>
+          </p:cNvPr>
+          <p:cNvCxnSpPr>
+            <a:cxnSpLocks/>
+          </p:cNvCxnSpPr>
+          <p:nvPr/>
+        </p:nvCxnSpPr>
+        <p:spPr>
+          <a:xfrm flipH="1">
+            <a:off x="5225456" y="8334375"/>
+            <a:ext cx="9526" cy="313747"/>
+          </a:xfrm>
+          <a:prstGeom prst="straightConnector1">
+            <a:avLst/>
+          </a:prstGeom>
+          <a:ln>
+            <a:tailEnd type="triangle"/>
+          </a:ln>
+        </p:spPr>
+        <p:style>
+          <a:lnRef idx="3">
+            <a:schemeClr val="accent1"/>
+          </a:lnRef>
+          <a:fillRef idx="0">
+            <a:schemeClr val="accent1"/>
+          </a:fillRef>
+          <a:effectRef idx="2">
+            <a:schemeClr val="accent1"/>
+          </a:effectRef>
+          <a:fontRef idx="minor">
+            <a:schemeClr val="tx1"/>
+          </a:fontRef>
+        </p:style>
+      </p:cxnSp>
+      <p:sp>
+        <p:nvSpPr>
+          <p:cNvPr id="44" name="Rectangle 43">
+            <a:extLst>
+              <a:ext uri="{FF2B5EF4-FFF2-40B4-BE49-F238E27FC236}">
+                <a16:creationId xmlns:a16="http://schemas.microsoft.com/office/drawing/2014/main" id="{18BC3F71-301D-B74D-8E87-3247AB52F4BF}"/>
+              </a:ext>
+            </a:extLst>
+          </p:cNvPr>
+          <p:cNvSpPr/>
+          <p:nvPr/>
+        </p:nvSpPr>
+        <p:spPr>
+          <a:xfrm>
+            <a:off x="4332865" y="10147960"/>
+            <a:ext cx="2346918" cy="1778964"/>
+          </a:xfrm>
+          <a:prstGeom prst="rect">
+            <a:avLst/>
+          </a:prstGeom>
+          <a:solidFill>
+            <a:schemeClr val="accent1">
+              <a:lumMod val="40000"/>
+              <a:lumOff val="60000"/>
+            </a:schemeClr>
+          </a:solidFill>
+        </p:spPr>
+        <p:style>
+          <a:lnRef idx="2">
+            <a:schemeClr val="accent1">
+              <a:shade val="15000"/>
+            </a:schemeClr>
+          </a:lnRef>
+          <a:fillRef idx="1">
+            <a:schemeClr val="accent1"/>
+          </a:fillRef>
+          <a:effectRef idx="0">
+            <a:schemeClr val="accent1"/>
+          </a:effectRef>
+          <a:fontRef idx="minor">
+            <a:schemeClr val="lt1"/>
+          </a:fontRef>
+        </p:style>
+        <p:txBody>
+          <a:bodyPr numCol="1" rtlCol="0" anchor="ctr"/>
+          <a:lstStyle/>
+          <a:p>
+            <a:pPr algn="ctr"/>
+            <a:r>
+              <a:rPr lang="en-US" sz="1200" dirty="0">
+                <a:solidFill>
+                  <a:schemeClr val="tx1"/>
+                </a:solidFill>
+                <a:latin typeface="Abadi" panose="020B0604020104020204" pitchFamily="34" charset="0"/>
+              </a:rPr>
+              <a:t>FOUR FINAL DATASETS</a:t>
+            </a:r>
+          </a:p>
+          <a:p>
+            <a:pPr algn="ctr"/>
+            <a:endParaRPr lang="en-US" sz="1200" dirty="0">
+              <a:solidFill>
+                <a:schemeClr val="tx1"/>
+              </a:solidFill>
+              <a:latin typeface="Abadi" panose="020B0604020104020204" pitchFamily="34" charset="0"/>
+            </a:endParaRPr>
+          </a:p>
+          <a:p>
+            <a:pPr marL="228600" indent="-228600">
+              <a:buFont typeface="+mj-lt"/>
+              <a:buAutoNum type="arabicPeriod"/>
+            </a:pPr>
+            <a:r>
+              <a:rPr lang="en-US" sz="1200" dirty="0" err="1">
+                <a:solidFill>
+                  <a:schemeClr val="tx1"/>
+                </a:solidFill>
+                <a:latin typeface="Abadi" panose="020B0604020104020204" pitchFamily="34" charset="0"/>
+              </a:rPr>
+              <a:t>Canonical_splice_sites.bed</a:t>
+            </a:r>
+            <a:endParaRPr lang="en-US" sz="1200" dirty="0">
+              <a:solidFill>
+                <a:schemeClr val="tx1"/>
+              </a:solidFill>
+              <a:latin typeface="Abadi" panose="020B0604020104020204" pitchFamily="34" charset="0"/>
+            </a:endParaRPr>
+          </a:p>
+          <a:p>
+            <a:pPr marL="228600" indent="-228600">
+              <a:buFont typeface="+mj-lt"/>
+              <a:buAutoNum type="arabicPeriod"/>
+            </a:pPr>
+            <a:r>
+              <a:rPr lang="en-US" sz="1200" dirty="0">
+                <a:solidFill>
+                  <a:schemeClr val="tx1"/>
+                </a:solidFill>
+                <a:latin typeface="Abadi" panose="020B0604020104020204" pitchFamily="34" charset="0"/>
+              </a:rPr>
+              <a:t>Alt5_splice_sites.bed</a:t>
+            </a:r>
+          </a:p>
+          <a:p>
+            <a:pPr marL="228600" indent="-228600">
+              <a:buFont typeface="+mj-lt"/>
+              <a:buAutoNum type="arabicPeriod"/>
+            </a:pPr>
+            <a:r>
+              <a:rPr lang="en-US" sz="1200" dirty="0" err="1">
+                <a:solidFill>
+                  <a:schemeClr val="tx1"/>
+                </a:solidFill>
+                <a:latin typeface="Abadi" panose="020B0604020104020204" pitchFamily="34" charset="0"/>
+              </a:rPr>
+              <a:t>Decoys.bed</a:t>
+            </a:r>
+            <a:endParaRPr lang="en-US" sz="1200" dirty="0">
+              <a:solidFill>
+                <a:schemeClr val="tx1"/>
+              </a:solidFill>
+              <a:latin typeface="Abadi" panose="020B0604020104020204" pitchFamily="34" charset="0"/>
+            </a:endParaRPr>
+          </a:p>
+          <a:p>
+            <a:pPr marL="228600" indent="-228600">
+              <a:buFont typeface="+mj-lt"/>
+              <a:buAutoNum type="arabicPeriod"/>
+            </a:pPr>
+            <a:r>
+              <a:rPr lang="en-US" sz="1200" dirty="0" err="1">
+                <a:solidFill>
+                  <a:schemeClr val="tx1"/>
+                </a:solidFill>
+                <a:latin typeface="Abadi" panose="020B0604020104020204" pitchFamily="34" charset="0"/>
+              </a:rPr>
+              <a:t>Cryptics_supported.bed</a:t>
+            </a:r>
+            <a:endParaRPr lang="en-US" sz="1200" dirty="0">
+              <a:solidFill>
+                <a:schemeClr val="tx1"/>
+              </a:solidFill>
+              <a:latin typeface="Abadi" panose="020B0604020104020204" pitchFamily="34" charset="0"/>
+            </a:endParaRPr>
+          </a:p>
+        </p:txBody>
+      </p:sp>
+      <p:sp>
+        <p:nvSpPr>
+          <p:cNvPr id="46" name="Rectangle 45">
+            <a:extLst>
+              <a:ext uri="{FF2B5EF4-FFF2-40B4-BE49-F238E27FC236}">
+                <a16:creationId xmlns:a16="http://schemas.microsoft.com/office/drawing/2014/main" id="{D0EBDD17-E857-FAD9-ECF4-2CDFD6B87B2B}"/>
+              </a:ext>
+            </a:extLst>
+          </p:cNvPr>
+          <p:cNvSpPr/>
+          <p:nvPr/>
+        </p:nvSpPr>
+        <p:spPr>
+          <a:xfrm>
+            <a:off x="4870173" y="9953343"/>
+            <a:ext cx="1272301" cy="393700"/>
+          </a:xfrm>
+          <a:prstGeom prst="rect">
+            <a:avLst/>
+          </a:prstGeom>
+          <a:ln w="19050">
+            <a:solidFill>
+              <a:schemeClr val="tx1"/>
+            </a:solidFill>
+          </a:ln>
+        </p:spPr>
+        <p:style>
+          <a:lnRef idx="2">
+            <a:schemeClr val="accent1"/>
+          </a:lnRef>
+          <a:fillRef idx="1">
+            <a:schemeClr val="lt1"/>
+          </a:fillRef>
+          <a:effectRef idx="0">
+            <a:schemeClr val="accent1"/>
+          </a:effectRef>
+          <a:fontRef idx="minor">
+            <a:schemeClr val="dk1"/>
+          </a:fontRef>
+        </p:style>
+        <p:txBody>
+          <a:bodyPr rtlCol="0" anchor="ctr"/>
+          <a:lstStyle/>
+          <a:p>
+            <a:pPr algn="ctr"/>
+            <a:r>
+              <a:rPr lang="en-US" b="1" dirty="0">
+                <a:latin typeface="Raleway" pitchFamily="2" charset="0"/>
+                <a:cs typeface="Posterama" panose="020B0504020200020000" pitchFamily="34" charset="0"/>
+              </a:rPr>
+              <a:t>Result</a:t>
+            </a:r>
+            <a:endParaRPr lang="en-GB" b="1" dirty="0">
+              <a:latin typeface="Raleway" pitchFamily="2" charset="0"/>
+              <a:cs typeface="Posterama" panose="020B0504020200020000" pitchFamily="34" charset="0"/>
+            </a:endParaRPr>
+          </a:p>
+        </p:txBody>
+      </p:sp>
+      <p:cxnSp>
+        <p:nvCxnSpPr>
+          <p:cNvPr id="47" name="Straight Arrow Connector 46">
+            <a:extLst>
+              <a:ext uri="{FF2B5EF4-FFF2-40B4-BE49-F238E27FC236}">
+                <a16:creationId xmlns:a16="http://schemas.microsoft.com/office/drawing/2014/main" id="{9A29C1C3-045C-E477-9C9C-368BABC9DC23}"/>
+              </a:ext>
+            </a:extLst>
+          </p:cNvPr>
+          <p:cNvCxnSpPr>
+            <a:cxnSpLocks/>
+          </p:cNvCxnSpPr>
+          <p:nvPr/>
+        </p:nvCxnSpPr>
+        <p:spPr>
+          <a:xfrm>
+            <a:off x="5483504" y="9507483"/>
+            <a:ext cx="0" cy="445860"/>
+          </a:xfrm>
+          <a:prstGeom prst="straightConnector1">
+            <a:avLst/>
+          </a:prstGeom>
+          <a:ln>
+            <a:tailEnd type="triangle"/>
+          </a:ln>
+        </p:spPr>
+        <p:style>
+          <a:lnRef idx="3">
+            <a:schemeClr val="accent1"/>
+          </a:lnRef>
+          <a:fillRef idx="0">
+            <a:schemeClr val="accent1"/>
+          </a:fillRef>
+          <a:effectRef idx="2">
+            <a:schemeClr val="accent1"/>
+          </a:effectRef>
+          <a:fontRef idx="minor">
+            <a:schemeClr val="tx1"/>
+          </a:fontRef>
+        </p:style>
+      </p:cxnSp>
+      <p:cxnSp>
+        <p:nvCxnSpPr>
+          <p:cNvPr id="48" name="Straight Arrow Connector 47">
+            <a:extLst>
+              <a:ext uri="{FF2B5EF4-FFF2-40B4-BE49-F238E27FC236}">
+                <a16:creationId xmlns:a16="http://schemas.microsoft.com/office/drawing/2014/main" id="{73DE3673-D041-6C3D-F22F-5B45B2F6FF1B}"/>
+              </a:ext>
+            </a:extLst>
+          </p:cNvPr>
+          <p:cNvCxnSpPr>
+            <a:cxnSpLocks/>
+          </p:cNvCxnSpPr>
+          <p:nvPr/>
+        </p:nvCxnSpPr>
+        <p:spPr>
+          <a:xfrm flipV="1">
+            <a:off x="3046115" y="11499144"/>
+            <a:ext cx="1245754" cy="280073"/>
+          </a:xfrm>
+          <a:prstGeom prst="straightConnector1">
+            <a:avLst/>
+          </a:prstGeom>
+          <a:ln>
+            <a:tailEnd type="triangle"/>
+          </a:ln>
+        </p:spPr>
+        <p:style>
+          <a:lnRef idx="3">
+            <a:schemeClr val="accent1"/>
+          </a:lnRef>
+          <a:fillRef idx="0">
+            <a:schemeClr val="accent1"/>
+          </a:fillRef>
+          <a:effectRef idx="2">
+            <a:schemeClr val="accent1"/>
+          </a:effectRef>
+          <a:fontRef idx="minor">
+            <a:schemeClr val="tx1"/>
+          </a:fontRef>
+        </p:style>
+      </p:cxnSp>
+      <p:sp>
+        <p:nvSpPr>
+          <p:cNvPr id="5" name="TextBox 4">
+            <a:extLst>
+              <a:ext uri="{FF2B5EF4-FFF2-40B4-BE49-F238E27FC236}">
+                <a16:creationId xmlns:a16="http://schemas.microsoft.com/office/drawing/2014/main" id="{D467D879-2CAF-EB74-F0CE-F506D82A7E60}"/>
+              </a:ext>
+            </a:extLst>
+          </p:cNvPr>
+          <p:cNvSpPr txBox="1"/>
+          <p:nvPr/>
+        </p:nvSpPr>
+        <p:spPr>
+          <a:xfrm>
+            <a:off x="0" y="0"/>
+            <a:ext cx="2603500" cy="523220"/>
+          </a:xfrm>
+          <a:prstGeom prst="rect">
+            <a:avLst/>
+          </a:prstGeom>
+          <a:noFill/>
+        </p:spPr>
+        <p:txBody>
+          <a:bodyPr wrap="square" rtlCol="0">
+            <a:spAutoFit/>
+          </a:bodyPr>
+          <a:lstStyle/>
+          <a:p>
+            <a:r>
+              <a:rPr lang="en-US" sz="2800" dirty="0"/>
+              <a:t>NEW Proposal</a:t>
+            </a:r>
+            <a:endParaRPr lang="en-GB" sz="2800" dirty="0"/>
+          </a:p>
+        </p:txBody>
+      </p:sp>
+      <p:sp>
+        <p:nvSpPr>
+          <p:cNvPr id="12" name="Star: 5 Points 11">
+            <a:extLst>
+              <a:ext uri="{FF2B5EF4-FFF2-40B4-BE49-F238E27FC236}">
+                <a16:creationId xmlns:a16="http://schemas.microsoft.com/office/drawing/2014/main" id="{02A84F7B-65EF-C365-CE3B-DA1A4F4310DE}"/>
+              </a:ext>
+            </a:extLst>
+          </p:cNvPr>
+          <p:cNvSpPr/>
+          <p:nvPr/>
+        </p:nvSpPr>
+        <p:spPr>
+          <a:xfrm>
+            <a:off x="431756" y="3971925"/>
+            <a:ext cx="525671" cy="470504"/>
+          </a:xfrm>
+          <a:prstGeom prst="star5">
+            <a:avLst/>
+          </a:prstGeom>
+        </p:spPr>
+        <p:style>
+          <a:lnRef idx="2">
+            <a:schemeClr val="accent1">
+              <a:shade val="15000"/>
+            </a:schemeClr>
+          </a:lnRef>
+          <a:fillRef idx="1">
+            <a:schemeClr val="accent1"/>
+          </a:fillRef>
+          <a:effectRef idx="0">
+            <a:schemeClr val="accent1"/>
+          </a:effectRef>
+          <a:fontRef idx="minor">
+            <a:schemeClr val="lt1"/>
+          </a:fontRef>
+        </p:style>
+        <p:txBody>
+          <a:bodyPr rtlCol="0" anchor="ctr"/>
+          <a:lstStyle/>
+          <a:p>
+            <a:pPr algn="ctr"/>
+            <a:endParaRPr lang="en-GB"/>
+          </a:p>
+        </p:txBody>
+      </p:sp>
+      <p:cxnSp>
+        <p:nvCxnSpPr>
+          <p:cNvPr id="13" name="Straight Arrow Connector 12">
+            <a:extLst>
+              <a:ext uri="{FF2B5EF4-FFF2-40B4-BE49-F238E27FC236}">
+                <a16:creationId xmlns:a16="http://schemas.microsoft.com/office/drawing/2014/main" id="{5F794447-796E-91E8-B98B-2DC0DF124375}"/>
+              </a:ext>
+            </a:extLst>
+          </p:cNvPr>
+          <p:cNvCxnSpPr>
+            <a:cxnSpLocks/>
+          </p:cNvCxnSpPr>
+          <p:nvPr/>
+        </p:nvCxnSpPr>
+        <p:spPr>
+          <a:xfrm>
+            <a:off x="168920" y="497244"/>
+            <a:ext cx="405690" cy="3398924"/>
+          </a:xfrm>
+          <a:prstGeom prst="straightConnector1">
+            <a:avLst/>
+          </a:prstGeom>
+          <a:ln>
+            <a:tailEnd type="triangle"/>
+          </a:ln>
+        </p:spPr>
+        <p:style>
+          <a:lnRef idx="3">
+            <a:schemeClr val="accent1"/>
+          </a:lnRef>
+          <a:fillRef idx="0">
+            <a:schemeClr val="accent1"/>
+          </a:fillRef>
+          <a:effectRef idx="2">
+            <a:schemeClr val="accent1"/>
+          </a:effectRef>
+          <a:fontRef idx="minor">
+            <a:schemeClr val="tx1"/>
+          </a:fontRef>
+        </p:style>
+      </p:cxnSp>
+    </p:spTree>
+    <p:extLst>
+      <p:ext uri="{BB962C8B-B14F-4D97-AF65-F5344CB8AC3E}">
+        <p14:creationId xmlns:p14="http://schemas.microsoft.com/office/powerpoint/2010/main" val="2048028097"/>
+      </p:ext>
+    </p:extLst>
+  </p:cSld>
+  <p:clrMapOvr>
+    <a:masterClrMapping/>
+  </p:clrMapOvr>
+</p:sld>
+</file>
+
+<file path=ppt/slides/slide3.xml><?xml version="1.0" encoding="utf-8"?>
+<p:sld xmlns:a="http://schemas.openxmlformats.org/drawingml/2006/main" xmlns:r="http://schemas.openxmlformats.org/officeDocument/2006/relationships" xmlns:p="http://schemas.openxmlformats.org/presentationml/2006/main">
+  <p:cSld>
+    <p:spTree>
+      <p:nvGrpSpPr>
+        <p:cNvPr id="1" name="">
+          <a:extLst>
+            <a:ext uri="{FF2B5EF4-FFF2-40B4-BE49-F238E27FC236}">
+              <a16:creationId xmlns:a16="http://schemas.microsoft.com/office/drawing/2014/main" id="{5439C57A-A402-852A-5A46-980E0F9068A7}"/>
+            </a:ext>
+          </a:extLst>
+        </p:cNvPr>
+        <p:cNvGrpSpPr/>
+        <p:nvPr/>
+      </p:nvGrpSpPr>
+      <p:grpSpPr>
+        <a:xfrm>
+          <a:off x="0" y="0"/>
+          <a:ext cx="0" cy="0"/>
+          <a:chOff x="0" y="0"/>
+          <a:chExt cx="0" cy="0"/>
+        </a:xfrm>
+      </p:grpSpPr>
+      <p:sp>
+        <p:nvSpPr>
+          <p:cNvPr id="4" name="Rectangle 3">
+            <a:extLst>
+              <a:ext uri="{FF2B5EF4-FFF2-40B4-BE49-F238E27FC236}">
+                <a16:creationId xmlns:a16="http://schemas.microsoft.com/office/drawing/2014/main" id="{A67E4938-9453-0E5B-76BE-C5754079A5B6}"/>
+              </a:ext>
+            </a:extLst>
+          </p:cNvPr>
+          <p:cNvSpPr/>
+          <p:nvPr/>
+        </p:nvSpPr>
+        <p:spPr>
+          <a:xfrm>
+            <a:off x="694592" y="618391"/>
+            <a:ext cx="5468816" cy="1014525"/>
+          </a:xfrm>
+          <a:prstGeom prst="rect">
+            <a:avLst/>
+          </a:prstGeom>
+          <a:solidFill>
+            <a:schemeClr val="accent1">
+              <a:lumMod val="40000"/>
+              <a:lumOff val="60000"/>
+            </a:schemeClr>
+          </a:solidFill>
+        </p:spPr>
+        <p:style>
+          <a:lnRef idx="2">
+            <a:schemeClr val="accent1">
+              <a:shade val="15000"/>
+            </a:schemeClr>
+          </a:lnRef>
+          <a:fillRef idx="1">
+            <a:schemeClr val="accent1"/>
+          </a:fillRef>
+          <a:effectRef idx="0">
+            <a:schemeClr val="accent1"/>
+          </a:effectRef>
+          <a:fontRef idx="minor">
+            <a:schemeClr val="lt1"/>
+          </a:fontRef>
+        </p:style>
+        <p:txBody>
+          <a:bodyPr rtlCol="0" anchor="ctr"/>
+          <a:lstStyle/>
+          <a:p>
+            <a:pPr algn="ctr"/>
+            <a:r>
+              <a:rPr lang="en-US" sz="1400" dirty="0" err="1">
+                <a:solidFill>
+                  <a:sysClr val="windowText" lastClr="000000"/>
+                </a:solidFill>
+                <a:latin typeface="Abadi" panose="020B0604020104020204" pitchFamily="34" charset="0"/>
+              </a:rPr>
+              <a:t>SpliceAI</a:t>
+            </a:r>
+            <a:r>
+              <a:rPr lang="en-US" sz="1400" dirty="0">
+                <a:solidFill>
+                  <a:sysClr val="windowText" lastClr="000000"/>
+                </a:solidFill>
+                <a:latin typeface="Abadi" panose="020B0604020104020204" pitchFamily="34" charset="0"/>
+              </a:rPr>
+              <a:t> inferences generated across whole introns and filtered to remove signal below 0.05</a:t>
+            </a:r>
+          </a:p>
+          <a:p>
+            <a:pPr algn="ctr"/>
+            <a:r>
+              <a:rPr lang="en-US" sz="1400" dirty="0">
+                <a:solidFill>
+                  <a:sysClr val="windowText" lastClr="000000"/>
+                </a:solidFill>
+                <a:latin typeface="Abadi" panose="020B0604020104020204" pitchFamily="34" charset="0"/>
+              </a:rPr>
+              <a:t>794,192 splice site inferences</a:t>
+            </a:r>
+            <a:endParaRPr lang="en-GB" sz="1400" dirty="0">
+              <a:solidFill>
+                <a:sysClr val="windowText" lastClr="000000"/>
+              </a:solidFill>
+              <a:latin typeface="Abadi" panose="020B0604020104020204" pitchFamily="34" charset="0"/>
+            </a:endParaRPr>
+          </a:p>
+        </p:txBody>
+      </p:sp>
+      <p:sp>
+        <p:nvSpPr>
+          <p:cNvPr id="7" name="Rectangle 6">
+            <a:extLst>
+              <a:ext uri="{FF2B5EF4-FFF2-40B4-BE49-F238E27FC236}">
+                <a16:creationId xmlns:a16="http://schemas.microsoft.com/office/drawing/2014/main" id="{7D876C3A-D43F-1F89-E3EE-3F2017980370}"/>
+              </a:ext>
+            </a:extLst>
+          </p:cNvPr>
+          <p:cNvSpPr/>
+          <p:nvPr/>
+        </p:nvSpPr>
+        <p:spPr>
+          <a:xfrm>
+            <a:off x="694592" y="3756322"/>
+            <a:ext cx="5468816" cy="1015181"/>
+          </a:xfrm>
+          <a:prstGeom prst="rect">
+            <a:avLst/>
+          </a:prstGeom>
+          <a:solidFill>
+            <a:schemeClr val="accent1">
+              <a:lumMod val="40000"/>
+              <a:lumOff val="60000"/>
+            </a:schemeClr>
+          </a:solidFill>
+        </p:spPr>
+        <p:style>
+          <a:lnRef idx="2">
+            <a:schemeClr val="accent1">
+              <a:shade val="15000"/>
+            </a:schemeClr>
+          </a:lnRef>
+          <a:fillRef idx="1">
+            <a:schemeClr val="accent1"/>
+          </a:fillRef>
+          <a:effectRef idx="0">
+            <a:schemeClr val="accent1"/>
+          </a:effectRef>
+          <a:fontRef idx="minor">
+            <a:schemeClr val="lt1"/>
+          </a:fontRef>
+        </p:style>
+        <p:txBody>
+          <a:bodyPr rtlCol="0" anchor="ctr"/>
+          <a:lstStyle/>
+          <a:p>
+            <a:pPr algn="ctr"/>
+            <a:r>
+              <a:rPr lang="en-US" sz="1400" dirty="0">
+                <a:solidFill>
+                  <a:sysClr val="windowText" lastClr="000000"/>
+                </a:solidFill>
+                <a:latin typeface="Abadi" panose="020B0604020104020204" pitchFamily="34" charset="0"/>
+              </a:rPr>
+              <a:t>Extract 5’ splice sites from PSI-TABLE to filter loci within +-50 bp of 5’ canonical splice site</a:t>
+            </a:r>
+          </a:p>
+          <a:p>
+            <a:pPr algn="ctr"/>
+            <a:r>
+              <a:rPr lang="en-US" sz="1400" dirty="0" err="1">
+                <a:solidFill>
+                  <a:schemeClr val="accent1"/>
+                </a:solidFill>
+                <a:latin typeface="Abadi" panose="020B0604020104020204" pitchFamily="34" charset="0"/>
+              </a:rPr>
+              <a:t>Canonical_splice_sites.bed</a:t>
+            </a:r>
+            <a:endParaRPr lang="en-US" sz="1400" dirty="0">
+              <a:solidFill>
+                <a:schemeClr val="accent1"/>
+              </a:solidFill>
+              <a:latin typeface="Abadi" panose="020B0604020104020204" pitchFamily="34" charset="0"/>
+            </a:endParaRPr>
+          </a:p>
+          <a:p>
+            <a:pPr algn="ctr"/>
+            <a:r>
+              <a:rPr lang="en-US" sz="1400" dirty="0" err="1">
+                <a:solidFill>
+                  <a:schemeClr val="accent1"/>
+                </a:solidFill>
+                <a:latin typeface="Abadi" panose="020B0604020104020204" pitchFamily="34" charset="0"/>
+              </a:rPr>
+              <a:t>Wide_canonical_splice_sites.bed</a:t>
+            </a:r>
+            <a:endParaRPr lang="en-US" sz="1400" dirty="0">
+              <a:solidFill>
+                <a:schemeClr val="accent1"/>
+              </a:solidFill>
+              <a:latin typeface="Abadi" panose="020B0604020104020204" pitchFamily="34" charset="0"/>
+            </a:endParaRPr>
+          </a:p>
+        </p:txBody>
+      </p:sp>
+      <p:sp>
+        <p:nvSpPr>
+          <p:cNvPr id="8" name="Rectangle 7">
+            <a:extLst>
+              <a:ext uri="{FF2B5EF4-FFF2-40B4-BE49-F238E27FC236}">
+                <a16:creationId xmlns:a16="http://schemas.microsoft.com/office/drawing/2014/main" id="{4A9376B9-F34D-029B-5D6C-958D73FB227D}"/>
+              </a:ext>
+            </a:extLst>
+          </p:cNvPr>
+          <p:cNvSpPr/>
+          <p:nvPr/>
+        </p:nvSpPr>
+        <p:spPr>
+          <a:xfrm>
+            <a:off x="2127250" y="421541"/>
+            <a:ext cx="2603500" cy="393700"/>
+          </a:xfrm>
+          <a:prstGeom prst="rect">
+            <a:avLst/>
+          </a:prstGeom>
+          <a:ln w="19050">
+            <a:solidFill>
+              <a:schemeClr val="tx1"/>
+            </a:solidFill>
+          </a:ln>
+        </p:spPr>
+        <p:style>
+          <a:lnRef idx="2">
+            <a:schemeClr val="accent1"/>
+          </a:lnRef>
+          <a:fillRef idx="1">
+            <a:schemeClr val="lt1"/>
+          </a:fillRef>
+          <a:effectRef idx="0">
+            <a:schemeClr val="accent1"/>
+          </a:effectRef>
+          <a:fontRef idx="minor">
+            <a:schemeClr val="dk1"/>
+          </a:fontRef>
+        </p:style>
+        <p:txBody>
+          <a:bodyPr rtlCol="0" anchor="ctr"/>
+          <a:lstStyle/>
+          <a:p>
+            <a:pPr algn="ctr"/>
+            <a:r>
+              <a:rPr lang="en-US" b="1" dirty="0" err="1">
+                <a:latin typeface="Raleway" pitchFamily="2" charset="0"/>
+                <a:cs typeface="Posterama" panose="020B0504020200020000" pitchFamily="34" charset="0"/>
+              </a:rPr>
+              <a:t>SpliceAI</a:t>
+            </a:r>
+            <a:endParaRPr lang="en-GB" b="1" dirty="0">
+              <a:latin typeface="Raleway" pitchFamily="2" charset="0"/>
+              <a:cs typeface="Posterama" panose="020B0504020200020000" pitchFamily="34" charset="0"/>
+            </a:endParaRPr>
+          </a:p>
+        </p:txBody>
+      </p:sp>
+      <p:sp>
+        <p:nvSpPr>
+          <p:cNvPr id="20" name="Rectangle 19">
+            <a:extLst>
+              <a:ext uri="{FF2B5EF4-FFF2-40B4-BE49-F238E27FC236}">
+                <a16:creationId xmlns:a16="http://schemas.microsoft.com/office/drawing/2014/main" id="{EAF81091-4972-AE75-04E4-AB75D899982E}"/>
+              </a:ext>
+            </a:extLst>
+          </p:cNvPr>
+          <p:cNvSpPr/>
+          <p:nvPr/>
+        </p:nvSpPr>
+        <p:spPr>
+          <a:xfrm>
+            <a:off x="694592" y="2040306"/>
+            <a:ext cx="5468816" cy="1130298"/>
+          </a:xfrm>
+          <a:prstGeom prst="rect">
+            <a:avLst/>
+          </a:prstGeom>
+          <a:solidFill>
+            <a:schemeClr val="accent1">
+              <a:lumMod val="40000"/>
+              <a:lumOff val="60000"/>
+            </a:schemeClr>
+          </a:solidFill>
+        </p:spPr>
+        <p:style>
+          <a:lnRef idx="2">
+            <a:schemeClr val="accent1">
+              <a:shade val="15000"/>
+            </a:schemeClr>
+          </a:lnRef>
+          <a:fillRef idx="1">
+            <a:schemeClr val="accent1"/>
+          </a:fillRef>
+          <a:effectRef idx="0">
+            <a:schemeClr val="accent1"/>
+          </a:effectRef>
+          <a:fontRef idx="minor">
+            <a:schemeClr val="lt1"/>
+          </a:fontRef>
+        </p:style>
+        <p:txBody>
+          <a:bodyPr rtlCol="0" anchor="ctr"/>
+          <a:lstStyle/>
+          <a:p>
+            <a:pPr algn="ctr"/>
+            <a:r>
+              <a:rPr lang="en-US" sz="1400" dirty="0">
+                <a:solidFill>
+                  <a:sysClr val="windowText" lastClr="000000"/>
+                </a:solidFill>
+                <a:latin typeface="Abadi" panose="020B0604020104020204" pitchFamily="34" charset="0"/>
+              </a:rPr>
+              <a:t>Using </a:t>
+            </a:r>
+            <a:r>
+              <a:rPr lang="en-US" sz="1400" dirty="0" err="1">
+                <a:solidFill>
+                  <a:sysClr val="windowText" lastClr="000000"/>
+                </a:solidFill>
+                <a:latin typeface="Abadi" panose="020B0604020104020204" pitchFamily="34" charset="0"/>
+              </a:rPr>
+              <a:t>GRanges</a:t>
+            </a:r>
+            <a:r>
+              <a:rPr lang="en-US" sz="1400" dirty="0">
+                <a:solidFill>
+                  <a:sysClr val="windowText" lastClr="000000"/>
+                </a:solidFill>
+                <a:latin typeface="Abadi" panose="020B0604020104020204" pitchFamily="34" charset="0"/>
+              </a:rPr>
+              <a:t>, keep only “</a:t>
+            </a:r>
+            <a:r>
+              <a:rPr lang="en-US" sz="1400" dirty="0" err="1">
+                <a:solidFill>
+                  <a:sysClr val="windowText" lastClr="000000"/>
+                </a:solidFill>
+                <a:latin typeface="Abadi" panose="020B0604020104020204" pitchFamily="34" charset="0"/>
+              </a:rPr>
+              <a:t>protein_coding</a:t>
+            </a:r>
+            <a:r>
+              <a:rPr lang="en-US" sz="1400" dirty="0">
+                <a:solidFill>
+                  <a:sysClr val="windowText" lastClr="000000"/>
+                </a:solidFill>
+                <a:latin typeface="Abadi" panose="020B0604020104020204" pitchFamily="34" charset="0"/>
+              </a:rPr>
+              <a:t>” regions in Gencode.v49.annotation.gtf</a:t>
+            </a:r>
+          </a:p>
+          <a:p>
+            <a:pPr algn="ctr"/>
+            <a:r>
+              <a:rPr lang="en-US" sz="1400" dirty="0" err="1">
+                <a:solidFill>
+                  <a:schemeClr val="accent1"/>
+                </a:solidFill>
+                <a:latin typeface="Abadi" panose="020B0604020104020204" pitchFamily="34" charset="0"/>
+              </a:rPr>
+              <a:t>Protein_coding_sites.bed</a:t>
+            </a:r>
+            <a:endParaRPr lang="en-US" sz="1400" dirty="0">
+              <a:solidFill>
+                <a:schemeClr val="accent1"/>
+              </a:solidFill>
+              <a:latin typeface="Abadi" panose="020B0604020104020204" pitchFamily="34" charset="0"/>
+            </a:endParaRPr>
+          </a:p>
+        </p:txBody>
+      </p:sp>
+      <p:sp>
+        <p:nvSpPr>
+          <p:cNvPr id="24" name="Rectangle 23">
+            <a:extLst>
+              <a:ext uri="{FF2B5EF4-FFF2-40B4-BE49-F238E27FC236}">
+                <a16:creationId xmlns:a16="http://schemas.microsoft.com/office/drawing/2014/main" id="{5F02F80F-8628-CCAE-9433-804866667A25}"/>
+              </a:ext>
+            </a:extLst>
+          </p:cNvPr>
+          <p:cNvSpPr/>
+          <p:nvPr/>
+        </p:nvSpPr>
+        <p:spPr>
+          <a:xfrm>
+            <a:off x="2127250" y="1843456"/>
+            <a:ext cx="2603500" cy="393700"/>
+          </a:xfrm>
+          <a:prstGeom prst="rect">
+            <a:avLst/>
+          </a:prstGeom>
+          <a:ln w="19050">
+            <a:solidFill>
+              <a:schemeClr val="tx1"/>
+            </a:solidFill>
+          </a:ln>
+        </p:spPr>
+        <p:style>
+          <a:lnRef idx="2">
+            <a:schemeClr val="accent1"/>
+          </a:lnRef>
+          <a:fillRef idx="1">
+            <a:schemeClr val="lt1"/>
+          </a:fillRef>
+          <a:effectRef idx="0">
+            <a:schemeClr val="accent1"/>
+          </a:effectRef>
+          <a:fontRef idx="minor">
+            <a:schemeClr val="dk1"/>
+          </a:fontRef>
+        </p:style>
+        <p:txBody>
+          <a:bodyPr rtlCol="0" anchor="ctr"/>
+          <a:lstStyle/>
+          <a:p>
+            <a:pPr algn="ctr"/>
+            <a:r>
+              <a:rPr lang="en-US" b="1" dirty="0">
+                <a:latin typeface="Raleway" pitchFamily="2" charset="0"/>
+                <a:cs typeface="Posterama" panose="020B0504020200020000" pitchFamily="34" charset="0"/>
+              </a:rPr>
+              <a:t>Genomic Ranges</a:t>
+            </a:r>
+            <a:endParaRPr lang="en-GB" b="1" dirty="0">
+              <a:latin typeface="Raleway" pitchFamily="2" charset="0"/>
+              <a:cs typeface="Posterama" panose="020B0504020200020000" pitchFamily="34" charset="0"/>
+            </a:endParaRPr>
+          </a:p>
+        </p:txBody>
+      </p:sp>
+      <p:sp>
+        <p:nvSpPr>
+          <p:cNvPr id="16" name="Rectangle 15">
+            <a:extLst>
+              <a:ext uri="{FF2B5EF4-FFF2-40B4-BE49-F238E27FC236}">
+                <a16:creationId xmlns:a16="http://schemas.microsoft.com/office/drawing/2014/main" id="{B237634D-E3A9-674A-3683-3BFD7D33FE0B}"/>
+              </a:ext>
+            </a:extLst>
+          </p:cNvPr>
+          <p:cNvSpPr/>
+          <p:nvPr/>
+        </p:nvSpPr>
+        <p:spPr>
+          <a:xfrm>
+            <a:off x="114296" y="5361027"/>
+            <a:ext cx="6619875" cy="909119"/>
+          </a:xfrm>
+          <a:prstGeom prst="rect">
+            <a:avLst/>
+          </a:prstGeom>
+          <a:solidFill>
+            <a:schemeClr val="accent1">
+              <a:lumMod val="40000"/>
+              <a:lumOff val="60000"/>
+            </a:schemeClr>
+          </a:solidFill>
+        </p:spPr>
+        <p:style>
+          <a:lnRef idx="2">
+            <a:schemeClr val="accent1">
+              <a:shade val="15000"/>
+            </a:schemeClr>
+          </a:lnRef>
+          <a:fillRef idx="1">
+            <a:schemeClr val="accent1"/>
+          </a:fillRef>
+          <a:effectRef idx="0">
+            <a:schemeClr val="accent1"/>
+          </a:effectRef>
+          <a:fontRef idx="minor">
+            <a:schemeClr val="lt1"/>
+          </a:fontRef>
+        </p:style>
+        <p:txBody>
+          <a:bodyPr numCol="2" rtlCol="0" anchor="ctr"/>
+          <a:lstStyle/>
+          <a:p>
+            <a:pPr algn="ctr"/>
+            <a:r>
+              <a:rPr lang="en-GB" sz="1400" dirty="0">
+                <a:solidFill>
+                  <a:sysClr val="windowText" lastClr="000000"/>
+                </a:solidFill>
+                <a:latin typeface="SimHei" panose="020B0503020204020204" pitchFamily="49" charset="-122"/>
+                <a:ea typeface="SimHei" panose="020B0503020204020204" pitchFamily="49" charset="-122"/>
+              </a:rPr>
+              <a:t>bedtools intersect -v (no overlap) </a:t>
+            </a:r>
+            <a:r>
+              <a:rPr lang="en-GB" sz="1400" dirty="0" err="1">
+                <a:solidFill>
+                  <a:sysClr val="windowText" lastClr="000000"/>
+                </a:solidFill>
+                <a:latin typeface="SimHei" panose="020B0503020204020204" pitchFamily="49" charset="-122"/>
+                <a:ea typeface="SimHei" panose="020B0503020204020204" pitchFamily="49" charset="-122"/>
+              </a:rPr>
+              <a:t>Wide_canonical_splice_sites.bed</a:t>
+            </a:r>
+            <a:br>
+              <a:rPr lang="en-GB" sz="1400" dirty="0">
+                <a:solidFill>
+                  <a:sysClr val="windowText" lastClr="000000"/>
+                </a:solidFill>
+                <a:latin typeface="SimHei" panose="020B0503020204020204" pitchFamily="49" charset="-122"/>
+                <a:ea typeface="SimHei" panose="020B0503020204020204" pitchFamily="49" charset="-122"/>
+              </a:rPr>
+            </a:br>
+            <a:r>
+              <a:rPr lang="en-GB" sz="1400" dirty="0">
+                <a:solidFill>
+                  <a:sysClr val="windowText" lastClr="000000"/>
+                </a:solidFill>
+                <a:latin typeface="SimHei" panose="020B0503020204020204" pitchFamily="49" charset="-122"/>
+                <a:ea typeface="SimHei" panose="020B0503020204020204" pitchFamily="49" charset="-122"/>
+              </a:rPr>
+              <a:t>== </a:t>
+            </a:r>
+            <a:r>
+              <a:rPr lang="en-GB" sz="1400" dirty="0" err="1">
+                <a:solidFill>
+                  <a:schemeClr val="accent1"/>
+                </a:solidFill>
+                <a:latin typeface="SimHei" panose="020B0503020204020204" pitchFamily="49" charset="-122"/>
+                <a:ea typeface="SimHei" panose="020B0503020204020204" pitchFamily="49" charset="-122"/>
+              </a:rPr>
+              <a:t>deep_intronic_sites.bed</a:t>
+            </a:r>
+            <a:endParaRPr lang="en-GB" sz="1400" dirty="0">
+              <a:solidFill>
+                <a:sysClr val="windowText" lastClr="000000"/>
+              </a:solidFill>
+              <a:latin typeface="SimHei" panose="020B0503020204020204" pitchFamily="49" charset="-122"/>
+              <a:ea typeface="SimHei" panose="020B0503020204020204" pitchFamily="49" charset="-122"/>
+            </a:endParaRPr>
+          </a:p>
+          <a:p>
+            <a:pPr algn="ctr"/>
+            <a:r>
+              <a:rPr lang="en-GB" sz="1400" dirty="0">
+                <a:solidFill>
+                  <a:sysClr val="windowText" lastClr="000000"/>
+                </a:solidFill>
+                <a:latin typeface="SimHei" panose="020B0503020204020204" pitchFamily="49" charset="-122"/>
+                <a:ea typeface="SimHei" panose="020B0503020204020204" pitchFamily="49" charset="-122"/>
+              </a:rPr>
+              <a:t>bedtools intersect -c (does overlap) </a:t>
+            </a:r>
+            <a:r>
+              <a:rPr lang="en-GB" sz="1400" dirty="0" err="1">
+                <a:solidFill>
+                  <a:sysClr val="windowText" lastClr="000000"/>
+                </a:solidFill>
+                <a:latin typeface="SimHei" panose="020B0503020204020204" pitchFamily="49" charset="-122"/>
+                <a:ea typeface="SimHei" panose="020B0503020204020204" pitchFamily="49" charset="-122"/>
+              </a:rPr>
+              <a:t>Wide_canonical_splice_sites.bed</a:t>
+            </a:r>
+            <a:br>
+              <a:rPr lang="en-GB" sz="1400" dirty="0">
+                <a:solidFill>
+                  <a:sysClr val="windowText" lastClr="000000"/>
+                </a:solidFill>
+                <a:latin typeface="SimHei" panose="020B0503020204020204" pitchFamily="49" charset="-122"/>
+                <a:ea typeface="SimHei" panose="020B0503020204020204" pitchFamily="49" charset="-122"/>
+              </a:rPr>
+            </a:br>
+            <a:r>
+              <a:rPr lang="en-GB" sz="1400" dirty="0">
+                <a:solidFill>
+                  <a:sysClr val="windowText" lastClr="000000"/>
+                </a:solidFill>
+                <a:latin typeface="SimHei" panose="020B0503020204020204" pitchFamily="49" charset="-122"/>
+                <a:ea typeface="SimHei" panose="020B0503020204020204" pitchFamily="49" charset="-122"/>
+              </a:rPr>
+              <a:t>== </a:t>
+            </a:r>
+            <a:r>
+              <a:rPr lang="en-GB" sz="1400" dirty="0" err="1">
+                <a:solidFill>
+                  <a:schemeClr val="accent1"/>
+                </a:solidFill>
+                <a:latin typeface="SimHei" panose="020B0503020204020204" pitchFamily="49" charset="-122"/>
+                <a:ea typeface="SimHei" panose="020B0503020204020204" pitchFamily="49" charset="-122"/>
+              </a:rPr>
+              <a:t>exonic.bed</a:t>
+            </a:r>
+            <a:endParaRPr lang="en-US" sz="1400" dirty="0">
+              <a:solidFill>
+                <a:schemeClr val="accent1"/>
+              </a:solidFill>
+              <a:latin typeface="Abadi" panose="020B0604020104020204" pitchFamily="34" charset="0"/>
+            </a:endParaRPr>
+          </a:p>
+        </p:txBody>
+      </p:sp>
+      <p:sp>
+        <p:nvSpPr>
+          <p:cNvPr id="10" name="Rectangle 9">
+            <a:extLst>
+              <a:ext uri="{FF2B5EF4-FFF2-40B4-BE49-F238E27FC236}">
+                <a16:creationId xmlns:a16="http://schemas.microsoft.com/office/drawing/2014/main" id="{2E967661-85DE-107A-4B1B-CFB488F451C2}"/>
+              </a:ext>
+            </a:extLst>
+          </p:cNvPr>
+          <p:cNvSpPr/>
+          <p:nvPr/>
+        </p:nvSpPr>
+        <p:spPr>
+          <a:xfrm>
+            <a:off x="2127250" y="5045458"/>
+            <a:ext cx="2603500" cy="393700"/>
+          </a:xfrm>
+          <a:prstGeom prst="rect">
+            <a:avLst/>
+          </a:prstGeom>
+          <a:ln w="19050">
+            <a:solidFill>
+              <a:schemeClr val="tx1"/>
+            </a:solidFill>
+          </a:ln>
+        </p:spPr>
+        <p:style>
+          <a:lnRef idx="2">
+            <a:schemeClr val="accent1"/>
+          </a:lnRef>
+          <a:fillRef idx="1">
+            <a:schemeClr val="lt1"/>
+          </a:fillRef>
+          <a:effectRef idx="0">
+            <a:schemeClr val="accent1"/>
+          </a:effectRef>
+          <a:fontRef idx="minor">
+            <a:schemeClr val="dk1"/>
+          </a:fontRef>
+        </p:style>
+        <p:txBody>
+          <a:bodyPr rtlCol="0" anchor="ctr"/>
+          <a:lstStyle/>
+          <a:p>
+            <a:pPr algn="ctr"/>
+            <a:r>
+              <a:rPr lang="en-US" b="1" dirty="0">
+                <a:latin typeface="Raleway" pitchFamily="2" charset="0"/>
+                <a:cs typeface="Posterama" panose="020B0504020200020000" pitchFamily="34" charset="0"/>
+              </a:rPr>
+              <a:t>Bedtools intersect</a:t>
+            </a:r>
+            <a:endParaRPr lang="en-GB" b="1" dirty="0">
+              <a:latin typeface="Raleway" pitchFamily="2" charset="0"/>
+              <a:cs typeface="Posterama" panose="020B0504020200020000" pitchFamily="34" charset="0"/>
+            </a:endParaRPr>
+          </a:p>
+        </p:txBody>
+      </p:sp>
+      <p:sp>
+        <p:nvSpPr>
+          <p:cNvPr id="21" name="Rectangle 20">
+            <a:extLst>
+              <a:ext uri="{FF2B5EF4-FFF2-40B4-BE49-F238E27FC236}">
+                <a16:creationId xmlns:a16="http://schemas.microsoft.com/office/drawing/2014/main" id="{7851F035-A026-80BA-A628-1C81C6EB44B3}"/>
+              </a:ext>
+            </a:extLst>
+          </p:cNvPr>
+          <p:cNvSpPr/>
+          <p:nvPr/>
+        </p:nvSpPr>
+        <p:spPr>
+          <a:xfrm>
+            <a:off x="1847053" y="3419614"/>
+            <a:ext cx="3154360" cy="393700"/>
+          </a:xfrm>
+          <a:prstGeom prst="rect">
+            <a:avLst/>
+          </a:prstGeom>
+          <a:ln w="19050">
+            <a:solidFill>
+              <a:schemeClr val="tx1"/>
+            </a:solidFill>
+          </a:ln>
+        </p:spPr>
+        <p:style>
+          <a:lnRef idx="2">
+            <a:schemeClr val="accent1"/>
+          </a:lnRef>
+          <a:fillRef idx="1">
+            <a:schemeClr val="lt1"/>
+          </a:fillRef>
+          <a:effectRef idx="0">
+            <a:schemeClr val="accent1"/>
+          </a:effectRef>
+          <a:fontRef idx="minor">
+            <a:schemeClr val="dk1"/>
+          </a:fontRef>
+        </p:style>
+        <p:txBody>
+          <a:bodyPr rtlCol="0" anchor="ctr"/>
+          <a:lstStyle/>
+          <a:p>
+            <a:pPr algn="ctr"/>
+            <a:r>
+              <a:rPr lang="en-US" b="1" dirty="0">
+                <a:latin typeface="Raleway" pitchFamily="2" charset="0"/>
+                <a:cs typeface="Posterama" panose="020B0504020200020000" pitchFamily="34" charset="0"/>
+              </a:rPr>
+              <a:t>VAST-DB MAIN-PSI-TABLE</a:t>
+            </a:r>
+            <a:endParaRPr lang="en-GB" b="1" dirty="0">
+              <a:latin typeface="Raleway" pitchFamily="2" charset="0"/>
+              <a:cs typeface="Posterama" panose="020B0504020200020000" pitchFamily="34" charset="0"/>
+            </a:endParaRPr>
+          </a:p>
+        </p:txBody>
+      </p:sp>
+      <p:sp>
+        <p:nvSpPr>
+          <p:cNvPr id="25" name="Rectangle 24">
+            <a:extLst>
+              <a:ext uri="{FF2B5EF4-FFF2-40B4-BE49-F238E27FC236}">
+                <a16:creationId xmlns:a16="http://schemas.microsoft.com/office/drawing/2014/main" id="{6530B05C-C3AA-27AC-7761-A14BF84794E5}"/>
+              </a:ext>
+            </a:extLst>
+          </p:cNvPr>
+          <p:cNvSpPr/>
+          <p:nvPr/>
+        </p:nvSpPr>
+        <p:spPr>
+          <a:xfrm>
+            <a:off x="192410" y="6734386"/>
+            <a:ext cx="6473179" cy="1132482"/>
+          </a:xfrm>
+          <a:prstGeom prst="rect">
+            <a:avLst/>
+          </a:prstGeom>
+          <a:solidFill>
+            <a:schemeClr val="accent1">
+              <a:lumMod val="40000"/>
+              <a:lumOff val="60000"/>
+            </a:schemeClr>
+          </a:solidFill>
+        </p:spPr>
+        <p:style>
+          <a:lnRef idx="2">
+            <a:schemeClr val="accent1">
+              <a:shade val="15000"/>
+            </a:schemeClr>
+          </a:lnRef>
+          <a:fillRef idx="1">
+            <a:schemeClr val="accent1"/>
+          </a:fillRef>
+          <a:effectRef idx="0">
+            <a:schemeClr val="accent1"/>
+          </a:effectRef>
+          <a:fontRef idx="minor">
+            <a:schemeClr val="lt1"/>
+          </a:fontRef>
+        </p:style>
+        <p:txBody>
+          <a:bodyPr numCol="2" rtlCol="0" anchor="ctr"/>
+          <a:lstStyle/>
+          <a:p>
+            <a:pPr algn="ctr"/>
+            <a:r>
+              <a:rPr lang="en-US" sz="1200" dirty="0">
+                <a:solidFill>
+                  <a:schemeClr val="tx1"/>
+                </a:solidFill>
+                <a:latin typeface="Abadi" panose="020B0604020104020204" pitchFamily="34" charset="0"/>
+              </a:rPr>
+              <a:t>Intersect </a:t>
+            </a:r>
+            <a:r>
+              <a:rPr lang="en-US" sz="1200" dirty="0" err="1">
+                <a:solidFill>
+                  <a:schemeClr val="tx1"/>
+                </a:solidFill>
+                <a:latin typeface="Abadi" panose="020B0604020104020204" pitchFamily="34" charset="0"/>
+              </a:rPr>
+              <a:t>deep_intronic_sites.bed</a:t>
+            </a:r>
+            <a:r>
+              <a:rPr lang="en-US" sz="1200" dirty="0">
+                <a:solidFill>
+                  <a:schemeClr val="tx1"/>
+                </a:solidFill>
+                <a:latin typeface="Abadi" panose="020B0604020104020204" pitchFamily="34" charset="0"/>
+              </a:rPr>
+              <a:t> </a:t>
+            </a:r>
+            <a:br>
+              <a:rPr lang="en-US" sz="1200" dirty="0">
+                <a:solidFill>
+                  <a:schemeClr val="accent1"/>
+                </a:solidFill>
+                <a:latin typeface="Abadi" panose="020B0604020104020204" pitchFamily="34" charset="0"/>
+              </a:rPr>
+            </a:br>
+            <a:r>
+              <a:rPr lang="en-US" sz="1200" dirty="0" err="1">
+                <a:solidFill>
+                  <a:schemeClr val="accent1"/>
+                </a:solidFill>
+                <a:latin typeface="Abadi" panose="020B0604020104020204" pitchFamily="34" charset="0"/>
+              </a:rPr>
+              <a:t>RBPnet</a:t>
+            </a:r>
+            <a:r>
+              <a:rPr lang="en-US" sz="1200" dirty="0">
+                <a:solidFill>
+                  <a:schemeClr val="accent1"/>
+                </a:solidFill>
+                <a:latin typeface="Abadi" panose="020B0604020104020204" pitchFamily="34" charset="0"/>
+              </a:rPr>
+              <a:t> PRPF8 predictions </a:t>
+            </a:r>
+          </a:p>
+          <a:p>
+            <a:pPr algn="ctr"/>
+            <a:r>
+              <a:rPr lang="en-US" sz="1200" dirty="0">
+                <a:solidFill>
+                  <a:schemeClr val="tx1"/>
+                </a:solidFill>
+                <a:latin typeface="Abadi" panose="020B0604020104020204" pitchFamily="34" charset="0"/>
+              </a:rPr>
+              <a:t>and/or </a:t>
+            </a:r>
+            <a:r>
+              <a:rPr lang="en-US" sz="1200" dirty="0">
+                <a:solidFill>
+                  <a:schemeClr val="accent1"/>
+                </a:solidFill>
+                <a:latin typeface="Abadi" panose="020B0604020104020204" pitchFamily="34" charset="0"/>
+              </a:rPr>
+              <a:t>PRPF8 Peaks </a:t>
+            </a:r>
+          </a:p>
+          <a:p>
+            <a:pPr algn="ctr"/>
+            <a:r>
+              <a:rPr lang="en-US" sz="1200" dirty="0">
+                <a:solidFill>
+                  <a:schemeClr val="tx1"/>
+                </a:solidFill>
+                <a:latin typeface="Abadi" panose="020B0604020104020204" pitchFamily="34" charset="0"/>
+              </a:rPr>
+              <a:t>and/or </a:t>
+            </a:r>
+            <a:r>
+              <a:rPr lang="en-US" sz="1200" dirty="0" err="1">
+                <a:solidFill>
+                  <a:schemeClr val="accent1"/>
+                </a:solidFill>
+                <a:latin typeface="Abadi" panose="020B0604020104020204" pitchFamily="34" charset="0"/>
+              </a:rPr>
+              <a:t>SmB</a:t>
+            </a:r>
+            <a:r>
+              <a:rPr lang="en-US" sz="1200" dirty="0">
+                <a:solidFill>
+                  <a:schemeClr val="accent1"/>
+                </a:solidFill>
+                <a:latin typeface="Abadi" panose="020B0604020104020204" pitchFamily="34" charset="0"/>
+              </a:rPr>
+              <a:t> Peaks</a:t>
+            </a:r>
+          </a:p>
+          <a:p>
+            <a:pPr algn="ctr"/>
+            <a:r>
+              <a:rPr lang="en-US" sz="1200" dirty="0">
+                <a:solidFill>
+                  <a:schemeClr val="tx1"/>
+                </a:solidFill>
+                <a:latin typeface="Abadi" panose="020B0604020104020204" pitchFamily="34" charset="0"/>
+              </a:rPr>
+              <a:t>== </a:t>
+            </a:r>
+            <a:r>
+              <a:rPr lang="en-US" sz="1200" dirty="0" err="1">
+                <a:solidFill>
+                  <a:schemeClr val="tx1"/>
+                </a:solidFill>
+                <a:latin typeface="Abadi" panose="020B0604020104020204" pitchFamily="34" charset="0"/>
+              </a:rPr>
+              <a:t>decoys.bed</a:t>
+            </a:r>
+            <a:endParaRPr lang="en-US" sz="1200" dirty="0">
+              <a:solidFill>
+                <a:schemeClr val="tx1"/>
+              </a:solidFill>
+              <a:latin typeface="Abadi" panose="020B0604020104020204" pitchFamily="34" charset="0"/>
+            </a:endParaRPr>
+          </a:p>
+          <a:p>
+            <a:pPr algn="ctr"/>
+            <a:r>
+              <a:rPr lang="en-US" sz="1200" dirty="0">
+                <a:solidFill>
+                  <a:schemeClr val="tx1"/>
+                </a:solidFill>
+                <a:latin typeface="Abadi" panose="020B0604020104020204" pitchFamily="34" charset="0"/>
+              </a:rPr>
+              <a:t>Intersect </a:t>
+            </a:r>
+            <a:r>
+              <a:rPr lang="en-US" sz="1200" dirty="0" err="1">
+                <a:solidFill>
+                  <a:schemeClr val="tx1"/>
+                </a:solidFill>
+                <a:latin typeface="Abadi" panose="020B0604020104020204" pitchFamily="34" charset="0"/>
+              </a:rPr>
+              <a:t>deep_intronic_sites.bed</a:t>
+            </a:r>
+            <a:br>
+              <a:rPr lang="en-US" sz="1200" dirty="0">
+                <a:solidFill>
+                  <a:schemeClr val="tx1"/>
+                </a:solidFill>
+                <a:latin typeface="Abadi" panose="020B0604020104020204" pitchFamily="34" charset="0"/>
+              </a:rPr>
+            </a:br>
+            <a:r>
+              <a:rPr lang="en-US" sz="1200" dirty="0">
+                <a:solidFill>
+                  <a:schemeClr val="tx1"/>
+                </a:solidFill>
+                <a:latin typeface="Abadi" panose="020B0604020104020204" pitchFamily="34" charset="0"/>
+              </a:rPr>
+              <a:t>None of </a:t>
+            </a:r>
+            <a:r>
+              <a:rPr lang="en-US" sz="1200" dirty="0" err="1">
+                <a:solidFill>
+                  <a:schemeClr val="accent1"/>
+                </a:solidFill>
+                <a:latin typeface="Abadi" panose="020B0604020104020204" pitchFamily="34" charset="0"/>
+              </a:rPr>
+              <a:t>RBPnet</a:t>
+            </a:r>
+            <a:r>
+              <a:rPr lang="en-US" sz="1200" dirty="0">
+                <a:solidFill>
+                  <a:schemeClr val="accent1"/>
+                </a:solidFill>
+                <a:latin typeface="Abadi" panose="020B0604020104020204" pitchFamily="34" charset="0"/>
+              </a:rPr>
+              <a:t> PRPF8 predictions </a:t>
+            </a:r>
+          </a:p>
+          <a:p>
+            <a:pPr algn="ctr"/>
+            <a:r>
+              <a:rPr lang="en-US" sz="1200" dirty="0">
+                <a:solidFill>
+                  <a:schemeClr val="tx1"/>
+                </a:solidFill>
+                <a:latin typeface="Abadi" panose="020B0604020104020204" pitchFamily="34" charset="0"/>
+              </a:rPr>
+              <a:t>or </a:t>
+            </a:r>
+            <a:r>
+              <a:rPr lang="en-US" sz="1200" dirty="0">
+                <a:solidFill>
+                  <a:schemeClr val="accent1"/>
+                </a:solidFill>
+                <a:latin typeface="Abadi" panose="020B0604020104020204" pitchFamily="34" charset="0"/>
+              </a:rPr>
+              <a:t>PRPF8 Peaks </a:t>
+            </a:r>
+          </a:p>
+          <a:p>
+            <a:pPr algn="ctr"/>
+            <a:r>
+              <a:rPr lang="en-US" sz="1200" dirty="0">
+                <a:solidFill>
+                  <a:schemeClr val="tx1"/>
+                </a:solidFill>
+                <a:latin typeface="Abadi" panose="020B0604020104020204" pitchFamily="34" charset="0"/>
+              </a:rPr>
+              <a:t>or </a:t>
+            </a:r>
+            <a:r>
+              <a:rPr lang="en-US" sz="1200" dirty="0" err="1">
+                <a:solidFill>
+                  <a:schemeClr val="accent1"/>
+                </a:solidFill>
+                <a:latin typeface="Abadi" panose="020B0604020104020204" pitchFamily="34" charset="0"/>
+              </a:rPr>
+              <a:t>SmB</a:t>
+            </a:r>
+            <a:r>
+              <a:rPr lang="en-US" sz="1200" dirty="0">
+                <a:solidFill>
+                  <a:schemeClr val="accent1"/>
+                </a:solidFill>
+                <a:latin typeface="Abadi" panose="020B0604020104020204" pitchFamily="34" charset="0"/>
+              </a:rPr>
+              <a:t> Peaks</a:t>
+            </a:r>
+          </a:p>
+          <a:p>
+            <a:pPr algn="ctr"/>
+            <a:r>
+              <a:rPr lang="en-US" sz="1200" dirty="0">
+                <a:solidFill>
+                  <a:schemeClr val="tx1"/>
+                </a:solidFill>
+                <a:latin typeface="Abadi" panose="020B0604020104020204" pitchFamily="34" charset="0"/>
+              </a:rPr>
+              <a:t>== </a:t>
+            </a:r>
+            <a:r>
+              <a:rPr lang="en-US" sz="1200" dirty="0" err="1">
+                <a:solidFill>
+                  <a:schemeClr val="tx1"/>
+                </a:solidFill>
+                <a:latin typeface="Abadi" panose="020B0604020104020204" pitchFamily="34" charset="0"/>
+              </a:rPr>
+              <a:t>cryptic_sites.bed</a:t>
+            </a:r>
+            <a:endParaRPr lang="en-US" sz="1200" dirty="0">
+              <a:solidFill>
+                <a:schemeClr val="tx1"/>
+              </a:solidFill>
+              <a:latin typeface="Abadi" panose="020B0604020104020204" pitchFamily="34" charset="0"/>
+            </a:endParaRPr>
+          </a:p>
+        </p:txBody>
+      </p:sp>
+      <p:sp>
+        <p:nvSpPr>
+          <p:cNvPr id="30" name="Rectangle 29">
+            <a:extLst>
+              <a:ext uri="{FF2B5EF4-FFF2-40B4-BE49-F238E27FC236}">
+                <a16:creationId xmlns:a16="http://schemas.microsoft.com/office/drawing/2014/main" id="{A0F3A86D-8144-E379-7458-D6A9C0EC011D}"/>
+              </a:ext>
+            </a:extLst>
+          </p:cNvPr>
+          <p:cNvSpPr/>
+          <p:nvPr/>
+        </p:nvSpPr>
+        <p:spPr>
+          <a:xfrm>
+            <a:off x="1388756" y="8188935"/>
+            <a:ext cx="4391691" cy="1876706"/>
+          </a:xfrm>
+          <a:prstGeom prst="rect">
+            <a:avLst/>
+          </a:prstGeom>
+          <a:solidFill>
+            <a:schemeClr val="accent1">
+              <a:lumMod val="40000"/>
+              <a:lumOff val="60000"/>
+            </a:schemeClr>
+          </a:solidFill>
+        </p:spPr>
+        <p:style>
+          <a:lnRef idx="2">
+            <a:schemeClr val="accent1">
+              <a:shade val="15000"/>
+            </a:schemeClr>
+          </a:lnRef>
+          <a:fillRef idx="1">
+            <a:schemeClr val="accent1"/>
+          </a:fillRef>
+          <a:effectRef idx="0">
+            <a:schemeClr val="accent1"/>
+          </a:effectRef>
+          <a:fontRef idx="minor">
+            <a:schemeClr val="lt1"/>
+          </a:fontRef>
+        </p:style>
+        <p:txBody>
+          <a:bodyPr numCol="1" rtlCol="0" anchor="ctr"/>
+          <a:lstStyle/>
+          <a:p>
+            <a:pPr algn="ctr"/>
+            <a:r>
+              <a:rPr lang="en-US" sz="1200" dirty="0">
+                <a:solidFill>
+                  <a:schemeClr val="tx1"/>
+                </a:solidFill>
+                <a:latin typeface="Abadi" panose="020B0604020104020204" pitchFamily="34" charset="0"/>
+              </a:rPr>
+              <a:t>Intersect </a:t>
+            </a:r>
+            <a:r>
+              <a:rPr lang="en-US" sz="1200" dirty="0" err="1">
+                <a:solidFill>
+                  <a:schemeClr val="tx1"/>
+                </a:solidFill>
+                <a:latin typeface="Abadi" panose="020B0604020104020204" pitchFamily="34" charset="0"/>
+              </a:rPr>
+              <a:t>Canonical_splice_sites.bed</a:t>
+            </a:r>
+            <a:endParaRPr lang="en-US" sz="1200" dirty="0">
+              <a:solidFill>
+                <a:schemeClr val="tx1"/>
+              </a:solidFill>
+              <a:latin typeface="Abadi" panose="020B0604020104020204" pitchFamily="34" charset="0"/>
+            </a:endParaRPr>
+          </a:p>
+          <a:p>
+            <a:pPr algn="ctr"/>
+            <a:r>
+              <a:rPr lang="en-US" sz="1200" dirty="0" err="1">
+                <a:solidFill>
+                  <a:schemeClr val="accent1"/>
+                </a:solidFill>
+                <a:latin typeface="Abadi" panose="020B0604020104020204" pitchFamily="34" charset="0"/>
+              </a:rPr>
+              <a:t>RBPnet</a:t>
+            </a:r>
+            <a:r>
+              <a:rPr lang="en-US" sz="1200" dirty="0">
+                <a:solidFill>
+                  <a:schemeClr val="accent1"/>
+                </a:solidFill>
+                <a:latin typeface="Abadi" panose="020B0604020104020204" pitchFamily="34" charset="0"/>
+              </a:rPr>
+              <a:t> PRPF8 predictions </a:t>
+            </a:r>
+          </a:p>
+          <a:p>
+            <a:pPr algn="ctr"/>
+            <a:r>
+              <a:rPr lang="en-US" sz="1200" dirty="0">
+                <a:solidFill>
+                  <a:schemeClr val="tx1"/>
+                </a:solidFill>
+                <a:latin typeface="Abadi" panose="020B0604020104020204" pitchFamily="34" charset="0"/>
+              </a:rPr>
+              <a:t>and/or </a:t>
+            </a:r>
+            <a:r>
+              <a:rPr lang="en-US" sz="1200" dirty="0">
+                <a:solidFill>
+                  <a:schemeClr val="accent1"/>
+                </a:solidFill>
+                <a:latin typeface="Abadi" panose="020B0604020104020204" pitchFamily="34" charset="0"/>
+              </a:rPr>
+              <a:t>PRPF8 Peaks </a:t>
+            </a:r>
+          </a:p>
+          <a:p>
+            <a:pPr algn="ctr"/>
+            <a:r>
+              <a:rPr lang="en-US" sz="1200" dirty="0">
+                <a:solidFill>
+                  <a:schemeClr val="tx1"/>
+                </a:solidFill>
+                <a:latin typeface="Abadi" panose="020B0604020104020204" pitchFamily="34" charset="0"/>
+              </a:rPr>
+              <a:t>and/or </a:t>
+            </a:r>
+            <a:r>
+              <a:rPr lang="en-US" sz="1200" dirty="0" err="1">
+                <a:solidFill>
+                  <a:schemeClr val="accent1"/>
+                </a:solidFill>
+                <a:latin typeface="Abadi" panose="020B0604020104020204" pitchFamily="34" charset="0"/>
+              </a:rPr>
+              <a:t>SmB</a:t>
+            </a:r>
+            <a:r>
+              <a:rPr lang="en-US" sz="1200" dirty="0">
+                <a:solidFill>
+                  <a:schemeClr val="accent1"/>
+                </a:solidFill>
+                <a:latin typeface="Abadi" panose="020B0604020104020204" pitchFamily="34" charset="0"/>
+              </a:rPr>
+              <a:t> Peaks</a:t>
+            </a:r>
+          </a:p>
+          <a:p>
+            <a:pPr algn="ctr"/>
+            <a:r>
+              <a:rPr lang="en-US" sz="1200" dirty="0">
+                <a:solidFill>
+                  <a:schemeClr val="tx1"/>
+                </a:solidFill>
+                <a:latin typeface="Abadi" panose="020B0604020104020204" pitchFamily="34" charset="0"/>
+              </a:rPr>
+              <a:t>==</a:t>
+            </a:r>
+            <a:r>
+              <a:rPr lang="en-US" sz="1200" dirty="0">
+                <a:solidFill>
+                  <a:schemeClr val="accent1"/>
+                </a:solidFill>
+                <a:latin typeface="Abadi" panose="020B0604020104020204" pitchFamily="34" charset="0"/>
+              </a:rPr>
+              <a:t> </a:t>
+            </a:r>
+            <a:r>
+              <a:rPr lang="en-US" sz="1200" dirty="0" err="1">
+                <a:solidFill>
+                  <a:schemeClr val="accent1"/>
+                </a:solidFill>
+                <a:latin typeface="Abadi" panose="020B0604020104020204" pitchFamily="34" charset="0"/>
+              </a:rPr>
+              <a:t>canonical_supported_sites.bed</a:t>
+            </a:r>
+            <a:endParaRPr lang="en-US" sz="1200" dirty="0">
+              <a:solidFill>
+                <a:schemeClr val="accent1"/>
+              </a:solidFill>
+              <a:latin typeface="Abadi" panose="020B0604020104020204" pitchFamily="34" charset="0"/>
+            </a:endParaRPr>
+          </a:p>
+          <a:p>
+            <a:pPr algn="ctr"/>
+            <a:br>
+              <a:rPr lang="en-US" sz="1200" dirty="0">
+                <a:solidFill>
+                  <a:schemeClr val="tx1"/>
+                </a:solidFill>
+                <a:latin typeface="Abadi" panose="020B0604020104020204" pitchFamily="34" charset="0"/>
+              </a:rPr>
+            </a:br>
+            <a:r>
+              <a:rPr lang="en-US" sz="1200" dirty="0">
+                <a:solidFill>
+                  <a:schemeClr val="tx1"/>
+                </a:solidFill>
+                <a:latin typeface="Abadi" panose="020B0604020104020204" pitchFamily="34" charset="0"/>
+              </a:rPr>
+              <a:t>Build overlap with introns and </a:t>
+            </a:r>
+            <a:r>
+              <a:rPr lang="en-US" sz="1200" dirty="0" err="1">
+                <a:solidFill>
+                  <a:schemeClr val="tx1"/>
+                </a:solidFill>
+                <a:latin typeface="Abadi" panose="020B0604020104020204" pitchFamily="34" charset="0"/>
+              </a:rPr>
+              <a:t>GRanges</a:t>
+            </a:r>
+            <a:r>
+              <a:rPr lang="en-US" sz="1200" dirty="0">
+                <a:solidFill>
+                  <a:schemeClr val="tx1"/>
+                </a:solidFill>
+                <a:latin typeface="Abadi" panose="020B0604020104020204" pitchFamily="34" charset="0"/>
+              </a:rPr>
+              <a:t> for </a:t>
+            </a:r>
+            <a:r>
+              <a:rPr lang="en-US" sz="1200" dirty="0" err="1">
+                <a:solidFill>
+                  <a:schemeClr val="tx1"/>
+                </a:solidFill>
+                <a:latin typeface="Abadi" panose="020B0604020104020204" pitchFamily="34" charset="0"/>
+              </a:rPr>
+              <a:t>cryptic_sites.bed</a:t>
+            </a:r>
+            <a:r>
+              <a:rPr lang="en-US" sz="1200" dirty="0">
+                <a:solidFill>
+                  <a:schemeClr val="tx1"/>
+                </a:solidFill>
+                <a:latin typeface="Abadi" panose="020B0604020104020204" pitchFamily="34" charset="0"/>
+              </a:rPr>
+              <a:t> </a:t>
+            </a:r>
+            <a:br>
+              <a:rPr lang="en-US" sz="1200" dirty="0">
+                <a:solidFill>
+                  <a:schemeClr val="accent1"/>
+                </a:solidFill>
+                <a:latin typeface="Abadi" panose="020B0604020104020204" pitchFamily="34" charset="0"/>
+              </a:rPr>
+            </a:br>
+            <a:r>
+              <a:rPr lang="en-US" sz="1200" dirty="0">
+                <a:solidFill>
+                  <a:schemeClr val="tx1">
+                    <a:lumMod val="95000"/>
+                    <a:lumOff val="5000"/>
+                  </a:schemeClr>
+                </a:solidFill>
+                <a:latin typeface="Abadi" panose="020B0604020104020204" pitchFamily="34" charset="0"/>
+              </a:rPr>
+              <a:t>with</a:t>
+            </a:r>
+            <a:r>
+              <a:rPr lang="en-US" sz="1200" dirty="0">
+                <a:solidFill>
+                  <a:schemeClr val="accent1"/>
+                </a:solidFill>
+                <a:latin typeface="Abadi" panose="020B0604020104020204" pitchFamily="34" charset="0"/>
+              </a:rPr>
+              <a:t> </a:t>
+            </a:r>
+            <a:r>
+              <a:rPr lang="en-US" sz="1200" dirty="0" err="1">
+                <a:solidFill>
+                  <a:schemeClr val="accent1"/>
+                </a:solidFill>
+                <a:latin typeface="Abadi" panose="020B0604020104020204" pitchFamily="34" charset="0"/>
+              </a:rPr>
+              <a:t>canonical_supported_sites.bed</a:t>
+            </a:r>
+            <a:endParaRPr lang="en-US" sz="1200" dirty="0">
+              <a:solidFill>
+                <a:schemeClr val="accent1"/>
+              </a:solidFill>
+              <a:latin typeface="Abadi" panose="020B0604020104020204" pitchFamily="34" charset="0"/>
+            </a:endParaRPr>
+          </a:p>
+          <a:p>
+            <a:pPr algn="ctr"/>
+            <a:r>
+              <a:rPr lang="en-US" sz="1200" dirty="0">
+                <a:solidFill>
+                  <a:schemeClr val="accent1"/>
+                </a:solidFill>
+                <a:latin typeface="Abadi" panose="020B0604020104020204" pitchFamily="34" charset="0"/>
+              </a:rPr>
+              <a:t>== </a:t>
+            </a:r>
+            <a:r>
+              <a:rPr lang="en-US" sz="1200" dirty="0" err="1">
+                <a:solidFill>
+                  <a:schemeClr val="accent1"/>
+                </a:solidFill>
+                <a:latin typeface="Abadi" panose="020B0604020104020204" pitchFamily="34" charset="0"/>
+              </a:rPr>
+              <a:t>cryptics_supported.bed</a:t>
+            </a:r>
+            <a:endParaRPr lang="en-US" sz="1200" dirty="0">
+              <a:solidFill>
+                <a:schemeClr val="accent1"/>
+              </a:solidFill>
+              <a:latin typeface="Abadi" panose="020B0604020104020204" pitchFamily="34" charset="0"/>
+            </a:endParaRPr>
+          </a:p>
+        </p:txBody>
+      </p:sp>
+      <p:cxnSp>
+        <p:nvCxnSpPr>
+          <p:cNvPr id="40" name="Straight Arrow Connector 39">
+            <a:extLst>
+              <a:ext uri="{FF2B5EF4-FFF2-40B4-BE49-F238E27FC236}">
+                <a16:creationId xmlns:a16="http://schemas.microsoft.com/office/drawing/2014/main" id="{9EAE3BA6-02A6-6E1B-5136-D377E5FEE4E4}"/>
+              </a:ext>
+            </a:extLst>
+          </p:cNvPr>
+          <p:cNvCxnSpPr>
+            <a:cxnSpLocks/>
+          </p:cNvCxnSpPr>
+          <p:nvPr/>
+        </p:nvCxnSpPr>
+        <p:spPr>
+          <a:xfrm>
+            <a:off x="2717800" y="6270146"/>
+            <a:ext cx="622300" cy="641477"/>
+          </a:xfrm>
+          <a:prstGeom prst="straightConnector1">
+            <a:avLst/>
+          </a:prstGeom>
+          <a:ln>
+            <a:tailEnd type="triangle"/>
+          </a:ln>
+        </p:spPr>
+        <p:style>
+          <a:lnRef idx="3">
+            <a:schemeClr val="accent1"/>
+          </a:lnRef>
+          <a:fillRef idx="0">
+            <a:schemeClr val="accent1"/>
+          </a:fillRef>
+          <a:effectRef idx="2">
+            <a:schemeClr val="accent1"/>
+          </a:effectRef>
+          <a:fontRef idx="minor">
+            <a:schemeClr val="tx1"/>
+          </a:fontRef>
+        </p:style>
+      </p:cxnSp>
+      <p:sp>
+        <p:nvSpPr>
+          <p:cNvPr id="44" name="Rectangle 43">
+            <a:extLst>
+              <a:ext uri="{FF2B5EF4-FFF2-40B4-BE49-F238E27FC236}">
+                <a16:creationId xmlns:a16="http://schemas.microsoft.com/office/drawing/2014/main" id="{24971D70-9CC5-6605-0360-4DB1C48DE14B}"/>
+              </a:ext>
+            </a:extLst>
+          </p:cNvPr>
+          <p:cNvSpPr/>
+          <p:nvPr/>
+        </p:nvSpPr>
+        <p:spPr>
+          <a:xfrm>
+            <a:off x="2438455" y="10896599"/>
+            <a:ext cx="2292295" cy="993725"/>
+          </a:xfrm>
+          <a:prstGeom prst="rect">
+            <a:avLst/>
+          </a:prstGeom>
+          <a:solidFill>
+            <a:schemeClr val="accent1">
+              <a:lumMod val="40000"/>
+              <a:lumOff val="60000"/>
+            </a:schemeClr>
+          </a:solidFill>
+        </p:spPr>
+        <p:style>
+          <a:lnRef idx="2">
+            <a:schemeClr val="accent1">
+              <a:shade val="15000"/>
+            </a:schemeClr>
+          </a:lnRef>
+          <a:fillRef idx="1">
+            <a:schemeClr val="accent1"/>
+          </a:fillRef>
+          <a:effectRef idx="0">
+            <a:schemeClr val="accent1"/>
+          </a:effectRef>
+          <a:fontRef idx="minor">
+            <a:schemeClr val="lt1"/>
+          </a:fontRef>
+        </p:style>
+        <p:txBody>
+          <a:bodyPr numCol="1" rtlCol="0" anchor="ctr"/>
+          <a:lstStyle/>
+          <a:p>
+            <a:pPr algn="ctr"/>
+            <a:r>
+              <a:rPr lang="en-US" sz="1200" dirty="0">
+                <a:solidFill>
+                  <a:schemeClr val="tx1"/>
+                </a:solidFill>
+                <a:latin typeface="Abadi" panose="020B0604020104020204" pitchFamily="34" charset="0"/>
+              </a:rPr>
+              <a:t>TWO FINAL DATASETS</a:t>
+            </a:r>
+          </a:p>
+          <a:p>
+            <a:pPr algn="ctr"/>
+            <a:endParaRPr lang="en-US" sz="1200" dirty="0">
+              <a:solidFill>
+                <a:schemeClr val="tx1"/>
+              </a:solidFill>
+              <a:latin typeface="Abadi" panose="020B0604020104020204" pitchFamily="34" charset="0"/>
+            </a:endParaRPr>
+          </a:p>
+          <a:p>
+            <a:pPr marL="228600" indent="-228600">
+              <a:buFont typeface="+mj-lt"/>
+              <a:buAutoNum type="arabicPeriod"/>
+            </a:pPr>
+            <a:r>
+              <a:rPr lang="en-US" sz="1200" dirty="0" err="1">
+                <a:solidFill>
+                  <a:schemeClr val="tx1"/>
+                </a:solidFill>
+                <a:latin typeface="Abadi" panose="020B0604020104020204" pitchFamily="34" charset="0"/>
+              </a:rPr>
+              <a:t>Decoys.bed</a:t>
+            </a:r>
+            <a:endParaRPr lang="en-US" sz="1200" dirty="0">
+              <a:solidFill>
+                <a:schemeClr val="tx1"/>
+              </a:solidFill>
+              <a:latin typeface="Abadi" panose="020B0604020104020204" pitchFamily="34" charset="0"/>
+            </a:endParaRPr>
+          </a:p>
+          <a:p>
+            <a:pPr marL="228600" indent="-228600">
+              <a:buFont typeface="+mj-lt"/>
+              <a:buAutoNum type="arabicPeriod"/>
+            </a:pPr>
+            <a:r>
+              <a:rPr lang="en-US" sz="1200" dirty="0" err="1">
+                <a:solidFill>
+                  <a:schemeClr val="tx1"/>
+                </a:solidFill>
+                <a:latin typeface="Abadi" panose="020B0604020104020204" pitchFamily="34" charset="0"/>
+              </a:rPr>
+              <a:t>Cryptics_supported.bed</a:t>
+            </a:r>
+            <a:endParaRPr lang="en-US" sz="1200" dirty="0">
+              <a:solidFill>
+                <a:schemeClr val="tx1"/>
+              </a:solidFill>
+              <a:latin typeface="Abadi" panose="020B0604020104020204" pitchFamily="34" charset="0"/>
+            </a:endParaRPr>
+          </a:p>
+        </p:txBody>
+      </p:sp>
+      <p:sp>
+        <p:nvSpPr>
+          <p:cNvPr id="46" name="Rectangle 45">
+            <a:extLst>
+              <a:ext uri="{FF2B5EF4-FFF2-40B4-BE49-F238E27FC236}">
+                <a16:creationId xmlns:a16="http://schemas.microsoft.com/office/drawing/2014/main" id="{0F7206D1-0EC6-54BF-D154-927586F64BFB}"/>
+              </a:ext>
+            </a:extLst>
+          </p:cNvPr>
+          <p:cNvSpPr/>
+          <p:nvPr/>
+        </p:nvSpPr>
+        <p:spPr>
+          <a:xfrm>
+            <a:off x="2952943" y="10574533"/>
+            <a:ext cx="1272301" cy="393700"/>
+          </a:xfrm>
+          <a:prstGeom prst="rect">
+            <a:avLst/>
+          </a:prstGeom>
+          <a:ln w="19050">
+            <a:solidFill>
+              <a:schemeClr val="tx1"/>
+            </a:solidFill>
+          </a:ln>
+        </p:spPr>
+        <p:style>
+          <a:lnRef idx="2">
+            <a:schemeClr val="accent1"/>
+          </a:lnRef>
+          <a:fillRef idx="1">
+            <a:schemeClr val="lt1"/>
+          </a:fillRef>
+          <a:effectRef idx="0">
+            <a:schemeClr val="accent1"/>
+          </a:effectRef>
+          <a:fontRef idx="minor">
+            <a:schemeClr val="dk1"/>
+          </a:fontRef>
+        </p:style>
+        <p:txBody>
+          <a:bodyPr rtlCol="0" anchor="ctr"/>
+          <a:lstStyle/>
+          <a:p>
+            <a:pPr algn="ctr"/>
+            <a:r>
+              <a:rPr lang="en-US" b="1" dirty="0">
+                <a:latin typeface="Raleway" pitchFamily="2" charset="0"/>
+                <a:cs typeface="Posterama" panose="020B0504020200020000" pitchFamily="34" charset="0"/>
+              </a:rPr>
+              <a:t>Result</a:t>
+            </a:r>
+            <a:endParaRPr lang="en-GB" b="1" dirty="0">
+              <a:latin typeface="Raleway" pitchFamily="2" charset="0"/>
+              <a:cs typeface="Posterama" panose="020B0504020200020000" pitchFamily="34" charset="0"/>
+            </a:endParaRPr>
+          </a:p>
+        </p:txBody>
+      </p:sp>
+      <p:cxnSp>
+        <p:nvCxnSpPr>
+          <p:cNvPr id="47" name="Straight Arrow Connector 46">
+            <a:extLst>
+              <a:ext uri="{FF2B5EF4-FFF2-40B4-BE49-F238E27FC236}">
+                <a16:creationId xmlns:a16="http://schemas.microsoft.com/office/drawing/2014/main" id="{0C68BD2A-0DF7-1037-C351-2694BC72F616}"/>
+              </a:ext>
+            </a:extLst>
+          </p:cNvPr>
+          <p:cNvCxnSpPr>
+            <a:cxnSpLocks/>
+          </p:cNvCxnSpPr>
+          <p:nvPr/>
+        </p:nvCxnSpPr>
+        <p:spPr>
+          <a:xfrm>
+            <a:off x="3587804" y="10128673"/>
+            <a:ext cx="0" cy="445860"/>
+          </a:xfrm>
+          <a:prstGeom prst="straightConnector1">
+            <a:avLst/>
+          </a:prstGeom>
+          <a:ln>
+            <a:tailEnd type="triangle"/>
+          </a:ln>
+        </p:spPr>
+        <p:style>
+          <a:lnRef idx="3">
+            <a:schemeClr val="accent1"/>
+          </a:lnRef>
+          <a:fillRef idx="0">
+            <a:schemeClr val="accent1"/>
+          </a:fillRef>
+          <a:effectRef idx="2">
+            <a:schemeClr val="accent1"/>
+          </a:effectRef>
+          <a:fontRef idx="minor">
+            <a:schemeClr val="tx1"/>
+          </a:fontRef>
+        </p:style>
+      </p:cxnSp>
+      <p:cxnSp>
+        <p:nvCxnSpPr>
+          <p:cNvPr id="22" name="Straight Arrow Connector 21">
+            <a:extLst>
+              <a:ext uri="{FF2B5EF4-FFF2-40B4-BE49-F238E27FC236}">
+                <a16:creationId xmlns:a16="http://schemas.microsoft.com/office/drawing/2014/main" id="{03F19691-C573-725D-5058-D25769502FB7}"/>
+              </a:ext>
+            </a:extLst>
+          </p:cNvPr>
+          <p:cNvCxnSpPr>
+            <a:cxnSpLocks/>
+          </p:cNvCxnSpPr>
+          <p:nvPr/>
+        </p:nvCxnSpPr>
+        <p:spPr>
+          <a:xfrm flipH="1">
+            <a:off x="5001413" y="7813171"/>
+            <a:ext cx="154787" cy="1624796"/>
+          </a:xfrm>
+          <a:prstGeom prst="straightConnector1">
+            <a:avLst/>
+          </a:prstGeom>
+          <a:ln>
+            <a:tailEnd type="triangle"/>
+          </a:ln>
+        </p:spPr>
+        <p:style>
+          <a:lnRef idx="3">
+            <a:schemeClr val="accent1"/>
+          </a:lnRef>
+          <a:fillRef idx="0">
+            <a:schemeClr val="accent1"/>
+          </a:fillRef>
+          <a:effectRef idx="2">
+            <a:schemeClr val="accent1"/>
+          </a:effectRef>
+          <a:fontRef idx="minor">
+            <a:schemeClr val="tx1"/>
+          </a:fontRef>
+        </p:style>
+      </p:cxnSp>
+    </p:spTree>
+    <p:extLst>
+      <p:ext uri="{BB962C8B-B14F-4D97-AF65-F5344CB8AC3E}">
+        <p14:creationId xmlns:p14="http://schemas.microsoft.com/office/powerpoint/2010/main" val="1390564789"/>
       </p:ext>
     </p:extLst>
   </p:cSld>

</xml_diff>

<commit_message>
added cryptics and alt5ss removal'
</commit_message>
<xml_diff>
--- a/figures/datasetgenerationflowchart.pptx
+++ b/figures/datasetgenerationflowchart.pptx
@@ -5,9 +5,7 @@
     <p:sldMasterId id="2147483684" r:id="rId1"/>
   </p:sldMasterIdLst>
   <p:sldIdLst>
-    <p:sldId id="256" r:id="rId2"/>
-    <p:sldId id="257" r:id="rId3"/>
-    <p:sldId id="258" r:id="rId4"/>
+    <p:sldId id="258" r:id="rId2"/>
   </p:sldIdLst>
   <p:sldSz cx="6858000" cy="12192000"/>
   <p:notesSz cx="6858000" cy="9144000"/>
@@ -263,7 +261,7 @@
           <a:p>
             <a:fld id="{0DAF61AA-5A98-4049-A93E-477E5505141A}" type="datetimeFigureOut">
               <a:rPr lang="en-US" smtClean="0"/>
-              <a:t>9/11/2026</a:t>
+              <a:t>9/22/2026</a:t>
             </a:fld>
             <a:endParaRPr lang="en-US" dirty="0"/>
           </a:p>
@@ -463,7 +461,7 @@
           <a:p>
             <a:fld id="{0DAF61AA-5A98-4049-A93E-477E5505141A}" type="datetimeFigureOut">
               <a:rPr lang="en-US" smtClean="0"/>
-              <a:t>9/11/2026</a:t>
+              <a:t>9/22/2026</a:t>
             </a:fld>
             <a:endParaRPr lang="en-US"/>
           </a:p>
@@ -673,7 +671,7 @@
           <a:p>
             <a:fld id="{0DAF61AA-5A98-4049-A93E-477E5505141A}" type="datetimeFigureOut">
               <a:rPr lang="en-US" smtClean="0"/>
-              <a:t>9/11/2026</a:t>
+              <a:t>9/22/2026</a:t>
             </a:fld>
             <a:endParaRPr lang="en-US"/>
           </a:p>
@@ -873,7 +871,7 @@
           <a:p>
             <a:fld id="{0DAF61AA-5A98-4049-A93E-477E5505141A}" type="datetimeFigureOut">
               <a:rPr lang="en-US" smtClean="0"/>
-              <a:t>9/11/2026</a:t>
+              <a:t>9/22/2026</a:t>
             </a:fld>
             <a:endParaRPr lang="en-US"/>
           </a:p>
@@ -1149,7 +1147,7 @@
           <a:p>
             <a:fld id="{0DAF61AA-5A98-4049-A93E-477E5505141A}" type="datetimeFigureOut">
               <a:rPr lang="en-US" smtClean="0"/>
-              <a:t>9/11/2026</a:t>
+              <a:t>9/22/2026</a:t>
             </a:fld>
             <a:endParaRPr lang="en-US"/>
           </a:p>
@@ -1417,7 +1415,7 @@
           <a:p>
             <a:fld id="{0DAF61AA-5A98-4049-A93E-477E5505141A}" type="datetimeFigureOut">
               <a:rPr lang="en-US" smtClean="0"/>
-              <a:t>9/11/2026</a:t>
+              <a:t>9/22/2026</a:t>
             </a:fld>
             <a:endParaRPr lang="en-US"/>
           </a:p>
@@ -1832,7 +1830,7 @@
           <a:p>
             <a:fld id="{0DAF61AA-5A98-4049-A93E-477E5505141A}" type="datetimeFigureOut">
               <a:rPr lang="en-US" smtClean="0"/>
-              <a:t>9/11/2026</a:t>
+              <a:t>9/22/2026</a:t>
             </a:fld>
             <a:endParaRPr lang="en-US"/>
           </a:p>
@@ -1974,7 +1972,7 @@
           <a:p>
             <a:fld id="{0DAF61AA-5A98-4049-A93E-477E5505141A}" type="datetimeFigureOut">
               <a:rPr lang="en-US" smtClean="0"/>
-              <a:t>9/11/2026</a:t>
+              <a:t>9/22/2026</a:t>
             </a:fld>
             <a:endParaRPr lang="en-US"/>
           </a:p>
@@ -2087,7 +2085,7 @@
           <a:p>
             <a:fld id="{0DAF61AA-5A98-4049-A93E-477E5505141A}" type="datetimeFigureOut">
               <a:rPr lang="en-US" smtClean="0"/>
-              <a:t>9/11/2026</a:t>
+              <a:t>9/22/2026</a:t>
             </a:fld>
             <a:endParaRPr lang="en-US"/>
           </a:p>
@@ -2400,7 +2398,7 @@
           <a:p>
             <a:fld id="{0DAF61AA-5A98-4049-A93E-477E5505141A}" type="datetimeFigureOut">
               <a:rPr lang="en-US" smtClean="0"/>
-              <a:t>9/11/2026</a:t>
+              <a:t>9/22/2026</a:t>
             </a:fld>
             <a:endParaRPr lang="en-US"/>
           </a:p>
@@ -2693,7 +2691,7 @@
           <a:p>
             <a:fld id="{0DAF61AA-5A98-4049-A93E-477E5505141A}" type="datetimeFigureOut">
               <a:rPr lang="en-US" smtClean="0"/>
-              <a:t>9/11/2026</a:t>
+              <a:t>9/22/2026</a:t>
             </a:fld>
             <a:endParaRPr lang="en-US"/>
           </a:p>
@@ -6406,7 +6404,7 @@
             <a:fld id="{0DAF61AA-5A98-4049-A93E-477E5505141A}" type="datetimeFigureOut">
               <a:rPr lang="en-US" smtClean="0"/>
               <a:pPr/>
-              <a:t>9/11/2026</a:t>
+              <a:t>9/22/2026</a:t>
             </a:fld>
             <a:endParaRPr lang="en-US" dirty="0"/>
           </a:p>
@@ -6825,11 +6823,17 @@
 </file>
 
 <file path=ppt/slides/slide1.xml><?xml version="1.0" encoding="utf-8"?>
-<p:sld xmlns:a="http://schemas.openxmlformats.org/drawingml/2006/main" xmlns:r="http://schemas.openxmlformats.org/officeDocument/2006/relationships" xmlns:p="http://schemas.openxmlformats.org/presentationml/2006/main" showMasterSp="0">
+<p:sld xmlns:a="http://schemas.openxmlformats.org/drawingml/2006/main" xmlns:r="http://schemas.openxmlformats.org/officeDocument/2006/relationships" xmlns:p="http://schemas.openxmlformats.org/presentationml/2006/main">
   <p:cSld>
     <p:spTree>
       <p:nvGrpSpPr>
-        <p:cNvPr id="1" name=""/>
+        <p:cNvPr id="1" name="">
+          <a:extLst>
+            <a:ext uri="{FF2B5EF4-FFF2-40B4-BE49-F238E27FC236}">
+              <a16:creationId xmlns:a16="http://schemas.microsoft.com/office/drawing/2014/main" id="{5439C57A-A402-852A-5A46-980E0F9068A7}"/>
+            </a:ext>
+          </a:extLst>
+        </p:cNvPr>
         <p:cNvGrpSpPr/>
         <p:nvPr/>
       </p:nvGrpSpPr>
@@ -6841,1084 +6845,12 @@
           <a:chExt cx="0" cy="0"/>
         </a:xfrm>
       </p:grpSpPr>
-      <p:sp>
-        <p:nvSpPr>
-          <p:cNvPr id="4" name="Rectangle 3">
+      <p:cxnSp>
+        <p:nvCxnSpPr>
+          <p:cNvPr id="2" name="Straight Arrow Connector 1">
             <a:extLst>
               <a:ext uri="{FF2B5EF4-FFF2-40B4-BE49-F238E27FC236}">
-                <a16:creationId xmlns:a16="http://schemas.microsoft.com/office/drawing/2014/main" id="{9E16FFA0-65E8-131F-6366-6E60FA7DA310}"/>
-              </a:ext>
-            </a:extLst>
-          </p:cNvPr>
-          <p:cNvSpPr/>
-          <p:nvPr/>
-        </p:nvSpPr>
-        <p:spPr>
-          <a:xfrm>
-            <a:off x="694592" y="618391"/>
-            <a:ext cx="5468816" cy="1400909"/>
-          </a:xfrm>
-          <a:prstGeom prst="rect">
-            <a:avLst/>
-          </a:prstGeom>
-          <a:solidFill>
-            <a:schemeClr val="accent1">
-              <a:lumMod val="40000"/>
-              <a:lumOff val="60000"/>
-            </a:schemeClr>
-          </a:solidFill>
-        </p:spPr>
-        <p:style>
-          <a:lnRef idx="2">
-            <a:schemeClr val="accent1">
-              <a:shade val="15000"/>
-            </a:schemeClr>
-          </a:lnRef>
-          <a:fillRef idx="1">
-            <a:schemeClr val="accent1"/>
-          </a:fillRef>
-          <a:effectRef idx="0">
-            <a:schemeClr val="accent1"/>
-          </a:effectRef>
-          <a:fontRef idx="minor">
-            <a:schemeClr val="lt1"/>
-          </a:fontRef>
-        </p:style>
-        <p:txBody>
-          <a:bodyPr rtlCol="0" anchor="ctr"/>
-          <a:lstStyle/>
-          <a:p>
-            <a:pPr algn="ctr"/>
-            <a:r>
-              <a:rPr lang="en-US" sz="1600" dirty="0" err="1">
-                <a:solidFill>
-                  <a:sysClr val="windowText" lastClr="000000"/>
-                </a:solidFill>
-                <a:latin typeface="Abadi" panose="020B0604020104020204" pitchFamily="34" charset="0"/>
-              </a:rPr>
-              <a:t>SpliceAI</a:t>
-            </a:r>
-            <a:r>
-              <a:rPr lang="en-US" sz="1600" dirty="0">
-                <a:solidFill>
-                  <a:sysClr val="windowText" lastClr="000000"/>
-                </a:solidFill>
-                <a:latin typeface="Abadi" panose="020B0604020104020204" pitchFamily="34" charset="0"/>
-              </a:rPr>
-              <a:t> inferences generated across whole introns and filtered to remove signal below 0.05</a:t>
-            </a:r>
-          </a:p>
-          <a:p>
-            <a:pPr algn="ctr"/>
-            <a:r>
-              <a:rPr lang="en-US" sz="1600" dirty="0">
-                <a:solidFill>
-                  <a:sysClr val="windowText" lastClr="000000"/>
-                </a:solidFill>
-                <a:latin typeface="Abadi" panose="020B0604020104020204" pitchFamily="34" charset="0"/>
-              </a:rPr>
-              <a:t>794,192 splice site inferences</a:t>
-            </a:r>
-            <a:endParaRPr lang="en-GB" sz="1600" dirty="0">
-              <a:solidFill>
-                <a:sysClr val="windowText" lastClr="000000"/>
-              </a:solidFill>
-              <a:latin typeface="Abadi" panose="020B0604020104020204" pitchFamily="34" charset="0"/>
-            </a:endParaRPr>
-          </a:p>
-        </p:txBody>
-      </p:sp>
-      <p:sp>
-        <p:nvSpPr>
-          <p:cNvPr id="5" name="Oval 4">
-            <a:extLst>
-              <a:ext uri="{FF2B5EF4-FFF2-40B4-BE49-F238E27FC236}">
-                <a16:creationId xmlns:a16="http://schemas.microsoft.com/office/drawing/2014/main" id="{3B70EEDD-A0AD-0DB4-9816-F3F88A2A2029}"/>
-              </a:ext>
-            </a:extLst>
-          </p:cNvPr>
-          <p:cNvSpPr/>
-          <p:nvPr/>
-        </p:nvSpPr>
-        <p:spPr>
-          <a:xfrm>
-            <a:off x="6001130" y="1318845"/>
-            <a:ext cx="508000" cy="495300"/>
-          </a:xfrm>
-          <a:prstGeom prst="ellipse">
-            <a:avLst/>
-          </a:prstGeom>
-        </p:spPr>
-        <p:style>
-          <a:lnRef idx="2">
-            <a:schemeClr val="accent1"/>
-          </a:lnRef>
-          <a:fillRef idx="1">
-            <a:schemeClr val="lt1"/>
-          </a:fillRef>
-          <a:effectRef idx="0">
-            <a:schemeClr val="accent1"/>
-          </a:effectRef>
-          <a:fontRef idx="minor">
-            <a:schemeClr val="dk1"/>
-          </a:fontRef>
-        </p:style>
-        <p:txBody>
-          <a:bodyPr rtlCol="0" anchor="ctr"/>
-          <a:lstStyle/>
-          <a:p>
-            <a:pPr algn="ctr"/>
-            <a:r>
-              <a:rPr lang="en-US" sz="1600" dirty="0"/>
-              <a:t>-a</a:t>
-            </a:r>
-            <a:endParaRPr lang="en-GB" sz="1600" dirty="0"/>
-          </a:p>
-        </p:txBody>
-      </p:sp>
-      <p:sp>
-        <p:nvSpPr>
-          <p:cNvPr id="7" name="Rectangle 6">
-            <a:extLst>
-              <a:ext uri="{FF2B5EF4-FFF2-40B4-BE49-F238E27FC236}">
-                <a16:creationId xmlns:a16="http://schemas.microsoft.com/office/drawing/2014/main" id="{85C0822E-1796-6E3C-602C-7D9DC80893DD}"/>
-              </a:ext>
-            </a:extLst>
-          </p:cNvPr>
-          <p:cNvSpPr/>
-          <p:nvPr/>
-        </p:nvSpPr>
-        <p:spPr>
-          <a:xfrm>
-            <a:off x="694592" y="4143828"/>
-            <a:ext cx="5468816" cy="5762873"/>
-          </a:xfrm>
-          <a:prstGeom prst="rect">
-            <a:avLst/>
-          </a:prstGeom>
-          <a:solidFill>
-            <a:schemeClr val="accent1">
-              <a:lumMod val="40000"/>
-              <a:lumOff val="60000"/>
-            </a:schemeClr>
-          </a:solidFill>
-        </p:spPr>
-        <p:style>
-          <a:lnRef idx="2">
-            <a:schemeClr val="accent1">
-              <a:shade val="15000"/>
-            </a:schemeClr>
-          </a:lnRef>
-          <a:fillRef idx="1">
-            <a:schemeClr val="accent1"/>
-          </a:fillRef>
-          <a:effectRef idx="0">
-            <a:schemeClr val="accent1"/>
-          </a:effectRef>
-          <a:fontRef idx="minor">
-            <a:schemeClr val="lt1"/>
-          </a:fontRef>
-        </p:style>
-        <p:txBody>
-          <a:bodyPr rtlCol="0" anchor="ctr"/>
-          <a:lstStyle/>
-          <a:p>
-            <a:pPr algn="ctr"/>
-            <a:r>
-              <a:rPr lang="en-US" sz="1600" dirty="0">
-                <a:solidFill>
-                  <a:sysClr val="windowText" lastClr="000000"/>
-                </a:solidFill>
-                <a:latin typeface="Abadi" panose="020B0604020104020204" pitchFamily="34" charset="0"/>
-              </a:rPr>
-              <a:t>Intersect –v to remove splice sites within 100 bp of canonical splice sites</a:t>
-            </a:r>
-          </a:p>
-          <a:p>
-            <a:pPr algn="ctr"/>
-            <a:endParaRPr lang="en-US" sz="1600" dirty="0">
-              <a:solidFill>
-                <a:sysClr val="windowText" lastClr="000000"/>
-              </a:solidFill>
-              <a:latin typeface="Abadi" panose="020B0604020104020204" pitchFamily="34" charset="0"/>
-            </a:endParaRPr>
-          </a:p>
-          <a:p>
-            <a:pPr algn="ctr"/>
-            <a:r>
-              <a:rPr lang="en-US" sz="1600" dirty="0" err="1">
-                <a:solidFill>
-                  <a:schemeClr val="accent1"/>
-                </a:solidFill>
-                <a:latin typeface="Abadi" panose="020B0604020104020204" pitchFamily="34" charset="0"/>
-              </a:rPr>
-              <a:t>Wide_canonical_splice_sites.bed</a:t>
-            </a:r>
-            <a:endParaRPr lang="en-US" sz="1600" dirty="0">
-              <a:solidFill>
-                <a:schemeClr val="accent1"/>
-              </a:solidFill>
-              <a:latin typeface="Abadi" panose="020B0604020104020204" pitchFamily="34" charset="0"/>
-            </a:endParaRPr>
-          </a:p>
-          <a:p>
-            <a:pPr algn="ctr"/>
-            <a:endParaRPr lang="en-US" sz="1600" dirty="0">
-              <a:solidFill>
-                <a:schemeClr val="accent1"/>
-              </a:solidFill>
-              <a:latin typeface="Abadi" panose="020B0604020104020204" pitchFamily="34" charset="0"/>
-            </a:endParaRPr>
-          </a:p>
-          <a:p>
-            <a:pPr algn="ctr"/>
-            <a:endParaRPr lang="en-US" sz="1600" dirty="0">
-              <a:solidFill>
-                <a:schemeClr val="accent1"/>
-              </a:solidFill>
-              <a:latin typeface="Abadi" panose="020B0604020104020204" pitchFamily="34" charset="0"/>
-            </a:endParaRPr>
-          </a:p>
-          <a:p>
-            <a:pPr algn="ctr"/>
-            <a:endParaRPr lang="en-US" sz="1600" dirty="0">
-              <a:solidFill>
-                <a:schemeClr val="accent1"/>
-              </a:solidFill>
-              <a:latin typeface="Abadi" panose="020B0604020104020204" pitchFamily="34" charset="0"/>
-            </a:endParaRPr>
-          </a:p>
-          <a:p>
-            <a:pPr algn="ctr"/>
-            <a:endParaRPr lang="en-US" sz="1600" dirty="0">
-              <a:solidFill>
-                <a:schemeClr val="accent1"/>
-              </a:solidFill>
-              <a:latin typeface="Abadi" panose="020B0604020104020204" pitchFamily="34" charset="0"/>
-            </a:endParaRPr>
-          </a:p>
-          <a:p>
-            <a:pPr algn="ctr"/>
-            <a:endParaRPr lang="en-US" sz="1600" dirty="0">
-              <a:solidFill>
-                <a:schemeClr val="accent1"/>
-              </a:solidFill>
-              <a:latin typeface="Abadi" panose="020B0604020104020204" pitchFamily="34" charset="0"/>
-            </a:endParaRPr>
-          </a:p>
-          <a:p>
-            <a:pPr algn="ctr"/>
-            <a:endParaRPr lang="en-US" sz="1600" dirty="0">
-              <a:solidFill>
-                <a:schemeClr val="accent1"/>
-              </a:solidFill>
-              <a:latin typeface="Abadi" panose="020B0604020104020204" pitchFamily="34" charset="0"/>
-            </a:endParaRPr>
-          </a:p>
-          <a:p>
-            <a:pPr algn="ctr"/>
-            <a:endParaRPr lang="en-US" sz="1600" dirty="0">
-              <a:solidFill>
-                <a:schemeClr val="accent1"/>
-              </a:solidFill>
-              <a:latin typeface="Abadi" panose="020B0604020104020204" pitchFamily="34" charset="0"/>
-            </a:endParaRPr>
-          </a:p>
-          <a:p>
-            <a:pPr algn="ctr"/>
-            <a:endParaRPr lang="en-US" sz="1600" dirty="0">
-              <a:solidFill>
-                <a:schemeClr val="accent1"/>
-              </a:solidFill>
-              <a:latin typeface="Abadi" panose="020B0604020104020204" pitchFamily="34" charset="0"/>
-            </a:endParaRPr>
-          </a:p>
-          <a:p>
-            <a:pPr algn="ctr"/>
-            <a:endParaRPr lang="en-US" sz="1600" dirty="0">
-              <a:solidFill>
-                <a:schemeClr val="accent1"/>
-              </a:solidFill>
-              <a:latin typeface="Abadi" panose="020B0604020104020204" pitchFamily="34" charset="0"/>
-            </a:endParaRPr>
-          </a:p>
-          <a:p>
-            <a:pPr algn="ctr"/>
-            <a:endParaRPr lang="en-US" sz="1600" dirty="0">
-              <a:solidFill>
-                <a:schemeClr val="accent1"/>
-              </a:solidFill>
-              <a:latin typeface="Abadi" panose="020B0604020104020204" pitchFamily="34" charset="0"/>
-            </a:endParaRPr>
-          </a:p>
-          <a:p>
-            <a:pPr algn="ctr"/>
-            <a:endParaRPr lang="en-US" sz="1600" dirty="0">
-              <a:solidFill>
-                <a:schemeClr val="accent1"/>
-              </a:solidFill>
-              <a:latin typeface="Abadi" panose="020B0604020104020204" pitchFamily="34" charset="0"/>
-            </a:endParaRPr>
-          </a:p>
-          <a:p>
-            <a:pPr algn="ctr"/>
-            <a:endParaRPr lang="en-US" sz="1600" dirty="0">
-              <a:solidFill>
-                <a:sysClr val="windowText" lastClr="000000"/>
-              </a:solidFill>
-              <a:latin typeface="Abadi" panose="020B0604020104020204" pitchFamily="34" charset="0"/>
-            </a:endParaRPr>
-          </a:p>
-          <a:p>
-            <a:pPr algn="ctr"/>
-            <a:r>
-              <a:rPr lang="en-US" sz="1600" dirty="0" err="1">
-                <a:solidFill>
-                  <a:sysClr val="windowText" lastClr="000000"/>
-                </a:solidFill>
-                <a:latin typeface="Abadi" panose="020B0604020104020204" pitchFamily="34" charset="0"/>
-              </a:rPr>
-              <a:t>RBPnet</a:t>
-            </a:r>
-            <a:r>
-              <a:rPr lang="en-US" sz="1600" dirty="0">
-                <a:solidFill>
-                  <a:sysClr val="windowText" lastClr="000000"/>
-                </a:solidFill>
-                <a:latin typeface="Abadi" panose="020B0604020104020204" pitchFamily="34" charset="0"/>
-              </a:rPr>
-              <a:t> </a:t>
-            </a:r>
-            <a:r>
-              <a:rPr lang="en-US" sz="1600" dirty="0">
-                <a:solidFill>
-                  <a:schemeClr val="accent1"/>
-                </a:solidFill>
-                <a:latin typeface="Abadi" panose="020B0604020104020204" pitchFamily="34" charset="0"/>
-              </a:rPr>
-              <a:t>PRPF8</a:t>
-            </a:r>
-            <a:r>
-              <a:rPr lang="en-US" sz="1600" dirty="0">
-                <a:solidFill>
-                  <a:sysClr val="windowText" lastClr="000000"/>
-                </a:solidFill>
-                <a:latin typeface="Abadi" panose="020B0604020104020204" pitchFamily="34" charset="0"/>
-              </a:rPr>
-              <a:t> predictions across introns 242,946 Peaks</a:t>
-            </a:r>
-          </a:p>
-          <a:p>
-            <a:pPr algn="ctr"/>
-            <a:r>
-              <a:rPr lang="en-US" sz="1600" dirty="0">
-                <a:solidFill>
-                  <a:sysClr val="windowText" lastClr="000000"/>
-                </a:solidFill>
-                <a:latin typeface="Abadi" panose="020B0604020104020204" pitchFamily="34" charset="0"/>
-              </a:rPr>
-              <a:t>Merged </a:t>
-            </a:r>
-            <a:r>
-              <a:rPr lang="en-US" sz="1600" dirty="0">
-                <a:solidFill>
-                  <a:schemeClr val="accent1"/>
-                </a:solidFill>
-                <a:latin typeface="Abadi" panose="020B0604020104020204" pitchFamily="34" charset="0"/>
-              </a:rPr>
-              <a:t>PRPF8 </a:t>
-            </a:r>
-            <a:r>
-              <a:rPr lang="en-US" sz="1600" dirty="0" err="1">
-                <a:solidFill>
-                  <a:schemeClr val="accent1"/>
-                </a:solidFill>
-                <a:latin typeface="Abadi" panose="020B0604020104020204" pitchFamily="34" charset="0"/>
-              </a:rPr>
-              <a:t>eCLIP</a:t>
-            </a:r>
-            <a:r>
-              <a:rPr lang="en-US" sz="1600" dirty="0">
-                <a:solidFill>
-                  <a:schemeClr val="accent1"/>
-                </a:solidFill>
-                <a:latin typeface="Abadi" panose="020B0604020104020204" pitchFamily="34" charset="0"/>
-              </a:rPr>
-              <a:t> and </a:t>
-            </a:r>
-            <a:r>
-              <a:rPr lang="en-US" sz="1600" dirty="0" err="1">
-                <a:solidFill>
-                  <a:schemeClr val="accent1"/>
-                </a:solidFill>
-                <a:latin typeface="Abadi" panose="020B0604020104020204" pitchFamily="34" charset="0"/>
-              </a:rPr>
-              <a:t>iCLIP</a:t>
-            </a:r>
-            <a:r>
-              <a:rPr lang="en-US" sz="1600" dirty="0">
-                <a:solidFill>
-                  <a:schemeClr val="accent1"/>
-                </a:solidFill>
-                <a:latin typeface="Abadi" panose="020B0604020104020204" pitchFamily="34" charset="0"/>
-              </a:rPr>
-              <a:t> </a:t>
-            </a:r>
-            <a:r>
-              <a:rPr lang="en-US" sz="1600" dirty="0">
-                <a:solidFill>
-                  <a:sysClr val="windowText" lastClr="000000"/>
-                </a:solidFill>
-                <a:latin typeface="Abadi" panose="020B0604020104020204" pitchFamily="34" charset="0"/>
-              </a:rPr>
-              <a:t>227,651 Peaks</a:t>
-            </a:r>
-          </a:p>
-          <a:p>
-            <a:pPr algn="ctr"/>
-            <a:r>
-              <a:rPr lang="en-GB" sz="1600" dirty="0">
-                <a:solidFill>
-                  <a:sysClr val="windowText" lastClr="000000"/>
-                </a:solidFill>
-                <a:latin typeface="Abadi" panose="020B0604020104020204" pitchFamily="34" charset="0"/>
-              </a:rPr>
-              <a:t>Merged </a:t>
-            </a:r>
-            <a:r>
-              <a:rPr lang="en-GB" sz="1600" dirty="0" err="1">
-                <a:solidFill>
-                  <a:schemeClr val="accent1"/>
-                </a:solidFill>
-                <a:latin typeface="Abadi" panose="020B0604020104020204" pitchFamily="34" charset="0"/>
-              </a:rPr>
-              <a:t>SmB</a:t>
-            </a:r>
-            <a:r>
-              <a:rPr lang="en-GB" sz="1600" dirty="0">
-                <a:solidFill>
-                  <a:schemeClr val="accent1"/>
-                </a:solidFill>
-                <a:latin typeface="Abadi" panose="020B0604020104020204" pitchFamily="34" charset="0"/>
-              </a:rPr>
-              <a:t> </a:t>
-            </a:r>
-            <a:r>
-              <a:rPr lang="en-GB" sz="1600" dirty="0" err="1">
-                <a:solidFill>
-                  <a:schemeClr val="accent1"/>
-                </a:solidFill>
-                <a:latin typeface="Abadi" panose="020B0604020104020204" pitchFamily="34" charset="0"/>
-              </a:rPr>
-              <a:t>iCLIP</a:t>
-            </a:r>
-            <a:r>
-              <a:rPr lang="en-GB" sz="1600" dirty="0">
-                <a:solidFill>
-                  <a:schemeClr val="accent1"/>
-                </a:solidFill>
-                <a:latin typeface="Abadi" panose="020B0604020104020204" pitchFamily="34" charset="0"/>
-              </a:rPr>
-              <a:t> </a:t>
-            </a:r>
-            <a:r>
-              <a:rPr lang="en-GB" sz="1600" dirty="0">
-                <a:solidFill>
-                  <a:sysClr val="windowText" lastClr="000000"/>
-                </a:solidFill>
-                <a:latin typeface="Abadi" panose="020B0604020104020204" pitchFamily="34" charset="0"/>
-              </a:rPr>
-              <a:t>152,983 Peaks </a:t>
-            </a:r>
-          </a:p>
-          <a:p>
-            <a:pPr algn="ctr"/>
-            <a:endParaRPr lang="en-GB" sz="1600" dirty="0">
-              <a:solidFill>
-                <a:sysClr val="windowText" lastClr="000000"/>
-              </a:solidFill>
-              <a:latin typeface="Abadi" panose="020B0604020104020204" pitchFamily="34" charset="0"/>
-            </a:endParaRPr>
-          </a:p>
-          <a:p>
-            <a:pPr algn="ctr"/>
-            <a:r>
-              <a:rPr lang="en-US" sz="1400" dirty="0">
-                <a:solidFill>
-                  <a:sysClr val="windowText" lastClr="000000"/>
-                </a:solidFill>
-                <a:latin typeface="Abadi" panose="020B0604020104020204" pitchFamily="34" charset="0"/>
-              </a:rPr>
-              <a:t>Need to use Granges AGAIN, to remove exons from intronic regions in decoys/</a:t>
-            </a:r>
-            <a:r>
-              <a:rPr lang="en-US" sz="1400" dirty="0" err="1">
-                <a:solidFill>
-                  <a:sysClr val="windowText" lastClr="000000"/>
-                </a:solidFill>
-                <a:latin typeface="Abadi" panose="020B0604020104020204" pitchFamily="34" charset="0"/>
-              </a:rPr>
-              <a:t>cryptics</a:t>
-            </a:r>
-            <a:endParaRPr lang="en-US" sz="1400" dirty="0">
-              <a:solidFill>
-                <a:sysClr val="windowText" lastClr="000000"/>
-              </a:solidFill>
-              <a:latin typeface="Abadi" panose="020B0604020104020204" pitchFamily="34" charset="0"/>
-            </a:endParaRPr>
-          </a:p>
-        </p:txBody>
-      </p:sp>
-      <p:sp>
-        <p:nvSpPr>
-          <p:cNvPr id="8" name="Rectangle 7">
-            <a:extLst>
-              <a:ext uri="{FF2B5EF4-FFF2-40B4-BE49-F238E27FC236}">
-                <a16:creationId xmlns:a16="http://schemas.microsoft.com/office/drawing/2014/main" id="{A32F0223-9EAB-1B55-C4B8-90BD5A9F1ABD}"/>
-              </a:ext>
-            </a:extLst>
-          </p:cNvPr>
-          <p:cNvSpPr/>
-          <p:nvPr/>
-        </p:nvSpPr>
-        <p:spPr>
-          <a:xfrm>
-            <a:off x="2127250" y="421541"/>
-            <a:ext cx="2603500" cy="393700"/>
-          </a:xfrm>
-          <a:prstGeom prst="rect">
-            <a:avLst/>
-          </a:prstGeom>
-          <a:ln w="19050">
-            <a:solidFill>
-              <a:schemeClr val="tx1"/>
-            </a:solidFill>
-          </a:ln>
-        </p:spPr>
-        <p:style>
-          <a:lnRef idx="2">
-            <a:schemeClr val="accent1"/>
-          </a:lnRef>
-          <a:fillRef idx="1">
-            <a:schemeClr val="lt1"/>
-          </a:fillRef>
-          <a:effectRef idx="0">
-            <a:schemeClr val="accent1"/>
-          </a:effectRef>
-          <a:fontRef idx="minor">
-            <a:schemeClr val="dk1"/>
-          </a:fontRef>
-        </p:style>
-        <p:txBody>
-          <a:bodyPr rtlCol="0" anchor="ctr"/>
-          <a:lstStyle/>
-          <a:p>
-            <a:pPr algn="ctr"/>
-            <a:r>
-              <a:rPr lang="en-US" b="1" dirty="0" err="1">
-                <a:latin typeface="Raleway" pitchFamily="2" charset="0"/>
-                <a:cs typeface="Posterama" panose="020B0504020200020000" pitchFamily="34" charset="0"/>
-              </a:rPr>
-              <a:t>SpliceAI</a:t>
-            </a:r>
-            <a:endParaRPr lang="en-GB" b="1" dirty="0">
-              <a:latin typeface="Raleway" pitchFamily="2" charset="0"/>
-              <a:cs typeface="Posterama" panose="020B0504020200020000" pitchFamily="34" charset="0"/>
-            </a:endParaRPr>
-          </a:p>
-        </p:txBody>
-      </p:sp>
-      <p:sp>
-        <p:nvSpPr>
-          <p:cNvPr id="10" name="Rectangle 9">
-            <a:extLst>
-              <a:ext uri="{FF2B5EF4-FFF2-40B4-BE49-F238E27FC236}">
-                <a16:creationId xmlns:a16="http://schemas.microsoft.com/office/drawing/2014/main" id="{3258C80A-D7BA-B1DC-3A6A-28477E98B595}"/>
-              </a:ext>
-            </a:extLst>
-          </p:cNvPr>
-          <p:cNvSpPr/>
-          <p:nvPr/>
-        </p:nvSpPr>
-        <p:spPr>
-          <a:xfrm>
-            <a:off x="2127250" y="3946979"/>
-            <a:ext cx="2603500" cy="393700"/>
-          </a:xfrm>
-          <a:prstGeom prst="rect">
-            <a:avLst/>
-          </a:prstGeom>
-          <a:ln w="19050">
-            <a:solidFill>
-              <a:schemeClr val="tx1"/>
-            </a:solidFill>
-          </a:ln>
-        </p:spPr>
-        <p:style>
-          <a:lnRef idx="2">
-            <a:schemeClr val="accent1"/>
-          </a:lnRef>
-          <a:fillRef idx="1">
-            <a:schemeClr val="lt1"/>
-          </a:fillRef>
-          <a:effectRef idx="0">
-            <a:schemeClr val="accent1"/>
-          </a:effectRef>
-          <a:fontRef idx="minor">
-            <a:schemeClr val="dk1"/>
-          </a:fontRef>
-        </p:style>
-        <p:txBody>
-          <a:bodyPr rtlCol="0" anchor="ctr"/>
-          <a:lstStyle/>
-          <a:p>
-            <a:pPr algn="ctr"/>
-            <a:r>
-              <a:rPr lang="en-US" b="1" dirty="0">
-                <a:latin typeface="Raleway" pitchFamily="2" charset="0"/>
-                <a:cs typeface="Posterama" panose="020B0504020200020000" pitchFamily="34" charset="0"/>
-              </a:rPr>
-              <a:t>Bedtools intersect</a:t>
-            </a:r>
-            <a:endParaRPr lang="en-GB" b="1" dirty="0">
-              <a:latin typeface="Raleway" pitchFamily="2" charset="0"/>
-              <a:cs typeface="Posterama" panose="020B0504020200020000" pitchFamily="34" charset="0"/>
-            </a:endParaRPr>
-          </a:p>
-        </p:txBody>
-      </p:sp>
-      <p:sp>
-        <p:nvSpPr>
-          <p:cNvPr id="20" name="Rectangle 19">
-            <a:extLst>
-              <a:ext uri="{FF2B5EF4-FFF2-40B4-BE49-F238E27FC236}">
-                <a16:creationId xmlns:a16="http://schemas.microsoft.com/office/drawing/2014/main" id="{A62C851E-9F51-FD47-A220-F6AF5F60A9C4}"/>
-              </a:ext>
-            </a:extLst>
-          </p:cNvPr>
-          <p:cNvSpPr/>
-          <p:nvPr/>
-        </p:nvSpPr>
-        <p:spPr>
-          <a:xfrm>
-            <a:off x="694592" y="2369514"/>
-            <a:ext cx="5468816" cy="1280258"/>
-          </a:xfrm>
-          <a:prstGeom prst="rect">
-            <a:avLst/>
-          </a:prstGeom>
-          <a:solidFill>
-            <a:schemeClr val="accent1">
-              <a:lumMod val="40000"/>
-              <a:lumOff val="60000"/>
-            </a:schemeClr>
-          </a:solidFill>
-        </p:spPr>
-        <p:style>
-          <a:lnRef idx="2">
-            <a:schemeClr val="accent1">
-              <a:shade val="15000"/>
-            </a:schemeClr>
-          </a:lnRef>
-          <a:fillRef idx="1">
-            <a:schemeClr val="accent1"/>
-          </a:fillRef>
-          <a:effectRef idx="0">
-            <a:schemeClr val="accent1"/>
-          </a:effectRef>
-          <a:fontRef idx="minor">
-            <a:schemeClr val="lt1"/>
-          </a:fontRef>
-        </p:style>
-        <p:txBody>
-          <a:bodyPr rtlCol="0" anchor="ctr"/>
-          <a:lstStyle/>
-          <a:p>
-            <a:pPr algn="ctr"/>
-            <a:r>
-              <a:rPr lang="en-US" sz="1600" dirty="0">
-                <a:solidFill>
-                  <a:sysClr val="windowText" lastClr="000000"/>
-                </a:solidFill>
-                <a:latin typeface="Abadi" panose="020B0604020104020204" pitchFamily="34" charset="0"/>
-              </a:rPr>
-              <a:t>Using </a:t>
-            </a:r>
-            <a:r>
-              <a:rPr lang="en-US" sz="1600" dirty="0" err="1">
-                <a:solidFill>
-                  <a:sysClr val="windowText" lastClr="000000"/>
-                </a:solidFill>
-                <a:latin typeface="Abadi" panose="020B0604020104020204" pitchFamily="34" charset="0"/>
-              </a:rPr>
-              <a:t>GRanges</a:t>
-            </a:r>
-            <a:r>
-              <a:rPr lang="en-US" sz="1600" dirty="0">
-                <a:solidFill>
-                  <a:sysClr val="windowText" lastClr="000000"/>
-                </a:solidFill>
-                <a:latin typeface="Abadi" panose="020B0604020104020204" pitchFamily="34" charset="0"/>
-              </a:rPr>
-              <a:t>, keep only “</a:t>
-            </a:r>
-            <a:r>
-              <a:rPr lang="en-US" sz="1600" dirty="0" err="1">
-                <a:solidFill>
-                  <a:sysClr val="windowText" lastClr="000000"/>
-                </a:solidFill>
-                <a:latin typeface="Abadi" panose="020B0604020104020204" pitchFamily="34" charset="0"/>
-              </a:rPr>
-              <a:t>protein_coding</a:t>
-            </a:r>
-            <a:r>
-              <a:rPr lang="en-US" sz="1600" dirty="0">
-                <a:solidFill>
-                  <a:sysClr val="windowText" lastClr="000000"/>
-                </a:solidFill>
-                <a:latin typeface="Abadi" panose="020B0604020104020204" pitchFamily="34" charset="0"/>
-              </a:rPr>
-              <a:t>” regions in Gencode.v49.annotation.gtf</a:t>
-            </a:r>
-          </a:p>
-          <a:p>
-            <a:pPr algn="ctr"/>
-            <a:r>
-              <a:rPr lang="en-US" sz="1600" dirty="0">
-                <a:solidFill>
-                  <a:sysClr val="windowText" lastClr="000000"/>
-                </a:solidFill>
-                <a:latin typeface="Abadi" panose="020B0604020104020204" pitchFamily="34" charset="0"/>
-              </a:rPr>
-              <a:t>* Predicted splice sites</a:t>
-            </a:r>
-          </a:p>
-        </p:txBody>
-      </p:sp>
-      <p:sp>
-        <p:nvSpPr>
-          <p:cNvPr id="22" name="Rectangle 21">
-            <a:extLst>
-              <a:ext uri="{FF2B5EF4-FFF2-40B4-BE49-F238E27FC236}">
-                <a16:creationId xmlns:a16="http://schemas.microsoft.com/office/drawing/2014/main" id="{9EF06EE5-AF03-3D0F-E200-390864EB9EBA}"/>
-              </a:ext>
-            </a:extLst>
-          </p:cNvPr>
-          <p:cNvSpPr/>
-          <p:nvPr/>
-        </p:nvSpPr>
-        <p:spPr>
-          <a:xfrm>
-            <a:off x="694592" y="10440381"/>
-            <a:ext cx="5468816" cy="1519390"/>
-          </a:xfrm>
-          <a:prstGeom prst="rect">
-            <a:avLst/>
-          </a:prstGeom>
-          <a:solidFill>
-            <a:schemeClr val="accent1">
-              <a:lumMod val="40000"/>
-              <a:lumOff val="60000"/>
-            </a:schemeClr>
-          </a:solidFill>
-        </p:spPr>
-        <p:style>
-          <a:lnRef idx="2">
-            <a:schemeClr val="accent1">
-              <a:shade val="15000"/>
-            </a:schemeClr>
-          </a:lnRef>
-          <a:fillRef idx="1">
-            <a:schemeClr val="accent1"/>
-          </a:fillRef>
-          <a:effectRef idx="0">
-            <a:schemeClr val="accent1"/>
-          </a:effectRef>
-          <a:fontRef idx="minor">
-            <a:schemeClr val="lt1"/>
-          </a:fontRef>
-        </p:style>
-        <p:txBody>
-          <a:bodyPr rtlCol="0" anchor="ctr"/>
-          <a:lstStyle/>
-          <a:p>
-            <a:pPr algn="ctr"/>
-            <a:r>
-              <a:rPr lang="en-US" sz="1600" dirty="0">
-                <a:solidFill>
-                  <a:sysClr val="windowText" lastClr="000000"/>
-                </a:solidFill>
-                <a:latin typeface="Abadi" panose="020B0604020104020204" pitchFamily="34" charset="0"/>
-              </a:rPr>
-              <a:t>Pull FASTA using BED coordinates with SpliceAI_Inference.py to re-score inferences over a ±24nt window surrounding the loci, filter to &gt; 0.1 Donor Score</a:t>
-            </a:r>
-          </a:p>
-          <a:p>
-            <a:pPr algn="ctr"/>
-            <a:r>
-              <a:rPr lang="en-US" sz="1600" dirty="0">
-                <a:solidFill>
-                  <a:sysClr val="windowText" lastClr="000000"/>
-                </a:solidFill>
-                <a:latin typeface="Abadi" panose="020B0604020104020204" pitchFamily="34" charset="0"/>
-              </a:rPr>
-              <a:t>7022 Predicted Splice Sites</a:t>
-            </a:r>
-          </a:p>
-        </p:txBody>
-      </p:sp>
-      <p:sp>
-        <p:nvSpPr>
-          <p:cNvPr id="24" name="Rectangle 23">
-            <a:extLst>
-              <a:ext uri="{FF2B5EF4-FFF2-40B4-BE49-F238E27FC236}">
-                <a16:creationId xmlns:a16="http://schemas.microsoft.com/office/drawing/2014/main" id="{4D31029C-2849-065F-6921-B5EDD11CF6C5}"/>
-              </a:ext>
-            </a:extLst>
-          </p:cNvPr>
-          <p:cNvSpPr/>
-          <p:nvPr/>
-        </p:nvSpPr>
-        <p:spPr>
-          <a:xfrm>
-            <a:off x="2127250" y="2172664"/>
-            <a:ext cx="2603500" cy="393700"/>
-          </a:xfrm>
-          <a:prstGeom prst="rect">
-            <a:avLst/>
-          </a:prstGeom>
-          <a:ln w="19050">
-            <a:solidFill>
-              <a:schemeClr val="tx1"/>
-            </a:solidFill>
-          </a:ln>
-        </p:spPr>
-        <p:style>
-          <a:lnRef idx="2">
-            <a:schemeClr val="accent1"/>
-          </a:lnRef>
-          <a:fillRef idx="1">
-            <a:schemeClr val="lt1"/>
-          </a:fillRef>
-          <a:effectRef idx="0">
-            <a:schemeClr val="accent1"/>
-          </a:effectRef>
-          <a:fontRef idx="minor">
-            <a:schemeClr val="dk1"/>
-          </a:fontRef>
-        </p:style>
-        <p:txBody>
-          <a:bodyPr rtlCol="0" anchor="ctr"/>
-          <a:lstStyle/>
-          <a:p>
-            <a:pPr algn="ctr"/>
-            <a:r>
-              <a:rPr lang="en-US" b="1" dirty="0">
-                <a:latin typeface="Raleway" pitchFamily="2" charset="0"/>
-                <a:cs typeface="Posterama" panose="020B0504020200020000" pitchFamily="34" charset="0"/>
-              </a:rPr>
-              <a:t>Genomic Ranges</a:t>
-            </a:r>
-            <a:endParaRPr lang="en-GB" b="1" dirty="0">
-              <a:latin typeface="Raleway" pitchFamily="2" charset="0"/>
-              <a:cs typeface="Posterama" panose="020B0504020200020000" pitchFamily="34" charset="0"/>
-            </a:endParaRPr>
-          </a:p>
-        </p:txBody>
-      </p:sp>
-      <p:sp>
-        <p:nvSpPr>
-          <p:cNvPr id="2" name="Right Brace 1">
-            <a:extLst>
-              <a:ext uri="{FF2B5EF4-FFF2-40B4-BE49-F238E27FC236}">
-                <a16:creationId xmlns:a16="http://schemas.microsoft.com/office/drawing/2014/main" id="{F18A3004-090F-26E2-3A54-3E8AB0186268}"/>
-              </a:ext>
-            </a:extLst>
-          </p:cNvPr>
-          <p:cNvSpPr/>
-          <p:nvPr/>
-        </p:nvSpPr>
-        <p:spPr>
-          <a:xfrm>
-            <a:off x="5945663" y="4304668"/>
-            <a:ext cx="300349" cy="3014187"/>
-          </a:xfrm>
-          <a:prstGeom prst="rightBrace">
-            <a:avLst/>
-          </a:prstGeom>
-        </p:spPr>
-        <p:style>
-          <a:lnRef idx="3">
-            <a:schemeClr val="accent1"/>
-          </a:lnRef>
-          <a:fillRef idx="0">
-            <a:schemeClr val="accent1"/>
-          </a:fillRef>
-          <a:effectRef idx="2">
-            <a:schemeClr val="accent1"/>
-          </a:effectRef>
-          <a:fontRef idx="minor">
-            <a:schemeClr val="tx1"/>
-          </a:fontRef>
-        </p:style>
-        <p:txBody>
-          <a:bodyPr rtlCol="0" anchor="ctr"/>
-          <a:lstStyle/>
-          <a:p>
-            <a:pPr algn="ctr"/>
-            <a:endParaRPr lang="en-GB"/>
-          </a:p>
-        </p:txBody>
-      </p:sp>
-      <p:sp>
-        <p:nvSpPr>
-          <p:cNvPr id="26" name="Rectangle 25">
-            <a:extLst>
-              <a:ext uri="{FF2B5EF4-FFF2-40B4-BE49-F238E27FC236}">
-                <a16:creationId xmlns:a16="http://schemas.microsoft.com/office/drawing/2014/main" id="{82A8B043-284B-871C-0F20-AB9A4DE82FA3}"/>
-              </a:ext>
-            </a:extLst>
-          </p:cNvPr>
-          <p:cNvSpPr/>
-          <p:nvPr/>
-        </p:nvSpPr>
-        <p:spPr>
-          <a:xfrm>
-            <a:off x="2127250" y="10243531"/>
-            <a:ext cx="2603500" cy="393700"/>
-          </a:xfrm>
-          <a:prstGeom prst="rect">
-            <a:avLst/>
-          </a:prstGeom>
-          <a:ln w="19050">
-            <a:solidFill>
-              <a:schemeClr val="tx1"/>
-            </a:solidFill>
-          </a:ln>
-        </p:spPr>
-        <p:style>
-          <a:lnRef idx="2">
-            <a:schemeClr val="accent1"/>
-          </a:lnRef>
-          <a:fillRef idx="1">
-            <a:schemeClr val="lt1"/>
-          </a:fillRef>
-          <a:effectRef idx="0">
-            <a:schemeClr val="accent1"/>
-          </a:effectRef>
-          <a:fontRef idx="minor">
-            <a:schemeClr val="dk1"/>
-          </a:fontRef>
-        </p:style>
-        <p:txBody>
-          <a:bodyPr rtlCol="0" anchor="ctr"/>
-          <a:lstStyle/>
-          <a:p>
-            <a:pPr algn="ctr"/>
-            <a:r>
-              <a:rPr lang="en-US" b="1" dirty="0">
-                <a:latin typeface="Raleway" pitchFamily="2" charset="0"/>
-                <a:cs typeface="Posterama" panose="020B0504020200020000" pitchFamily="34" charset="0"/>
-              </a:rPr>
-              <a:t>Rescore locus</a:t>
-            </a:r>
-            <a:endParaRPr lang="en-GB" b="1" dirty="0">
-              <a:latin typeface="Raleway" pitchFamily="2" charset="0"/>
-              <a:cs typeface="Posterama" panose="020B0504020200020000" pitchFamily="34" charset="0"/>
-            </a:endParaRPr>
-          </a:p>
-        </p:txBody>
-      </p:sp>
-      <p:sp>
-        <p:nvSpPr>
-          <p:cNvPr id="12" name="Oval 11">
-            <a:extLst>
-              <a:ext uri="{FF2B5EF4-FFF2-40B4-BE49-F238E27FC236}">
-                <a16:creationId xmlns:a16="http://schemas.microsoft.com/office/drawing/2014/main" id="{84A3C5B3-0E4E-58AA-3355-3552F2F1365C}"/>
-              </a:ext>
-            </a:extLst>
-          </p:cNvPr>
-          <p:cNvSpPr/>
-          <p:nvPr/>
-        </p:nvSpPr>
-        <p:spPr>
-          <a:xfrm>
-            <a:off x="6030438" y="5564112"/>
-            <a:ext cx="508000" cy="495300"/>
-          </a:xfrm>
-          <a:prstGeom prst="ellipse">
-            <a:avLst/>
-          </a:prstGeom>
-        </p:spPr>
-        <p:style>
-          <a:lnRef idx="2">
-            <a:schemeClr val="accent1"/>
-          </a:lnRef>
-          <a:fillRef idx="1">
-            <a:schemeClr val="lt1"/>
-          </a:fillRef>
-          <a:effectRef idx="0">
-            <a:schemeClr val="accent1"/>
-          </a:effectRef>
-          <a:fontRef idx="minor">
-            <a:schemeClr val="dk1"/>
-          </a:fontRef>
-        </p:style>
-        <p:txBody>
-          <a:bodyPr rtlCol="0" anchor="ctr"/>
-          <a:lstStyle/>
-          <a:p>
-            <a:pPr algn="ctr"/>
-            <a:r>
-              <a:rPr lang="en-US" sz="1400" dirty="0"/>
-              <a:t>-b</a:t>
-            </a:r>
-            <a:endParaRPr lang="en-GB" sz="1400" dirty="0"/>
-          </a:p>
-        </p:txBody>
-      </p:sp>
-      <p:pic>
-        <p:nvPicPr>
-          <p:cNvPr id="6" name="Picture 5">
-            <a:extLst>
-              <a:ext uri="{FF2B5EF4-FFF2-40B4-BE49-F238E27FC236}">
-                <a16:creationId xmlns:a16="http://schemas.microsoft.com/office/drawing/2014/main" id="{9FB30D7F-2777-4174-C8AB-D0DE9459BC7E}"/>
-              </a:ext>
-            </a:extLst>
-          </p:cNvPr>
-          <p:cNvPicPr>
-            <a:picLocks noChangeAspect="1"/>
-          </p:cNvPicPr>
-          <p:nvPr/>
-        </p:nvPicPr>
-        <p:blipFill>
-          <a:blip r:embed="rId2"/>
-          <a:srcRect t="24837" r="20597"/>
-          <a:stretch>
-            <a:fillRect/>
-          </a:stretch>
-        </p:blipFill>
-        <p:spPr>
-          <a:xfrm>
-            <a:off x="402166" y="5403328"/>
-            <a:ext cx="5708780" cy="2855747"/>
-          </a:xfrm>
-          <a:prstGeom prst="rect">
-            <a:avLst/>
-          </a:prstGeom>
-          <a:ln w="19050">
-            <a:solidFill>
-              <a:schemeClr val="tx1"/>
-            </a:solidFill>
-          </a:ln>
-        </p:spPr>
-      </p:pic>
-      <p:cxnSp>
-        <p:nvCxnSpPr>
-          <p:cNvPr id="11" name="Straight Arrow Connector 10">
-            <a:extLst>
-              <a:ext uri="{FF2B5EF4-FFF2-40B4-BE49-F238E27FC236}">
-                <a16:creationId xmlns:a16="http://schemas.microsoft.com/office/drawing/2014/main" id="{5E99D58F-D8A1-36D1-08B2-D4B2D1CF4EA6}"/>
+                <a16:creationId xmlns:a16="http://schemas.microsoft.com/office/drawing/2014/main" id="{DF910A35-7BFA-EFD1-C33D-01B9AE8E57B2}"/>
               </a:ext>
             </a:extLst>
           </p:cNvPr>
@@ -7929,8 +6861,8 @@
         </p:nvCxnSpPr>
         <p:spPr>
           <a:xfrm>
-            <a:off x="3971925" y="5403328"/>
-            <a:ext cx="457200" cy="892697"/>
+            <a:off x="2328474" y="7866868"/>
+            <a:ext cx="829611" cy="2211765"/>
           </a:xfrm>
           <a:prstGeom prst="straightConnector1">
             <a:avLst/>
@@ -7954,2342 +6886,6 @@
           </a:fontRef>
         </p:style>
       </p:cxnSp>
-      <p:cxnSp>
-        <p:nvCxnSpPr>
-          <p:cNvPr id="14" name="Straight Arrow Connector 13">
-            <a:extLst>
-              <a:ext uri="{FF2B5EF4-FFF2-40B4-BE49-F238E27FC236}">
-                <a16:creationId xmlns:a16="http://schemas.microsoft.com/office/drawing/2014/main" id="{9159153F-C10D-2CF6-4421-32D3C2D17193}"/>
-              </a:ext>
-            </a:extLst>
-          </p:cNvPr>
-          <p:cNvCxnSpPr>
-            <a:cxnSpLocks/>
-          </p:cNvCxnSpPr>
-          <p:nvPr/>
-        </p:nvCxnSpPr>
-        <p:spPr>
-          <a:xfrm>
-            <a:off x="4452938" y="6767513"/>
-            <a:ext cx="0" cy="1382185"/>
-          </a:xfrm>
-          <a:prstGeom prst="straightConnector1">
-            <a:avLst/>
-          </a:prstGeom>
-          <a:ln>
-            <a:tailEnd type="triangle"/>
-          </a:ln>
-        </p:spPr>
-        <p:style>
-          <a:lnRef idx="3">
-            <a:schemeClr val="accent1"/>
-          </a:lnRef>
-          <a:fillRef idx="0">
-            <a:schemeClr val="accent1"/>
-          </a:fillRef>
-          <a:effectRef idx="2">
-            <a:schemeClr val="accent1"/>
-          </a:effectRef>
-          <a:fontRef idx="minor">
-            <a:schemeClr val="tx1"/>
-          </a:fontRef>
-        </p:style>
-      </p:cxnSp>
-      <p:sp>
-        <p:nvSpPr>
-          <p:cNvPr id="3" name="TextBox 2">
-            <a:extLst>
-              <a:ext uri="{FF2B5EF4-FFF2-40B4-BE49-F238E27FC236}">
-                <a16:creationId xmlns:a16="http://schemas.microsoft.com/office/drawing/2014/main" id="{23254414-C9FD-7817-C8C3-17BE8AC59B65}"/>
-              </a:ext>
-            </a:extLst>
-          </p:cNvPr>
-          <p:cNvSpPr txBox="1"/>
-          <p:nvPr/>
-        </p:nvSpPr>
-        <p:spPr>
-          <a:xfrm>
-            <a:off x="0" y="0"/>
-            <a:ext cx="2127250" cy="523220"/>
-          </a:xfrm>
-          <a:prstGeom prst="rect">
-            <a:avLst/>
-          </a:prstGeom>
-          <a:noFill/>
-        </p:spPr>
-        <p:txBody>
-          <a:bodyPr wrap="square" rtlCol="0">
-            <a:spAutoFit/>
-          </a:bodyPr>
-          <a:lstStyle/>
-          <a:p>
-            <a:r>
-              <a:rPr lang="en-US" sz="2800" dirty="0"/>
-              <a:t>CURRENT</a:t>
-            </a:r>
-            <a:endParaRPr lang="en-GB" sz="2800" dirty="0"/>
-          </a:p>
-        </p:txBody>
-      </p:sp>
-    </p:spTree>
-    <p:extLst>
-      <p:ext uri="{BB962C8B-B14F-4D97-AF65-F5344CB8AC3E}">
-        <p14:creationId xmlns:p14="http://schemas.microsoft.com/office/powerpoint/2010/main" val="72113033"/>
-      </p:ext>
-    </p:extLst>
-  </p:cSld>
-  <p:clrMapOvr>
-    <a:masterClrMapping/>
-  </p:clrMapOvr>
-</p:sld>
-</file>
-
-<file path=ppt/slides/slide2.xml><?xml version="1.0" encoding="utf-8"?>
-<p:sld xmlns:a="http://schemas.openxmlformats.org/drawingml/2006/main" xmlns:r="http://schemas.openxmlformats.org/officeDocument/2006/relationships" xmlns:p="http://schemas.openxmlformats.org/presentationml/2006/main">
-  <p:cSld>
-    <p:spTree>
-      <p:nvGrpSpPr>
-        <p:cNvPr id="1" name="">
-          <a:extLst>
-            <a:ext uri="{FF2B5EF4-FFF2-40B4-BE49-F238E27FC236}">
-              <a16:creationId xmlns:a16="http://schemas.microsoft.com/office/drawing/2014/main" id="{7E346146-B82F-C9BA-9347-5B1D9E5F6438}"/>
-            </a:ext>
-          </a:extLst>
-        </p:cNvPr>
-        <p:cNvGrpSpPr/>
-        <p:nvPr/>
-      </p:nvGrpSpPr>
-      <p:grpSpPr>
-        <a:xfrm>
-          <a:off x="0" y="0"/>
-          <a:ext cx="0" cy="0"/>
-          <a:chOff x="0" y="0"/>
-          <a:chExt cx="0" cy="0"/>
-        </a:xfrm>
-      </p:grpSpPr>
-      <p:cxnSp>
-        <p:nvCxnSpPr>
-          <p:cNvPr id="50" name="Straight Arrow Connector 49">
-            <a:extLst>
-              <a:ext uri="{FF2B5EF4-FFF2-40B4-BE49-F238E27FC236}">
-                <a16:creationId xmlns:a16="http://schemas.microsoft.com/office/drawing/2014/main" id="{81F23D2E-2079-4704-8564-AA968031C0D2}"/>
-              </a:ext>
-            </a:extLst>
-          </p:cNvPr>
-          <p:cNvCxnSpPr>
-            <a:cxnSpLocks/>
-          </p:cNvCxnSpPr>
-          <p:nvPr/>
-        </p:nvCxnSpPr>
-        <p:spPr>
-          <a:xfrm>
-            <a:off x="1133475" y="9953343"/>
-            <a:ext cx="3193248" cy="1351291"/>
-          </a:xfrm>
-          <a:prstGeom prst="straightConnector1">
-            <a:avLst/>
-          </a:prstGeom>
-          <a:ln>
-            <a:tailEnd type="triangle"/>
-          </a:ln>
-        </p:spPr>
-        <p:style>
-          <a:lnRef idx="3">
-            <a:schemeClr val="accent1"/>
-          </a:lnRef>
-          <a:fillRef idx="0">
-            <a:schemeClr val="accent1"/>
-          </a:fillRef>
-          <a:effectRef idx="2">
-            <a:schemeClr val="accent1"/>
-          </a:effectRef>
-          <a:fontRef idx="minor">
-            <a:schemeClr val="tx1"/>
-          </a:fontRef>
-        </p:style>
-      </p:cxnSp>
-      <p:sp>
-        <p:nvSpPr>
-          <p:cNvPr id="4" name="Rectangle 3">
-            <a:extLst>
-              <a:ext uri="{FF2B5EF4-FFF2-40B4-BE49-F238E27FC236}">
-                <a16:creationId xmlns:a16="http://schemas.microsoft.com/office/drawing/2014/main" id="{F36FDDD2-8D43-A135-5329-ED20464B5E0F}"/>
-              </a:ext>
-            </a:extLst>
-          </p:cNvPr>
-          <p:cNvSpPr/>
-          <p:nvPr/>
-        </p:nvSpPr>
-        <p:spPr>
-          <a:xfrm>
-            <a:off x="694592" y="618391"/>
-            <a:ext cx="5468816" cy="1014525"/>
-          </a:xfrm>
-          <a:prstGeom prst="rect">
-            <a:avLst/>
-          </a:prstGeom>
-          <a:solidFill>
-            <a:schemeClr val="accent1">
-              <a:lumMod val="40000"/>
-              <a:lumOff val="60000"/>
-            </a:schemeClr>
-          </a:solidFill>
-        </p:spPr>
-        <p:style>
-          <a:lnRef idx="2">
-            <a:schemeClr val="accent1">
-              <a:shade val="15000"/>
-            </a:schemeClr>
-          </a:lnRef>
-          <a:fillRef idx="1">
-            <a:schemeClr val="accent1"/>
-          </a:fillRef>
-          <a:effectRef idx="0">
-            <a:schemeClr val="accent1"/>
-          </a:effectRef>
-          <a:fontRef idx="minor">
-            <a:schemeClr val="lt1"/>
-          </a:fontRef>
-        </p:style>
-        <p:txBody>
-          <a:bodyPr rtlCol="0" anchor="ctr"/>
-          <a:lstStyle/>
-          <a:p>
-            <a:pPr algn="ctr"/>
-            <a:r>
-              <a:rPr lang="en-US" sz="1400" dirty="0" err="1">
-                <a:solidFill>
-                  <a:sysClr val="windowText" lastClr="000000"/>
-                </a:solidFill>
-                <a:latin typeface="Abadi" panose="020B0604020104020204" pitchFamily="34" charset="0"/>
-              </a:rPr>
-              <a:t>SpliceAI</a:t>
-            </a:r>
-            <a:r>
-              <a:rPr lang="en-US" sz="1400" dirty="0">
-                <a:solidFill>
-                  <a:sysClr val="windowText" lastClr="000000"/>
-                </a:solidFill>
-                <a:latin typeface="Abadi" panose="020B0604020104020204" pitchFamily="34" charset="0"/>
-              </a:rPr>
-              <a:t> inferences generated across whole introns and filtered to remove signal below 0.05</a:t>
-            </a:r>
-          </a:p>
-          <a:p>
-            <a:pPr algn="ctr"/>
-            <a:r>
-              <a:rPr lang="en-US" sz="1400" dirty="0">
-                <a:solidFill>
-                  <a:sysClr val="windowText" lastClr="000000"/>
-                </a:solidFill>
-                <a:latin typeface="Abadi" panose="020B0604020104020204" pitchFamily="34" charset="0"/>
-              </a:rPr>
-              <a:t>794,192 splice site inferences</a:t>
-            </a:r>
-            <a:endParaRPr lang="en-GB" sz="1400" dirty="0">
-              <a:solidFill>
-                <a:sysClr val="windowText" lastClr="000000"/>
-              </a:solidFill>
-              <a:latin typeface="Abadi" panose="020B0604020104020204" pitchFamily="34" charset="0"/>
-            </a:endParaRPr>
-          </a:p>
-        </p:txBody>
-      </p:sp>
-      <p:sp>
-        <p:nvSpPr>
-          <p:cNvPr id="7" name="Rectangle 6">
-            <a:extLst>
-              <a:ext uri="{FF2B5EF4-FFF2-40B4-BE49-F238E27FC236}">
-                <a16:creationId xmlns:a16="http://schemas.microsoft.com/office/drawing/2014/main" id="{01EF1563-0C33-BE4B-F0E6-CE5448F4BE4F}"/>
-              </a:ext>
-            </a:extLst>
-          </p:cNvPr>
-          <p:cNvSpPr/>
-          <p:nvPr/>
-        </p:nvSpPr>
-        <p:spPr>
-          <a:xfrm>
-            <a:off x="694592" y="3464631"/>
-            <a:ext cx="5468816" cy="1015181"/>
-          </a:xfrm>
-          <a:prstGeom prst="rect">
-            <a:avLst/>
-          </a:prstGeom>
-          <a:solidFill>
-            <a:schemeClr val="accent1">
-              <a:lumMod val="40000"/>
-              <a:lumOff val="60000"/>
-            </a:schemeClr>
-          </a:solidFill>
-        </p:spPr>
-        <p:style>
-          <a:lnRef idx="2">
-            <a:schemeClr val="accent1">
-              <a:shade val="15000"/>
-            </a:schemeClr>
-          </a:lnRef>
-          <a:fillRef idx="1">
-            <a:schemeClr val="accent1"/>
-          </a:fillRef>
-          <a:effectRef idx="0">
-            <a:schemeClr val="accent1"/>
-          </a:effectRef>
-          <a:fontRef idx="minor">
-            <a:schemeClr val="lt1"/>
-          </a:fontRef>
-        </p:style>
-        <p:txBody>
-          <a:bodyPr rtlCol="0" anchor="ctr"/>
-          <a:lstStyle/>
-          <a:p>
-            <a:pPr algn="ctr"/>
-            <a:r>
-              <a:rPr lang="en-US" sz="1400" dirty="0">
-                <a:solidFill>
-                  <a:sysClr val="windowText" lastClr="000000"/>
-                </a:solidFill>
-                <a:latin typeface="Abadi" panose="020B0604020104020204" pitchFamily="34" charset="0"/>
-              </a:rPr>
-              <a:t>Create a new exonic bed to filter splice sites within 100 bp of exon boundaries</a:t>
-            </a:r>
-          </a:p>
-          <a:p>
-            <a:pPr algn="ctr"/>
-            <a:r>
-              <a:rPr lang="en-US" sz="1400" dirty="0">
-                <a:solidFill>
-                  <a:schemeClr val="accent1"/>
-                </a:solidFill>
-                <a:latin typeface="Abadi" panose="020B0604020104020204" pitchFamily="34" charset="0"/>
-              </a:rPr>
-              <a:t>50nt_exonic_loci.bed</a:t>
-            </a:r>
-          </a:p>
-        </p:txBody>
-      </p:sp>
-      <p:sp>
-        <p:nvSpPr>
-          <p:cNvPr id="8" name="Rectangle 7">
-            <a:extLst>
-              <a:ext uri="{FF2B5EF4-FFF2-40B4-BE49-F238E27FC236}">
-                <a16:creationId xmlns:a16="http://schemas.microsoft.com/office/drawing/2014/main" id="{855B8832-A681-E024-AF34-09BED346DF87}"/>
-              </a:ext>
-            </a:extLst>
-          </p:cNvPr>
-          <p:cNvSpPr/>
-          <p:nvPr/>
-        </p:nvSpPr>
-        <p:spPr>
-          <a:xfrm>
-            <a:off x="2127250" y="421541"/>
-            <a:ext cx="2603500" cy="393700"/>
-          </a:xfrm>
-          <a:prstGeom prst="rect">
-            <a:avLst/>
-          </a:prstGeom>
-          <a:ln w="19050">
-            <a:solidFill>
-              <a:schemeClr val="tx1"/>
-            </a:solidFill>
-          </a:ln>
-        </p:spPr>
-        <p:style>
-          <a:lnRef idx="2">
-            <a:schemeClr val="accent1"/>
-          </a:lnRef>
-          <a:fillRef idx="1">
-            <a:schemeClr val="lt1"/>
-          </a:fillRef>
-          <a:effectRef idx="0">
-            <a:schemeClr val="accent1"/>
-          </a:effectRef>
-          <a:fontRef idx="minor">
-            <a:schemeClr val="dk1"/>
-          </a:fontRef>
-        </p:style>
-        <p:txBody>
-          <a:bodyPr rtlCol="0" anchor="ctr"/>
-          <a:lstStyle/>
-          <a:p>
-            <a:pPr algn="ctr"/>
-            <a:r>
-              <a:rPr lang="en-US" b="1" dirty="0" err="1">
-                <a:latin typeface="Raleway" pitchFamily="2" charset="0"/>
-                <a:cs typeface="Posterama" panose="020B0504020200020000" pitchFamily="34" charset="0"/>
-              </a:rPr>
-              <a:t>SpliceAI</a:t>
-            </a:r>
-            <a:endParaRPr lang="en-GB" b="1" dirty="0">
-              <a:latin typeface="Raleway" pitchFamily="2" charset="0"/>
-              <a:cs typeface="Posterama" panose="020B0504020200020000" pitchFamily="34" charset="0"/>
-            </a:endParaRPr>
-          </a:p>
-        </p:txBody>
-      </p:sp>
-      <p:sp>
-        <p:nvSpPr>
-          <p:cNvPr id="20" name="Rectangle 19">
-            <a:extLst>
-              <a:ext uri="{FF2B5EF4-FFF2-40B4-BE49-F238E27FC236}">
-                <a16:creationId xmlns:a16="http://schemas.microsoft.com/office/drawing/2014/main" id="{827BB162-2D86-44A6-4FAC-AF1178C52E17}"/>
-              </a:ext>
-            </a:extLst>
-          </p:cNvPr>
-          <p:cNvSpPr/>
-          <p:nvPr/>
-        </p:nvSpPr>
-        <p:spPr>
-          <a:xfrm>
-            <a:off x="694592" y="1975814"/>
-            <a:ext cx="5468816" cy="1130298"/>
-          </a:xfrm>
-          <a:prstGeom prst="rect">
-            <a:avLst/>
-          </a:prstGeom>
-          <a:solidFill>
-            <a:schemeClr val="accent1">
-              <a:lumMod val="40000"/>
-              <a:lumOff val="60000"/>
-            </a:schemeClr>
-          </a:solidFill>
-        </p:spPr>
-        <p:style>
-          <a:lnRef idx="2">
-            <a:schemeClr val="accent1">
-              <a:shade val="15000"/>
-            </a:schemeClr>
-          </a:lnRef>
-          <a:fillRef idx="1">
-            <a:schemeClr val="accent1"/>
-          </a:fillRef>
-          <a:effectRef idx="0">
-            <a:schemeClr val="accent1"/>
-          </a:effectRef>
-          <a:fontRef idx="minor">
-            <a:schemeClr val="lt1"/>
-          </a:fontRef>
-        </p:style>
-        <p:txBody>
-          <a:bodyPr rtlCol="0" anchor="ctr"/>
-          <a:lstStyle/>
-          <a:p>
-            <a:pPr algn="ctr"/>
-            <a:r>
-              <a:rPr lang="en-US" sz="1400" dirty="0">
-                <a:solidFill>
-                  <a:sysClr val="windowText" lastClr="000000"/>
-                </a:solidFill>
-                <a:latin typeface="Abadi" panose="020B0604020104020204" pitchFamily="34" charset="0"/>
-              </a:rPr>
-              <a:t>Using </a:t>
-            </a:r>
-            <a:r>
-              <a:rPr lang="en-US" sz="1400" dirty="0" err="1">
-                <a:solidFill>
-                  <a:sysClr val="windowText" lastClr="000000"/>
-                </a:solidFill>
-                <a:latin typeface="Abadi" panose="020B0604020104020204" pitchFamily="34" charset="0"/>
-              </a:rPr>
-              <a:t>GRanges</a:t>
-            </a:r>
-            <a:r>
-              <a:rPr lang="en-US" sz="1400" dirty="0">
-                <a:solidFill>
-                  <a:sysClr val="windowText" lastClr="000000"/>
-                </a:solidFill>
-                <a:latin typeface="Abadi" panose="020B0604020104020204" pitchFamily="34" charset="0"/>
-              </a:rPr>
-              <a:t>, keep only “</a:t>
-            </a:r>
-            <a:r>
-              <a:rPr lang="en-US" sz="1400" dirty="0" err="1">
-                <a:solidFill>
-                  <a:sysClr val="windowText" lastClr="000000"/>
-                </a:solidFill>
-                <a:latin typeface="Abadi" panose="020B0604020104020204" pitchFamily="34" charset="0"/>
-              </a:rPr>
-              <a:t>protein_coding</a:t>
-            </a:r>
-            <a:r>
-              <a:rPr lang="en-US" sz="1400" dirty="0">
-                <a:solidFill>
-                  <a:sysClr val="windowText" lastClr="000000"/>
-                </a:solidFill>
-                <a:latin typeface="Abadi" panose="020B0604020104020204" pitchFamily="34" charset="0"/>
-              </a:rPr>
-              <a:t>” regions in Gencode.v49.annotation.gtf</a:t>
-            </a:r>
-          </a:p>
-          <a:p>
-            <a:pPr algn="ctr"/>
-            <a:r>
-              <a:rPr lang="en-US" sz="1400" dirty="0" err="1">
-                <a:solidFill>
-                  <a:schemeClr val="accent1"/>
-                </a:solidFill>
-                <a:latin typeface="Abadi" panose="020B0604020104020204" pitchFamily="34" charset="0"/>
-              </a:rPr>
-              <a:t>Protein_coding_sites.bed</a:t>
-            </a:r>
-            <a:endParaRPr lang="en-US" sz="1400" dirty="0">
-              <a:solidFill>
-                <a:schemeClr val="accent1"/>
-              </a:solidFill>
-              <a:latin typeface="Abadi" panose="020B0604020104020204" pitchFamily="34" charset="0"/>
-            </a:endParaRPr>
-          </a:p>
-        </p:txBody>
-      </p:sp>
-      <p:sp>
-        <p:nvSpPr>
-          <p:cNvPr id="24" name="Rectangle 23">
-            <a:extLst>
-              <a:ext uri="{FF2B5EF4-FFF2-40B4-BE49-F238E27FC236}">
-                <a16:creationId xmlns:a16="http://schemas.microsoft.com/office/drawing/2014/main" id="{B4CD350F-DE7C-600B-2C59-379360BFA161}"/>
-              </a:ext>
-            </a:extLst>
-          </p:cNvPr>
-          <p:cNvSpPr/>
-          <p:nvPr/>
-        </p:nvSpPr>
-        <p:spPr>
-          <a:xfrm>
-            <a:off x="2127250" y="1778964"/>
-            <a:ext cx="2603500" cy="393700"/>
-          </a:xfrm>
-          <a:prstGeom prst="rect">
-            <a:avLst/>
-          </a:prstGeom>
-          <a:ln w="19050">
-            <a:solidFill>
-              <a:schemeClr val="tx1"/>
-            </a:solidFill>
-          </a:ln>
-        </p:spPr>
-        <p:style>
-          <a:lnRef idx="2">
-            <a:schemeClr val="accent1"/>
-          </a:lnRef>
-          <a:fillRef idx="1">
-            <a:schemeClr val="lt1"/>
-          </a:fillRef>
-          <a:effectRef idx="0">
-            <a:schemeClr val="accent1"/>
-          </a:effectRef>
-          <a:fontRef idx="minor">
-            <a:schemeClr val="dk1"/>
-          </a:fontRef>
-        </p:style>
-        <p:txBody>
-          <a:bodyPr rtlCol="0" anchor="ctr"/>
-          <a:lstStyle/>
-          <a:p>
-            <a:pPr algn="ctr"/>
-            <a:r>
-              <a:rPr lang="en-US" b="1" dirty="0">
-                <a:latin typeface="Raleway" pitchFamily="2" charset="0"/>
-                <a:cs typeface="Posterama" panose="020B0504020200020000" pitchFamily="34" charset="0"/>
-              </a:rPr>
-              <a:t>Genomic Ranges</a:t>
-            </a:r>
-            <a:endParaRPr lang="en-GB" b="1" dirty="0">
-              <a:latin typeface="Raleway" pitchFamily="2" charset="0"/>
-              <a:cs typeface="Posterama" panose="020B0504020200020000" pitchFamily="34" charset="0"/>
-            </a:endParaRPr>
-          </a:p>
-        </p:txBody>
-      </p:sp>
-      <p:pic>
-        <p:nvPicPr>
-          <p:cNvPr id="6" name="Picture 5">
-            <a:extLst>
-              <a:ext uri="{FF2B5EF4-FFF2-40B4-BE49-F238E27FC236}">
-                <a16:creationId xmlns:a16="http://schemas.microsoft.com/office/drawing/2014/main" id="{3F9560D4-C02F-4894-8EAD-C2116003F603}"/>
-              </a:ext>
-            </a:extLst>
-          </p:cNvPr>
-          <p:cNvPicPr>
-            <a:picLocks noChangeAspect="1"/>
-          </p:cNvPicPr>
-          <p:nvPr/>
-        </p:nvPicPr>
-        <p:blipFill>
-          <a:blip r:embed="rId2"/>
-          <a:srcRect t="39377" r="20597"/>
-          <a:stretch>
-            <a:fillRect/>
-          </a:stretch>
-        </p:blipFill>
-        <p:spPr>
-          <a:xfrm>
-            <a:off x="574610" y="4838331"/>
-            <a:ext cx="5708780" cy="2303297"/>
-          </a:xfrm>
-          <a:prstGeom prst="rect">
-            <a:avLst/>
-          </a:prstGeom>
-          <a:ln w="19050">
-            <a:solidFill>
-              <a:schemeClr val="tx1"/>
-            </a:solidFill>
-          </a:ln>
-        </p:spPr>
-      </p:pic>
-      <p:cxnSp>
-        <p:nvCxnSpPr>
-          <p:cNvPr id="11" name="Straight Arrow Connector 10">
-            <a:extLst>
-              <a:ext uri="{FF2B5EF4-FFF2-40B4-BE49-F238E27FC236}">
-                <a16:creationId xmlns:a16="http://schemas.microsoft.com/office/drawing/2014/main" id="{88C74F9B-5EE0-B602-61CE-8304D5B4E442}"/>
-              </a:ext>
-            </a:extLst>
-          </p:cNvPr>
-          <p:cNvCxnSpPr>
-            <a:cxnSpLocks/>
-          </p:cNvCxnSpPr>
-          <p:nvPr/>
-        </p:nvCxnSpPr>
-        <p:spPr>
-          <a:xfrm>
-            <a:off x="4326723" y="4301330"/>
-            <a:ext cx="525671" cy="895520"/>
-          </a:xfrm>
-          <a:prstGeom prst="straightConnector1">
-            <a:avLst/>
-          </a:prstGeom>
-          <a:ln>
-            <a:tailEnd type="triangle"/>
-          </a:ln>
-        </p:spPr>
-        <p:style>
-          <a:lnRef idx="3">
-            <a:schemeClr val="accent1"/>
-          </a:lnRef>
-          <a:fillRef idx="0">
-            <a:schemeClr val="accent1"/>
-          </a:fillRef>
-          <a:effectRef idx="2">
-            <a:schemeClr val="accent1"/>
-          </a:effectRef>
-          <a:fontRef idx="minor">
-            <a:schemeClr val="tx1"/>
-          </a:fontRef>
-        </p:style>
-      </p:cxnSp>
-      <p:cxnSp>
-        <p:nvCxnSpPr>
-          <p:cNvPr id="14" name="Straight Arrow Connector 13">
-            <a:extLst>
-              <a:ext uri="{FF2B5EF4-FFF2-40B4-BE49-F238E27FC236}">
-                <a16:creationId xmlns:a16="http://schemas.microsoft.com/office/drawing/2014/main" id="{B939BD0A-E98E-7F5F-546D-DD10B661AE50}"/>
-              </a:ext>
-            </a:extLst>
-          </p:cNvPr>
-          <p:cNvCxnSpPr>
-            <a:cxnSpLocks/>
-          </p:cNvCxnSpPr>
-          <p:nvPr/>
-        </p:nvCxnSpPr>
-        <p:spPr>
-          <a:xfrm>
-            <a:off x="4625382" y="5650066"/>
-            <a:ext cx="0" cy="1382185"/>
-          </a:xfrm>
-          <a:prstGeom prst="straightConnector1">
-            <a:avLst/>
-          </a:prstGeom>
-          <a:ln>
-            <a:tailEnd type="triangle"/>
-          </a:ln>
-        </p:spPr>
-        <p:style>
-          <a:lnRef idx="3">
-            <a:schemeClr val="accent1"/>
-          </a:lnRef>
-          <a:fillRef idx="0">
-            <a:schemeClr val="accent1"/>
-          </a:fillRef>
-          <a:effectRef idx="2">
-            <a:schemeClr val="accent1"/>
-          </a:effectRef>
-          <a:fontRef idx="minor">
-            <a:schemeClr val="tx1"/>
-          </a:fontRef>
-        </p:style>
-      </p:cxnSp>
-      <p:sp>
-        <p:nvSpPr>
-          <p:cNvPr id="3" name="Rectangle 2">
-            <a:extLst>
-              <a:ext uri="{FF2B5EF4-FFF2-40B4-BE49-F238E27FC236}">
-                <a16:creationId xmlns:a16="http://schemas.microsoft.com/office/drawing/2014/main" id="{50C5DF0C-5B73-6093-285E-5B4DE3EA7FBF}"/>
-              </a:ext>
-            </a:extLst>
-          </p:cNvPr>
-          <p:cNvSpPr/>
-          <p:nvPr/>
-        </p:nvSpPr>
-        <p:spPr>
-          <a:xfrm>
-            <a:off x="4852394" y="5296053"/>
-            <a:ext cx="525671" cy="110969"/>
-          </a:xfrm>
-          <a:prstGeom prst="rect">
-            <a:avLst/>
-          </a:prstGeom>
-        </p:spPr>
-        <p:style>
-          <a:lnRef idx="2">
-            <a:schemeClr val="accent1">
-              <a:shade val="15000"/>
-            </a:schemeClr>
-          </a:lnRef>
-          <a:fillRef idx="1">
-            <a:schemeClr val="accent1"/>
-          </a:fillRef>
-          <a:effectRef idx="0">
-            <a:schemeClr val="accent1"/>
-          </a:effectRef>
-          <a:fontRef idx="minor">
-            <a:schemeClr val="lt1"/>
-          </a:fontRef>
-        </p:style>
-        <p:txBody>
-          <a:bodyPr rtlCol="0" anchor="ctr"/>
-          <a:lstStyle/>
-          <a:p>
-            <a:pPr algn="ctr"/>
-            <a:endParaRPr lang="en-GB"/>
-          </a:p>
-        </p:txBody>
-      </p:sp>
-      <p:cxnSp>
-        <p:nvCxnSpPr>
-          <p:cNvPr id="9" name="Straight Arrow Connector 8">
-            <a:extLst>
-              <a:ext uri="{FF2B5EF4-FFF2-40B4-BE49-F238E27FC236}">
-                <a16:creationId xmlns:a16="http://schemas.microsoft.com/office/drawing/2014/main" id="{AD512864-D50D-2AD6-7FBE-43E8FD8FE5D0}"/>
-              </a:ext>
-            </a:extLst>
-          </p:cNvPr>
-          <p:cNvCxnSpPr>
-            <a:cxnSpLocks/>
-          </p:cNvCxnSpPr>
-          <p:nvPr/>
-        </p:nvCxnSpPr>
-        <p:spPr>
-          <a:xfrm>
-            <a:off x="5234982" y="5650066"/>
-            <a:ext cx="0" cy="1382185"/>
-          </a:xfrm>
-          <a:prstGeom prst="straightConnector1">
-            <a:avLst/>
-          </a:prstGeom>
-          <a:ln>
-            <a:tailEnd type="triangle"/>
-          </a:ln>
-        </p:spPr>
-        <p:style>
-          <a:lnRef idx="3">
-            <a:schemeClr val="accent1"/>
-          </a:lnRef>
-          <a:fillRef idx="0">
-            <a:schemeClr val="accent1"/>
-          </a:fillRef>
-          <a:effectRef idx="2">
-            <a:schemeClr val="accent1"/>
-          </a:effectRef>
-          <a:fontRef idx="minor">
-            <a:schemeClr val="tx1"/>
-          </a:fontRef>
-        </p:style>
-      </p:cxnSp>
-      <p:sp>
-        <p:nvSpPr>
-          <p:cNvPr id="16" name="Rectangle 15">
-            <a:extLst>
-              <a:ext uri="{FF2B5EF4-FFF2-40B4-BE49-F238E27FC236}">
-                <a16:creationId xmlns:a16="http://schemas.microsoft.com/office/drawing/2014/main" id="{1A203446-C53A-CA4E-ED61-017C4703609F}"/>
-              </a:ext>
-            </a:extLst>
-          </p:cNvPr>
-          <p:cNvSpPr/>
-          <p:nvPr/>
-        </p:nvSpPr>
-        <p:spPr>
-          <a:xfrm>
-            <a:off x="114297" y="7537530"/>
-            <a:ext cx="6619875" cy="909119"/>
-          </a:xfrm>
-          <a:prstGeom prst="rect">
-            <a:avLst/>
-          </a:prstGeom>
-          <a:solidFill>
-            <a:schemeClr val="accent1">
-              <a:lumMod val="40000"/>
-              <a:lumOff val="60000"/>
-            </a:schemeClr>
-          </a:solidFill>
-        </p:spPr>
-        <p:style>
-          <a:lnRef idx="2">
-            <a:schemeClr val="accent1">
-              <a:shade val="15000"/>
-            </a:schemeClr>
-          </a:lnRef>
-          <a:fillRef idx="1">
-            <a:schemeClr val="accent1"/>
-          </a:fillRef>
-          <a:effectRef idx="0">
-            <a:schemeClr val="accent1"/>
-          </a:effectRef>
-          <a:fontRef idx="minor">
-            <a:schemeClr val="lt1"/>
-          </a:fontRef>
-        </p:style>
-        <p:txBody>
-          <a:bodyPr numCol="2" rtlCol="0" anchor="ctr"/>
-          <a:lstStyle/>
-          <a:p>
-            <a:pPr algn="ctr"/>
-            <a:endParaRPr lang="en-GB" sz="1400" dirty="0">
-              <a:solidFill>
-                <a:sysClr val="windowText" lastClr="000000"/>
-              </a:solidFill>
-              <a:latin typeface="SimHei" panose="020B0503020204020204" pitchFamily="49" charset="-122"/>
-              <a:ea typeface="SimHei" panose="020B0503020204020204" pitchFamily="49" charset="-122"/>
-            </a:endParaRPr>
-          </a:p>
-          <a:p>
-            <a:pPr algn="ctr"/>
-            <a:r>
-              <a:rPr lang="en-GB" sz="1400" dirty="0">
-                <a:solidFill>
-                  <a:sysClr val="windowText" lastClr="000000"/>
-                </a:solidFill>
-                <a:latin typeface="SimHei" panose="020B0503020204020204" pitchFamily="49" charset="-122"/>
-                <a:ea typeface="SimHei" panose="020B0503020204020204" pitchFamily="49" charset="-122"/>
-              </a:rPr>
-              <a:t>bedtools intersect -v (does not overlap) 50nt_exonic_loci.bed</a:t>
-            </a:r>
-            <a:br>
-              <a:rPr lang="en-GB" sz="1400" dirty="0">
-                <a:solidFill>
-                  <a:sysClr val="windowText" lastClr="000000"/>
-                </a:solidFill>
-                <a:latin typeface="SimHei" panose="020B0503020204020204" pitchFamily="49" charset="-122"/>
-                <a:ea typeface="SimHei" panose="020B0503020204020204" pitchFamily="49" charset="-122"/>
-              </a:rPr>
-            </a:br>
-            <a:r>
-              <a:rPr lang="en-GB" sz="1400" dirty="0">
-                <a:solidFill>
-                  <a:sysClr val="windowText" lastClr="000000"/>
-                </a:solidFill>
-                <a:latin typeface="SimHei" panose="020B0503020204020204" pitchFamily="49" charset="-122"/>
-                <a:ea typeface="SimHei" panose="020B0503020204020204" pitchFamily="49" charset="-122"/>
-              </a:rPr>
-              <a:t>== </a:t>
-            </a:r>
-            <a:r>
-              <a:rPr lang="en-GB" sz="1400" dirty="0" err="1">
-                <a:solidFill>
-                  <a:schemeClr val="accent1"/>
-                </a:solidFill>
-                <a:latin typeface="SimHei" panose="020B0503020204020204" pitchFamily="49" charset="-122"/>
-                <a:ea typeface="SimHei" panose="020B0503020204020204" pitchFamily="49" charset="-122"/>
-              </a:rPr>
-              <a:t>deep_intronic_sites.bed</a:t>
-            </a:r>
-            <a:endParaRPr lang="en-GB" sz="1400" dirty="0">
-              <a:solidFill>
-                <a:schemeClr val="accent1"/>
-              </a:solidFill>
-              <a:latin typeface="SimHei" panose="020B0503020204020204" pitchFamily="49" charset="-122"/>
-              <a:ea typeface="SimHei" panose="020B0503020204020204" pitchFamily="49" charset="-122"/>
-            </a:endParaRPr>
-          </a:p>
-          <a:p>
-            <a:pPr algn="ctr"/>
-            <a:endParaRPr lang="en-GB" sz="1400" dirty="0">
-              <a:solidFill>
-                <a:sysClr val="windowText" lastClr="000000"/>
-              </a:solidFill>
-              <a:latin typeface="SimHei" panose="020B0503020204020204" pitchFamily="49" charset="-122"/>
-              <a:ea typeface="SimHei" panose="020B0503020204020204" pitchFamily="49" charset="-122"/>
-            </a:endParaRPr>
-          </a:p>
-          <a:p>
-            <a:pPr algn="ctr"/>
-            <a:endParaRPr lang="en-GB" sz="1400" dirty="0">
-              <a:solidFill>
-                <a:sysClr val="windowText" lastClr="000000"/>
-              </a:solidFill>
-              <a:latin typeface="SimHei" panose="020B0503020204020204" pitchFamily="49" charset="-122"/>
-              <a:ea typeface="SimHei" panose="020B0503020204020204" pitchFamily="49" charset="-122"/>
-            </a:endParaRPr>
-          </a:p>
-          <a:p>
-            <a:pPr algn="ctr"/>
-            <a:endParaRPr lang="en-GB" sz="1400" dirty="0">
-              <a:solidFill>
-                <a:sysClr val="windowText" lastClr="000000"/>
-              </a:solidFill>
-              <a:latin typeface="SimHei" panose="020B0503020204020204" pitchFamily="49" charset="-122"/>
-              <a:ea typeface="SimHei" panose="020B0503020204020204" pitchFamily="49" charset="-122"/>
-            </a:endParaRPr>
-          </a:p>
-          <a:p>
-            <a:pPr algn="ctr"/>
-            <a:r>
-              <a:rPr lang="en-GB" sz="1400" dirty="0">
-                <a:solidFill>
-                  <a:sysClr val="windowText" lastClr="000000"/>
-                </a:solidFill>
-                <a:latin typeface="SimHei" panose="020B0503020204020204" pitchFamily="49" charset="-122"/>
-                <a:ea typeface="SimHei" panose="020B0503020204020204" pitchFamily="49" charset="-122"/>
-              </a:rPr>
-              <a:t>bedtools intersect -c (does overlap) 50nt_exonic_loci.bed</a:t>
-            </a:r>
-            <a:br>
-              <a:rPr lang="en-GB" sz="1400" dirty="0">
-                <a:solidFill>
-                  <a:sysClr val="windowText" lastClr="000000"/>
-                </a:solidFill>
-                <a:latin typeface="SimHei" panose="020B0503020204020204" pitchFamily="49" charset="-122"/>
-                <a:ea typeface="SimHei" panose="020B0503020204020204" pitchFamily="49" charset="-122"/>
-              </a:rPr>
-            </a:br>
-            <a:r>
-              <a:rPr lang="en-GB" sz="1400" dirty="0">
-                <a:solidFill>
-                  <a:sysClr val="windowText" lastClr="000000"/>
-                </a:solidFill>
-                <a:latin typeface="SimHei" panose="020B0503020204020204" pitchFamily="49" charset="-122"/>
-                <a:ea typeface="SimHei" panose="020B0503020204020204" pitchFamily="49" charset="-122"/>
-              </a:rPr>
-              <a:t>== </a:t>
-            </a:r>
-            <a:r>
-              <a:rPr lang="en-GB" sz="1400" dirty="0" err="1">
-                <a:solidFill>
-                  <a:schemeClr val="accent1"/>
-                </a:solidFill>
-                <a:latin typeface="SimHei" panose="020B0503020204020204" pitchFamily="49" charset="-122"/>
-                <a:ea typeface="SimHei" panose="020B0503020204020204" pitchFamily="49" charset="-122"/>
-              </a:rPr>
-              <a:t>exonic.bed</a:t>
-            </a:r>
-            <a:endParaRPr lang="en-US" sz="1400" dirty="0">
-              <a:solidFill>
-                <a:schemeClr val="accent1"/>
-              </a:solidFill>
-              <a:latin typeface="Abadi" panose="020B0604020104020204" pitchFamily="34" charset="0"/>
-            </a:endParaRPr>
-          </a:p>
-          <a:p>
-            <a:pPr algn="ctr"/>
-            <a:endParaRPr lang="en-US" dirty="0">
-              <a:solidFill>
-                <a:sysClr val="windowText" lastClr="000000"/>
-              </a:solidFill>
-              <a:latin typeface="Abadi" panose="020B0604020104020204" pitchFamily="34" charset="0"/>
-            </a:endParaRPr>
-          </a:p>
-        </p:txBody>
-      </p:sp>
-      <p:sp>
-        <p:nvSpPr>
-          <p:cNvPr id="10" name="Rectangle 9">
-            <a:extLst>
-              <a:ext uri="{FF2B5EF4-FFF2-40B4-BE49-F238E27FC236}">
-                <a16:creationId xmlns:a16="http://schemas.microsoft.com/office/drawing/2014/main" id="{7986058C-5F08-E956-A26E-19F8D99BD785}"/>
-              </a:ext>
-            </a:extLst>
-          </p:cNvPr>
-          <p:cNvSpPr/>
-          <p:nvPr/>
-        </p:nvSpPr>
-        <p:spPr>
-          <a:xfrm>
-            <a:off x="2127250" y="7221972"/>
-            <a:ext cx="2603500" cy="393700"/>
-          </a:xfrm>
-          <a:prstGeom prst="rect">
-            <a:avLst/>
-          </a:prstGeom>
-          <a:ln w="19050">
-            <a:solidFill>
-              <a:schemeClr val="tx1"/>
-            </a:solidFill>
-          </a:ln>
-        </p:spPr>
-        <p:style>
-          <a:lnRef idx="2">
-            <a:schemeClr val="accent1"/>
-          </a:lnRef>
-          <a:fillRef idx="1">
-            <a:schemeClr val="lt1"/>
-          </a:fillRef>
-          <a:effectRef idx="0">
-            <a:schemeClr val="accent1"/>
-          </a:effectRef>
-          <a:fontRef idx="minor">
-            <a:schemeClr val="dk1"/>
-          </a:fontRef>
-        </p:style>
-        <p:txBody>
-          <a:bodyPr rtlCol="0" anchor="ctr"/>
-          <a:lstStyle/>
-          <a:p>
-            <a:pPr algn="ctr"/>
-            <a:r>
-              <a:rPr lang="en-US" b="1" dirty="0">
-                <a:latin typeface="Raleway" pitchFamily="2" charset="0"/>
-                <a:cs typeface="Posterama" panose="020B0504020200020000" pitchFamily="34" charset="0"/>
-              </a:rPr>
-              <a:t>Bedtools intersect</a:t>
-            </a:r>
-            <a:endParaRPr lang="en-GB" b="1" dirty="0">
-              <a:latin typeface="Raleway" pitchFamily="2" charset="0"/>
-              <a:cs typeface="Posterama" panose="020B0504020200020000" pitchFamily="34" charset="0"/>
-            </a:endParaRPr>
-          </a:p>
-        </p:txBody>
-      </p:sp>
-      <p:sp>
-        <p:nvSpPr>
-          <p:cNvPr id="21" name="Rectangle 20">
-            <a:extLst>
-              <a:ext uri="{FF2B5EF4-FFF2-40B4-BE49-F238E27FC236}">
-                <a16:creationId xmlns:a16="http://schemas.microsoft.com/office/drawing/2014/main" id="{A78BE0AB-C7A5-4A64-AB8A-3FDFA8307852}"/>
-              </a:ext>
-            </a:extLst>
-          </p:cNvPr>
-          <p:cNvSpPr/>
-          <p:nvPr/>
-        </p:nvSpPr>
-        <p:spPr>
-          <a:xfrm>
-            <a:off x="1847054" y="3227259"/>
-            <a:ext cx="3154360" cy="393700"/>
-          </a:xfrm>
-          <a:prstGeom prst="rect">
-            <a:avLst/>
-          </a:prstGeom>
-          <a:ln w="19050">
-            <a:solidFill>
-              <a:schemeClr val="tx1"/>
-            </a:solidFill>
-          </a:ln>
-        </p:spPr>
-        <p:style>
-          <a:lnRef idx="2">
-            <a:schemeClr val="accent1"/>
-          </a:lnRef>
-          <a:fillRef idx="1">
-            <a:schemeClr val="lt1"/>
-          </a:fillRef>
-          <a:effectRef idx="0">
-            <a:schemeClr val="accent1"/>
-          </a:effectRef>
-          <a:fontRef idx="minor">
-            <a:schemeClr val="dk1"/>
-          </a:fontRef>
-        </p:style>
-        <p:txBody>
-          <a:bodyPr rtlCol="0" anchor="ctr"/>
-          <a:lstStyle/>
-          <a:p>
-            <a:pPr algn="ctr"/>
-            <a:r>
-              <a:rPr lang="en-US" b="1" dirty="0">
-                <a:latin typeface="Raleway" pitchFamily="2" charset="0"/>
-                <a:cs typeface="Posterama" panose="020B0504020200020000" pitchFamily="34" charset="0"/>
-              </a:rPr>
-              <a:t>VAST-DB MAIN-PSI-TABLE</a:t>
-            </a:r>
-            <a:endParaRPr lang="en-GB" b="1" dirty="0">
-              <a:latin typeface="Raleway" pitchFamily="2" charset="0"/>
-              <a:cs typeface="Posterama" panose="020B0504020200020000" pitchFamily="34" charset="0"/>
-            </a:endParaRPr>
-          </a:p>
-        </p:txBody>
-      </p:sp>
-      <p:sp>
-        <p:nvSpPr>
-          <p:cNvPr id="25" name="Rectangle 24">
-            <a:extLst>
-              <a:ext uri="{FF2B5EF4-FFF2-40B4-BE49-F238E27FC236}">
-                <a16:creationId xmlns:a16="http://schemas.microsoft.com/office/drawing/2014/main" id="{0639E164-C200-CA46-95AD-8E6D551016C1}"/>
-              </a:ext>
-            </a:extLst>
-          </p:cNvPr>
-          <p:cNvSpPr/>
-          <p:nvPr/>
-        </p:nvSpPr>
-        <p:spPr>
-          <a:xfrm>
-            <a:off x="114298" y="8522406"/>
-            <a:ext cx="3314702" cy="1488369"/>
-          </a:xfrm>
-          <a:prstGeom prst="rect">
-            <a:avLst/>
-          </a:prstGeom>
-          <a:solidFill>
-            <a:schemeClr val="accent1">
-              <a:lumMod val="40000"/>
-              <a:lumOff val="60000"/>
-            </a:schemeClr>
-          </a:solidFill>
-        </p:spPr>
-        <p:style>
-          <a:lnRef idx="2">
-            <a:schemeClr val="accent1">
-              <a:shade val="15000"/>
-            </a:schemeClr>
-          </a:lnRef>
-          <a:fillRef idx="1">
-            <a:schemeClr val="accent1"/>
-          </a:fillRef>
-          <a:effectRef idx="0">
-            <a:schemeClr val="accent1"/>
-          </a:effectRef>
-          <a:fontRef idx="minor">
-            <a:schemeClr val="lt1"/>
-          </a:fontRef>
-        </p:style>
-        <p:txBody>
-          <a:bodyPr numCol="2" rtlCol="0" anchor="ctr"/>
-          <a:lstStyle/>
-          <a:p>
-            <a:pPr algn="ctr"/>
-            <a:r>
-              <a:rPr lang="en-US" sz="1200" dirty="0">
-                <a:solidFill>
-                  <a:schemeClr val="tx1"/>
-                </a:solidFill>
-                <a:latin typeface="Abadi" panose="020B0604020104020204" pitchFamily="34" charset="0"/>
-              </a:rPr>
-              <a:t>Intersect </a:t>
-            </a:r>
-            <a:r>
-              <a:rPr lang="en-US" sz="1200" dirty="0" err="1">
-                <a:solidFill>
-                  <a:schemeClr val="tx1"/>
-                </a:solidFill>
-                <a:latin typeface="Abadi" panose="020B0604020104020204" pitchFamily="34" charset="0"/>
-              </a:rPr>
-              <a:t>deep_intronic_sites.bed</a:t>
-            </a:r>
-            <a:r>
-              <a:rPr lang="en-US" sz="1200" dirty="0">
-                <a:solidFill>
-                  <a:schemeClr val="tx1"/>
-                </a:solidFill>
-                <a:latin typeface="Abadi" panose="020B0604020104020204" pitchFamily="34" charset="0"/>
-              </a:rPr>
-              <a:t> </a:t>
-            </a:r>
-            <a:br>
-              <a:rPr lang="en-US" sz="1200" dirty="0">
-                <a:solidFill>
-                  <a:schemeClr val="accent1"/>
-                </a:solidFill>
-                <a:latin typeface="Abadi" panose="020B0604020104020204" pitchFamily="34" charset="0"/>
-              </a:rPr>
-            </a:br>
-            <a:r>
-              <a:rPr lang="en-US" sz="1200" dirty="0" err="1">
-                <a:solidFill>
-                  <a:schemeClr val="accent1"/>
-                </a:solidFill>
-                <a:latin typeface="Abadi" panose="020B0604020104020204" pitchFamily="34" charset="0"/>
-              </a:rPr>
-              <a:t>RBPnet</a:t>
-            </a:r>
-            <a:r>
-              <a:rPr lang="en-US" sz="1200" dirty="0">
-                <a:solidFill>
-                  <a:schemeClr val="accent1"/>
-                </a:solidFill>
-                <a:latin typeface="Abadi" panose="020B0604020104020204" pitchFamily="34" charset="0"/>
-              </a:rPr>
-              <a:t> PRPF8 predictions </a:t>
-            </a:r>
-          </a:p>
-          <a:p>
-            <a:pPr algn="ctr"/>
-            <a:r>
-              <a:rPr lang="en-US" sz="1200" dirty="0">
-                <a:solidFill>
-                  <a:schemeClr val="tx1"/>
-                </a:solidFill>
-                <a:latin typeface="Abadi" panose="020B0604020104020204" pitchFamily="34" charset="0"/>
-              </a:rPr>
-              <a:t>and/or </a:t>
-            </a:r>
-            <a:r>
-              <a:rPr lang="en-US" sz="1200" dirty="0">
-                <a:solidFill>
-                  <a:schemeClr val="accent1"/>
-                </a:solidFill>
-                <a:latin typeface="Abadi" panose="020B0604020104020204" pitchFamily="34" charset="0"/>
-              </a:rPr>
-              <a:t>PRPF8 Peaks </a:t>
-            </a:r>
-          </a:p>
-          <a:p>
-            <a:pPr algn="ctr"/>
-            <a:r>
-              <a:rPr lang="en-US" sz="1200" dirty="0">
-                <a:solidFill>
-                  <a:schemeClr val="tx1"/>
-                </a:solidFill>
-                <a:latin typeface="Abadi" panose="020B0604020104020204" pitchFamily="34" charset="0"/>
-              </a:rPr>
-              <a:t>and/or </a:t>
-            </a:r>
-            <a:r>
-              <a:rPr lang="en-US" sz="1200" dirty="0" err="1">
-                <a:solidFill>
-                  <a:schemeClr val="accent1"/>
-                </a:solidFill>
-                <a:latin typeface="Abadi" panose="020B0604020104020204" pitchFamily="34" charset="0"/>
-              </a:rPr>
-              <a:t>SmB</a:t>
-            </a:r>
-            <a:r>
-              <a:rPr lang="en-US" sz="1200" dirty="0">
-                <a:solidFill>
-                  <a:schemeClr val="accent1"/>
-                </a:solidFill>
-                <a:latin typeface="Abadi" panose="020B0604020104020204" pitchFamily="34" charset="0"/>
-              </a:rPr>
-              <a:t> Peaks</a:t>
-            </a:r>
-          </a:p>
-          <a:p>
-            <a:pPr algn="ctr"/>
-            <a:r>
-              <a:rPr lang="en-US" sz="1200" dirty="0">
-                <a:solidFill>
-                  <a:schemeClr val="tx1"/>
-                </a:solidFill>
-                <a:latin typeface="Abadi" panose="020B0604020104020204" pitchFamily="34" charset="0"/>
-              </a:rPr>
-              <a:t>== </a:t>
-            </a:r>
-            <a:r>
-              <a:rPr lang="en-US" sz="1200" dirty="0" err="1">
-                <a:solidFill>
-                  <a:schemeClr val="tx1"/>
-                </a:solidFill>
-                <a:latin typeface="Abadi" panose="020B0604020104020204" pitchFamily="34" charset="0"/>
-              </a:rPr>
-              <a:t>decoys.bed</a:t>
-            </a:r>
-            <a:br>
-              <a:rPr lang="en-US" sz="1200" dirty="0">
-                <a:solidFill>
-                  <a:schemeClr val="tx1"/>
-                </a:solidFill>
-                <a:latin typeface="Abadi" panose="020B0604020104020204" pitchFamily="34" charset="0"/>
-              </a:rPr>
-            </a:br>
-            <a:r>
-              <a:rPr lang="en-US" sz="1200" dirty="0">
-                <a:solidFill>
-                  <a:schemeClr val="tx1"/>
-                </a:solidFill>
-                <a:latin typeface="Abadi" panose="020B0604020104020204" pitchFamily="34" charset="0"/>
-              </a:rPr>
-              <a:t>Intersect </a:t>
-            </a:r>
-            <a:r>
-              <a:rPr lang="en-US" sz="1200" dirty="0" err="1">
-                <a:solidFill>
-                  <a:schemeClr val="tx1"/>
-                </a:solidFill>
-                <a:latin typeface="Abadi" panose="020B0604020104020204" pitchFamily="34" charset="0"/>
-              </a:rPr>
-              <a:t>deep_intronic_sites.bed</a:t>
-            </a:r>
-            <a:br>
-              <a:rPr lang="en-US" sz="1200" dirty="0">
-                <a:solidFill>
-                  <a:schemeClr val="tx1"/>
-                </a:solidFill>
-                <a:latin typeface="Abadi" panose="020B0604020104020204" pitchFamily="34" charset="0"/>
-              </a:rPr>
-            </a:br>
-            <a:r>
-              <a:rPr lang="en-US" sz="1200" dirty="0">
-                <a:solidFill>
-                  <a:schemeClr val="tx1"/>
-                </a:solidFill>
-                <a:latin typeface="Abadi" panose="020B0604020104020204" pitchFamily="34" charset="0"/>
-              </a:rPr>
-              <a:t>None of </a:t>
-            </a:r>
-            <a:r>
-              <a:rPr lang="en-US" sz="1200" dirty="0" err="1">
-                <a:solidFill>
-                  <a:schemeClr val="accent1"/>
-                </a:solidFill>
-                <a:latin typeface="Abadi" panose="020B0604020104020204" pitchFamily="34" charset="0"/>
-              </a:rPr>
-              <a:t>RBPnet</a:t>
-            </a:r>
-            <a:r>
-              <a:rPr lang="en-US" sz="1200" dirty="0">
-                <a:solidFill>
-                  <a:schemeClr val="accent1"/>
-                </a:solidFill>
-                <a:latin typeface="Abadi" panose="020B0604020104020204" pitchFamily="34" charset="0"/>
-              </a:rPr>
-              <a:t> PRPF8 predictions </a:t>
-            </a:r>
-          </a:p>
-          <a:p>
-            <a:pPr algn="ctr"/>
-            <a:r>
-              <a:rPr lang="en-US" sz="1200" dirty="0">
-                <a:solidFill>
-                  <a:schemeClr val="tx1"/>
-                </a:solidFill>
-                <a:latin typeface="Abadi" panose="020B0604020104020204" pitchFamily="34" charset="0"/>
-              </a:rPr>
-              <a:t>or </a:t>
-            </a:r>
-            <a:r>
-              <a:rPr lang="en-US" sz="1200" dirty="0">
-                <a:solidFill>
-                  <a:schemeClr val="accent1"/>
-                </a:solidFill>
-                <a:latin typeface="Abadi" panose="020B0604020104020204" pitchFamily="34" charset="0"/>
-              </a:rPr>
-              <a:t>PRPF8 Peaks </a:t>
-            </a:r>
-          </a:p>
-          <a:p>
-            <a:pPr algn="ctr"/>
-            <a:r>
-              <a:rPr lang="en-US" sz="1200" dirty="0">
-                <a:solidFill>
-                  <a:schemeClr val="tx1"/>
-                </a:solidFill>
-                <a:latin typeface="Abadi" panose="020B0604020104020204" pitchFamily="34" charset="0"/>
-              </a:rPr>
-              <a:t>or </a:t>
-            </a:r>
-            <a:r>
-              <a:rPr lang="en-US" sz="1200" dirty="0" err="1">
-                <a:solidFill>
-                  <a:schemeClr val="accent1"/>
-                </a:solidFill>
-                <a:latin typeface="Abadi" panose="020B0604020104020204" pitchFamily="34" charset="0"/>
-              </a:rPr>
-              <a:t>SmB</a:t>
-            </a:r>
-            <a:r>
-              <a:rPr lang="en-US" sz="1200" dirty="0">
-                <a:solidFill>
-                  <a:schemeClr val="accent1"/>
-                </a:solidFill>
-                <a:latin typeface="Abadi" panose="020B0604020104020204" pitchFamily="34" charset="0"/>
-              </a:rPr>
-              <a:t> Peaks</a:t>
-            </a:r>
-          </a:p>
-          <a:p>
-            <a:pPr algn="ctr"/>
-            <a:r>
-              <a:rPr lang="en-US" sz="1200" dirty="0">
-                <a:solidFill>
-                  <a:schemeClr val="tx1"/>
-                </a:solidFill>
-                <a:latin typeface="Abadi" panose="020B0604020104020204" pitchFamily="34" charset="0"/>
-              </a:rPr>
-              <a:t>== </a:t>
-            </a:r>
-            <a:r>
-              <a:rPr lang="en-US" sz="1200" dirty="0" err="1">
-                <a:solidFill>
-                  <a:schemeClr val="tx1"/>
-                </a:solidFill>
-                <a:latin typeface="Abadi" panose="020B0604020104020204" pitchFamily="34" charset="0"/>
-              </a:rPr>
-              <a:t>cryptic_sites.bed</a:t>
-            </a:r>
-            <a:endParaRPr lang="en-US" sz="1200" dirty="0">
-              <a:solidFill>
-                <a:schemeClr val="tx1"/>
-              </a:solidFill>
-              <a:latin typeface="Abadi" panose="020B0604020104020204" pitchFamily="34" charset="0"/>
-            </a:endParaRPr>
-          </a:p>
-        </p:txBody>
-      </p:sp>
-      <p:sp>
-        <p:nvSpPr>
-          <p:cNvPr id="28" name="Rectangle 27">
-            <a:extLst>
-              <a:ext uri="{FF2B5EF4-FFF2-40B4-BE49-F238E27FC236}">
-                <a16:creationId xmlns:a16="http://schemas.microsoft.com/office/drawing/2014/main" id="{8E9C454C-497A-EEF9-9806-1AD272B5DBF2}"/>
-              </a:ext>
-            </a:extLst>
-          </p:cNvPr>
-          <p:cNvSpPr/>
-          <p:nvPr/>
-        </p:nvSpPr>
-        <p:spPr>
-          <a:xfrm>
-            <a:off x="4051997" y="8656821"/>
-            <a:ext cx="2346918" cy="909119"/>
-          </a:xfrm>
-          <a:prstGeom prst="rect">
-            <a:avLst/>
-          </a:prstGeom>
-          <a:solidFill>
-            <a:schemeClr val="accent1">
-              <a:lumMod val="40000"/>
-              <a:lumOff val="60000"/>
-            </a:schemeClr>
-          </a:solidFill>
-        </p:spPr>
-        <p:style>
-          <a:lnRef idx="2">
-            <a:schemeClr val="accent1">
-              <a:shade val="15000"/>
-            </a:schemeClr>
-          </a:lnRef>
-          <a:fillRef idx="1">
-            <a:schemeClr val="accent1"/>
-          </a:fillRef>
-          <a:effectRef idx="0">
-            <a:schemeClr val="accent1"/>
-          </a:effectRef>
-          <a:fontRef idx="minor">
-            <a:schemeClr val="lt1"/>
-          </a:fontRef>
-        </p:style>
-        <p:txBody>
-          <a:bodyPr numCol="1" rtlCol="0" anchor="ctr"/>
-          <a:lstStyle/>
-          <a:p>
-            <a:pPr algn="ctr"/>
-            <a:r>
-              <a:rPr lang="en-US" sz="1200" dirty="0">
-                <a:solidFill>
-                  <a:schemeClr val="tx1"/>
-                </a:solidFill>
-                <a:latin typeface="Abadi" panose="020B0604020104020204" pitchFamily="34" charset="0"/>
-              </a:rPr>
-              <a:t>Intersect </a:t>
-            </a:r>
-            <a:r>
-              <a:rPr lang="en-US" sz="1200" dirty="0" err="1">
-                <a:solidFill>
-                  <a:schemeClr val="tx1"/>
-                </a:solidFill>
-                <a:latin typeface="Abadi" panose="020B0604020104020204" pitchFamily="34" charset="0"/>
-              </a:rPr>
-              <a:t>exonic.bed</a:t>
-            </a:r>
-            <a:r>
-              <a:rPr lang="en-US" sz="1200" dirty="0">
-                <a:solidFill>
-                  <a:schemeClr val="tx1"/>
-                </a:solidFill>
-                <a:latin typeface="Abadi" panose="020B0604020104020204" pitchFamily="34" charset="0"/>
-              </a:rPr>
-              <a:t> -v</a:t>
-            </a:r>
-            <a:br>
-              <a:rPr lang="en-US" sz="1200" dirty="0">
-                <a:solidFill>
-                  <a:schemeClr val="accent1"/>
-                </a:solidFill>
-                <a:latin typeface="Abadi" panose="020B0604020104020204" pitchFamily="34" charset="0"/>
-              </a:rPr>
-            </a:br>
-            <a:r>
-              <a:rPr lang="en-US" sz="1200" dirty="0" err="1">
-                <a:solidFill>
-                  <a:schemeClr val="accent1"/>
-                </a:solidFill>
-                <a:latin typeface="Abadi" panose="020B0604020104020204" pitchFamily="34" charset="0"/>
-              </a:rPr>
-              <a:t>canonical_splice_sites.bed</a:t>
-            </a:r>
-            <a:endParaRPr lang="en-US" sz="1200" dirty="0">
-              <a:solidFill>
-                <a:schemeClr val="accent1"/>
-              </a:solidFill>
-              <a:latin typeface="Abadi" panose="020B0604020104020204" pitchFamily="34" charset="0"/>
-            </a:endParaRPr>
-          </a:p>
-          <a:p>
-            <a:pPr algn="ctr"/>
-            <a:r>
-              <a:rPr lang="en-US" sz="1200" dirty="0">
-                <a:solidFill>
-                  <a:schemeClr val="tx1"/>
-                </a:solidFill>
-                <a:latin typeface="Abadi" panose="020B0604020104020204" pitchFamily="34" charset="0"/>
-              </a:rPr>
-              <a:t>== alt5_splice_sites.bed</a:t>
-            </a:r>
-          </a:p>
-        </p:txBody>
-      </p:sp>
-      <p:sp>
-        <p:nvSpPr>
-          <p:cNvPr id="30" name="Rectangle 29">
-            <a:extLst>
-              <a:ext uri="{FF2B5EF4-FFF2-40B4-BE49-F238E27FC236}">
-                <a16:creationId xmlns:a16="http://schemas.microsoft.com/office/drawing/2014/main" id="{BBCDD2FF-01BE-CB9E-D112-F3133CBDA1A6}"/>
-              </a:ext>
-            </a:extLst>
-          </p:cNvPr>
-          <p:cNvSpPr/>
-          <p:nvPr/>
-        </p:nvSpPr>
-        <p:spPr>
-          <a:xfrm>
-            <a:off x="114297" y="10167597"/>
-            <a:ext cx="3879434" cy="1778964"/>
-          </a:xfrm>
-          <a:prstGeom prst="rect">
-            <a:avLst/>
-          </a:prstGeom>
-          <a:solidFill>
-            <a:schemeClr val="accent1">
-              <a:lumMod val="40000"/>
-              <a:lumOff val="60000"/>
-            </a:schemeClr>
-          </a:solidFill>
-        </p:spPr>
-        <p:style>
-          <a:lnRef idx="2">
-            <a:schemeClr val="accent1">
-              <a:shade val="15000"/>
-            </a:schemeClr>
-          </a:lnRef>
-          <a:fillRef idx="1">
-            <a:schemeClr val="accent1"/>
-          </a:fillRef>
-          <a:effectRef idx="0">
-            <a:schemeClr val="accent1"/>
-          </a:effectRef>
-          <a:fontRef idx="minor">
-            <a:schemeClr val="lt1"/>
-          </a:fontRef>
-        </p:style>
-        <p:txBody>
-          <a:bodyPr numCol="1" rtlCol="0" anchor="ctr"/>
-          <a:lstStyle/>
-          <a:p>
-            <a:pPr algn="ctr"/>
-            <a:r>
-              <a:rPr lang="en-US" sz="1200" dirty="0">
-                <a:solidFill>
-                  <a:schemeClr val="tx1"/>
-                </a:solidFill>
-                <a:latin typeface="Abadi" panose="020B0604020104020204" pitchFamily="34" charset="0"/>
-              </a:rPr>
-              <a:t>Create new dataset, intersect </a:t>
-            </a:r>
-            <a:r>
-              <a:rPr lang="en-US" sz="1200" dirty="0" err="1">
-                <a:solidFill>
-                  <a:schemeClr val="tx1"/>
-                </a:solidFill>
-                <a:latin typeface="Abadi" panose="020B0604020104020204" pitchFamily="34" charset="0"/>
-              </a:rPr>
-              <a:t>Canonical_splice_sites.bed</a:t>
-            </a:r>
-            <a:endParaRPr lang="en-US" sz="1200" dirty="0">
-              <a:solidFill>
-                <a:schemeClr val="tx1"/>
-              </a:solidFill>
-              <a:latin typeface="Abadi" panose="020B0604020104020204" pitchFamily="34" charset="0"/>
-            </a:endParaRPr>
-          </a:p>
-          <a:p>
-            <a:pPr algn="ctr"/>
-            <a:r>
-              <a:rPr lang="en-US" sz="1200" dirty="0" err="1">
-                <a:solidFill>
-                  <a:schemeClr val="accent1"/>
-                </a:solidFill>
-                <a:latin typeface="Abadi" panose="020B0604020104020204" pitchFamily="34" charset="0"/>
-              </a:rPr>
-              <a:t>RBPnet</a:t>
-            </a:r>
-            <a:r>
-              <a:rPr lang="en-US" sz="1200" dirty="0">
-                <a:solidFill>
-                  <a:schemeClr val="accent1"/>
-                </a:solidFill>
-                <a:latin typeface="Abadi" panose="020B0604020104020204" pitchFamily="34" charset="0"/>
-              </a:rPr>
-              <a:t> PRPF8 predictions </a:t>
-            </a:r>
-          </a:p>
-          <a:p>
-            <a:pPr algn="ctr"/>
-            <a:r>
-              <a:rPr lang="en-US" sz="1200" dirty="0">
-                <a:solidFill>
-                  <a:schemeClr val="tx1"/>
-                </a:solidFill>
-                <a:latin typeface="Abadi" panose="020B0604020104020204" pitchFamily="34" charset="0"/>
-              </a:rPr>
-              <a:t>and/or </a:t>
-            </a:r>
-            <a:r>
-              <a:rPr lang="en-US" sz="1200" dirty="0">
-                <a:solidFill>
-                  <a:schemeClr val="accent1"/>
-                </a:solidFill>
-                <a:latin typeface="Abadi" panose="020B0604020104020204" pitchFamily="34" charset="0"/>
-              </a:rPr>
-              <a:t>PRPF8 Peaks </a:t>
-            </a:r>
-          </a:p>
-          <a:p>
-            <a:pPr algn="ctr"/>
-            <a:r>
-              <a:rPr lang="en-US" sz="1200" dirty="0">
-                <a:solidFill>
-                  <a:schemeClr val="tx1"/>
-                </a:solidFill>
-                <a:latin typeface="Abadi" panose="020B0604020104020204" pitchFamily="34" charset="0"/>
-              </a:rPr>
-              <a:t>and/or </a:t>
-            </a:r>
-            <a:r>
-              <a:rPr lang="en-US" sz="1200" dirty="0" err="1">
-                <a:solidFill>
-                  <a:schemeClr val="accent1"/>
-                </a:solidFill>
-                <a:latin typeface="Abadi" panose="020B0604020104020204" pitchFamily="34" charset="0"/>
-              </a:rPr>
-              <a:t>SmB</a:t>
-            </a:r>
-            <a:r>
-              <a:rPr lang="en-US" sz="1200" dirty="0">
-                <a:solidFill>
-                  <a:schemeClr val="accent1"/>
-                </a:solidFill>
-                <a:latin typeface="Abadi" panose="020B0604020104020204" pitchFamily="34" charset="0"/>
-              </a:rPr>
-              <a:t> Peaks</a:t>
-            </a:r>
-          </a:p>
-          <a:p>
-            <a:pPr algn="ctr"/>
-            <a:br>
-              <a:rPr lang="en-US" sz="1200" dirty="0">
-                <a:solidFill>
-                  <a:schemeClr val="tx1"/>
-                </a:solidFill>
-                <a:latin typeface="Abadi" panose="020B0604020104020204" pitchFamily="34" charset="0"/>
-              </a:rPr>
-            </a:br>
-            <a:r>
-              <a:rPr lang="en-US" sz="1200" dirty="0">
-                <a:solidFill>
-                  <a:schemeClr val="tx1"/>
-                </a:solidFill>
-                <a:latin typeface="Abadi" panose="020B0604020104020204" pitchFamily="34" charset="0"/>
-              </a:rPr>
-              <a:t>Build overlap with introns and </a:t>
-            </a:r>
-            <a:r>
-              <a:rPr lang="en-US" sz="1200" dirty="0" err="1">
-                <a:solidFill>
-                  <a:schemeClr val="tx1"/>
-                </a:solidFill>
-                <a:latin typeface="Abadi" panose="020B0604020104020204" pitchFamily="34" charset="0"/>
-              </a:rPr>
-              <a:t>GRanges</a:t>
-            </a:r>
-            <a:r>
-              <a:rPr lang="en-US" sz="1200" dirty="0">
-                <a:solidFill>
-                  <a:schemeClr val="tx1"/>
-                </a:solidFill>
-                <a:latin typeface="Abadi" panose="020B0604020104020204" pitchFamily="34" charset="0"/>
-              </a:rPr>
-              <a:t> for </a:t>
-            </a:r>
-            <a:r>
-              <a:rPr lang="en-US" sz="1200" dirty="0" err="1">
-                <a:solidFill>
-                  <a:schemeClr val="tx1"/>
-                </a:solidFill>
-                <a:latin typeface="Abadi" panose="020B0604020104020204" pitchFamily="34" charset="0"/>
-              </a:rPr>
-              <a:t>cryptic_sites.bed</a:t>
-            </a:r>
-            <a:r>
-              <a:rPr lang="en-US" sz="1200" dirty="0">
-                <a:solidFill>
-                  <a:schemeClr val="tx1"/>
-                </a:solidFill>
-                <a:latin typeface="Abadi" panose="020B0604020104020204" pitchFamily="34" charset="0"/>
-              </a:rPr>
-              <a:t> </a:t>
-            </a:r>
-            <a:br>
-              <a:rPr lang="en-US" sz="1200" dirty="0">
-                <a:solidFill>
-                  <a:schemeClr val="accent1"/>
-                </a:solidFill>
-                <a:latin typeface="Abadi" panose="020B0604020104020204" pitchFamily="34" charset="0"/>
-              </a:rPr>
-            </a:br>
-            <a:r>
-              <a:rPr lang="en-US" sz="1200" dirty="0">
-                <a:solidFill>
-                  <a:schemeClr val="tx1">
-                    <a:lumMod val="95000"/>
-                    <a:lumOff val="5000"/>
-                  </a:schemeClr>
-                </a:solidFill>
-                <a:latin typeface="Abadi" panose="020B0604020104020204" pitchFamily="34" charset="0"/>
-              </a:rPr>
-              <a:t>with</a:t>
-            </a:r>
-            <a:r>
-              <a:rPr lang="en-US" sz="1200" dirty="0">
-                <a:solidFill>
-                  <a:schemeClr val="accent1"/>
-                </a:solidFill>
-                <a:latin typeface="Abadi" panose="020B0604020104020204" pitchFamily="34" charset="0"/>
-              </a:rPr>
-              <a:t> </a:t>
-            </a:r>
-            <a:r>
-              <a:rPr lang="en-US" sz="1200" dirty="0" err="1">
-                <a:solidFill>
-                  <a:schemeClr val="accent1"/>
-                </a:solidFill>
-                <a:latin typeface="Abadi" panose="020B0604020104020204" pitchFamily="34" charset="0"/>
-              </a:rPr>
-              <a:t>canonical_supported_sites.bed</a:t>
-            </a:r>
-            <a:endParaRPr lang="en-US" sz="1200" dirty="0">
-              <a:solidFill>
-                <a:schemeClr val="accent1"/>
-              </a:solidFill>
-              <a:latin typeface="Abadi" panose="020B0604020104020204" pitchFamily="34" charset="0"/>
-            </a:endParaRPr>
-          </a:p>
-          <a:p>
-            <a:pPr algn="ctr"/>
-            <a:r>
-              <a:rPr lang="en-US" sz="1200" dirty="0">
-                <a:solidFill>
-                  <a:schemeClr val="accent1"/>
-                </a:solidFill>
-                <a:latin typeface="Abadi" panose="020B0604020104020204" pitchFamily="34" charset="0"/>
-              </a:rPr>
-              <a:t>== </a:t>
-            </a:r>
-            <a:r>
-              <a:rPr lang="en-US" sz="1200" dirty="0" err="1">
-                <a:solidFill>
-                  <a:schemeClr val="accent1"/>
-                </a:solidFill>
-                <a:latin typeface="Abadi" panose="020B0604020104020204" pitchFamily="34" charset="0"/>
-              </a:rPr>
-              <a:t>cryptics_supported.bed</a:t>
-            </a:r>
-            <a:endParaRPr lang="en-US" sz="1200" dirty="0">
-              <a:solidFill>
-                <a:schemeClr val="accent1"/>
-              </a:solidFill>
-              <a:latin typeface="Abadi" panose="020B0604020104020204" pitchFamily="34" charset="0"/>
-            </a:endParaRPr>
-          </a:p>
-        </p:txBody>
-      </p:sp>
-      <p:cxnSp>
-        <p:nvCxnSpPr>
-          <p:cNvPr id="32" name="Connector: Curved 31">
-            <a:extLst>
-              <a:ext uri="{FF2B5EF4-FFF2-40B4-BE49-F238E27FC236}">
-                <a16:creationId xmlns:a16="http://schemas.microsoft.com/office/drawing/2014/main" id="{0F39E967-6144-B1AE-9CD6-F5523B6FE432}"/>
-              </a:ext>
-            </a:extLst>
-          </p:cNvPr>
-          <p:cNvCxnSpPr>
-            <a:cxnSpLocks/>
-          </p:cNvCxnSpPr>
-          <p:nvPr/>
-        </p:nvCxnSpPr>
-        <p:spPr>
-          <a:xfrm rot="16200000" flipH="1">
-            <a:off x="2441276" y="10369849"/>
-            <a:ext cx="1209679" cy="491531"/>
-          </a:xfrm>
-          <a:prstGeom prst="curvedConnector3">
-            <a:avLst>
-              <a:gd name="adj1" fmla="val 50000"/>
-            </a:avLst>
-          </a:prstGeom>
-          <a:ln>
-            <a:tailEnd type="triangle"/>
-          </a:ln>
-        </p:spPr>
-        <p:style>
-          <a:lnRef idx="3">
-            <a:schemeClr val="accent1"/>
-          </a:lnRef>
-          <a:fillRef idx="0">
-            <a:schemeClr val="accent1"/>
-          </a:fillRef>
-          <a:effectRef idx="2">
-            <a:schemeClr val="accent1"/>
-          </a:effectRef>
-          <a:fontRef idx="minor">
-            <a:schemeClr val="tx1"/>
-          </a:fontRef>
-        </p:style>
-      </p:cxnSp>
-      <p:cxnSp>
-        <p:nvCxnSpPr>
-          <p:cNvPr id="40" name="Straight Arrow Connector 39">
-            <a:extLst>
-              <a:ext uri="{FF2B5EF4-FFF2-40B4-BE49-F238E27FC236}">
-                <a16:creationId xmlns:a16="http://schemas.microsoft.com/office/drawing/2014/main" id="{4F7900BE-0022-626E-D64B-2254BD0F9118}"/>
-              </a:ext>
-            </a:extLst>
-          </p:cNvPr>
-          <p:cNvCxnSpPr>
-            <a:cxnSpLocks/>
-          </p:cNvCxnSpPr>
-          <p:nvPr/>
-        </p:nvCxnSpPr>
-        <p:spPr>
-          <a:xfrm>
-            <a:off x="1771649" y="8334375"/>
-            <a:ext cx="0" cy="349301"/>
-          </a:xfrm>
-          <a:prstGeom prst="straightConnector1">
-            <a:avLst/>
-          </a:prstGeom>
-          <a:ln>
-            <a:tailEnd type="triangle"/>
-          </a:ln>
-        </p:spPr>
-        <p:style>
-          <a:lnRef idx="3">
-            <a:schemeClr val="accent1"/>
-          </a:lnRef>
-          <a:fillRef idx="0">
-            <a:schemeClr val="accent1"/>
-          </a:fillRef>
-          <a:effectRef idx="2">
-            <a:schemeClr val="accent1"/>
-          </a:effectRef>
-          <a:fontRef idx="minor">
-            <a:schemeClr val="tx1"/>
-          </a:fontRef>
-        </p:style>
-      </p:cxnSp>
-      <p:cxnSp>
-        <p:nvCxnSpPr>
-          <p:cNvPr id="42" name="Straight Arrow Connector 41">
-            <a:extLst>
-              <a:ext uri="{FF2B5EF4-FFF2-40B4-BE49-F238E27FC236}">
-                <a16:creationId xmlns:a16="http://schemas.microsoft.com/office/drawing/2014/main" id="{DADC1EF0-6792-562E-8FCC-7100A09C72A9}"/>
-              </a:ext>
-            </a:extLst>
-          </p:cNvPr>
-          <p:cNvCxnSpPr>
-            <a:cxnSpLocks/>
-          </p:cNvCxnSpPr>
-          <p:nvPr/>
-        </p:nvCxnSpPr>
-        <p:spPr>
-          <a:xfrm flipH="1">
-            <a:off x="5225456" y="8334375"/>
-            <a:ext cx="9526" cy="313747"/>
-          </a:xfrm>
-          <a:prstGeom prst="straightConnector1">
-            <a:avLst/>
-          </a:prstGeom>
-          <a:ln>
-            <a:tailEnd type="triangle"/>
-          </a:ln>
-        </p:spPr>
-        <p:style>
-          <a:lnRef idx="3">
-            <a:schemeClr val="accent1"/>
-          </a:lnRef>
-          <a:fillRef idx="0">
-            <a:schemeClr val="accent1"/>
-          </a:fillRef>
-          <a:effectRef idx="2">
-            <a:schemeClr val="accent1"/>
-          </a:effectRef>
-          <a:fontRef idx="minor">
-            <a:schemeClr val="tx1"/>
-          </a:fontRef>
-        </p:style>
-      </p:cxnSp>
-      <p:sp>
-        <p:nvSpPr>
-          <p:cNvPr id="44" name="Rectangle 43">
-            <a:extLst>
-              <a:ext uri="{FF2B5EF4-FFF2-40B4-BE49-F238E27FC236}">
-                <a16:creationId xmlns:a16="http://schemas.microsoft.com/office/drawing/2014/main" id="{18BC3F71-301D-B74D-8E87-3247AB52F4BF}"/>
-              </a:ext>
-            </a:extLst>
-          </p:cNvPr>
-          <p:cNvSpPr/>
-          <p:nvPr/>
-        </p:nvSpPr>
-        <p:spPr>
-          <a:xfrm>
-            <a:off x="4332865" y="10147960"/>
-            <a:ext cx="2346918" cy="1778964"/>
-          </a:xfrm>
-          <a:prstGeom prst="rect">
-            <a:avLst/>
-          </a:prstGeom>
-          <a:solidFill>
-            <a:schemeClr val="accent1">
-              <a:lumMod val="40000"/>
-              <a:lumOff val="60000"/>
-            </a:schemeClr>
-          </a:solidFill>
-        </p:spPr>
-        <p:style>
-          <a:lnRef idx="2">
-            <a:schemeClr val="accent1">
-              <a:shade val="15000"/>
-            </a:schemeClr>
-          </a:lnRef>
-          <a:fillRef idx="1">
-            <a:schemeClr val="accent1"/>
-          </a:fillRef>
-          <a:effectRef idx="0">
-            <a:schemeClr val="accent1"/>
-          </a:effectRef>
-          <a:fontRef idx="minor">
-            <a:schemeClr val="lt1"/>
-          </a:fontRef>
-        </p:style>
-        <p:txBody>
-          <a:bodyPr numCol="1" rtlCol="0" anchor="ctr"/>
-          <a:lstStyle/>
-          <a:p>
-            <a:pPr algn="ctr"/>
-            <a:r>
-              <a:rPr lang="en-US" sz="1200" dirty="0">
-                <a:solidFill>
-                  <a:schemeClr val="tx1"/>
-                </a:solidFill>
-                <a:latin typeface="Abadi" panose="020B0604020104020204" pitchFamily="34" charset="0"/>
-              </a:rPr>
-              <a:t>FOUR FINAL DATASETS</a:t>
-            </a:r>
-          </a:p>
-          <a:p>
-            <a:pPr algn="ctr"/>
-            <a:endParaRPr lang="en-US" sz="1200" dirty="0">
-              <a:solidFill>
-                <a:schemeClr val="tx1"/>
-              </a:solidFill>
-              <a:latin typeface="Abadi" panose="020B0604020104020204" pitchFamily="34" charset="0"/>
-            </a:endParaRPr>
-          </a:p>
-          <a:p>
-            <a:pPr marL="228600" indent="-228600">
-              <a:buFont typeface="+mj-lt"/>
-              <a:buAutoNum type="arabicPeriod"/>
-            </a:pPr>
-            <a:r>
-              <a:rPr lang="en-US" sz="1200" dirty="0" err="1">
-                <a:solidFill>
-                  <a:schemeClr val="tx1"/>
-                </a:solidFill>
-                <a:latin typeface="Abadi" panose="020B0604020104020204" pitchFamily="34" charset="0"/>
-              </a:rPr>
-              <a:t>Canonical_splice_sites.bed</a:t>
-            </a:r>
-            <a:endParaRPr lang="en-US" sz="1200" dirty="0">
-              <a:solidFill>
-                <a:schemeClr val="tx1"/>
-              </a:solidFill>
-              <a:latin typeface="Abadi" panose="020B0604020104020204" pitchFamily="34" charset="0"/>
-            </a:endParaRPr>
-          </a:p>
-          <a:p>
-            <a:pPr marL="228600" indent="-228600">
-              <a:buFont typeface="+mj-lt"/>
-              <a:buAutoNum type="arabicPeriod"/>
-            </a:pPr>
-            <a:r>
-              <a:rPr lang="en-US" sz="1200" dirty="0">
-                <a:solidFill>
-                  <a:schemeClr val="tx1"/>
-                </a:solidFill>
-                <a:latin typeface="Abadi" panose="020B0604020104020204" pitchFamily="34" charset="0"/>
-              </a:rPr>
-              <a:t>Alt5_splice_sites.bed</a:t>
-            </a:r>
-          </a:p>
-          <a:p>
-            <a:pPr marL="228600" indent="-228600">
-              <a:buFont typeface="+mj-lt"/>
-              <a:buAutoNum type="arabicPeriod"/>
-            </a:pPr>
-            <a:r>
-              <a:rPr lang="en-US" sz="1200" dirty="0" err="1">
-                <a:solidFill>
-                  <a:schemeClr val="tx1"/>
-                </a:solidFill>
-                <a:latin typeface="Abadi" panose="020B0604020104020204" pitchFamily="34" charset="0"/>
-              </a:rPr>
-              <a:t>Decoys.bed</a:t>
-            </a:r>
-            <a:endParaRPr lang="en-US" sz="1200" dirty="0">
-              <a:solidFill>
-                <a:schemeClr val="tx1"/>
-              </a:solidFill>
-              <a:latin typeface="Abadi" panose="020B0604020104020204" pitchFamily="34" charset="0"/>
-            </a:endParaRPr>
-          </a:p>
-          <a:p>
-            <a:pPr marL="228600" indent="-228600">
-              <a:buFont typeface="+mj-lt"/>
-              <a:buAutoNum type="arabicPeriod"/>
-            </a:pPr>
-            <a:r>
-              <a:rPr lang="en-US" sz="1200" dirty="0" err="1">
-                <a:solidFill>
-                  <a:schemeClr val="tx1"/>
-                </a:solidFill>
-                <a:latin typeface="Abadi" panose="020B0604020104020204" pitchFamily="34" charset="0"/>
-              </a:rPr>
-              <a:t>Cryptics_supported.bed</a:t>
-            </a:r>
-            <a:endParaRPr lang="en-US" sz="1200" dirty="0">
-              <a:solidFill>
-                <a:schemeClr val="tx1"/>
-              </a:solidFill>
-              <a:latin typeface="Abadi" panose="020B0604020104020204" pitchFamily="34" charset="0"/>
-            </a:endParaRPr>
-          </a:p>
-        </p:txBody>
-      </p:sp>
-      <p:sp>
-        <p:nvSpPr>
-          <p:cNvPr id="46" name="Rectangle 45">
-            <a:extLst>
-              <a:ext uri="{FF2B5EF4-FFF2-40B4-BE49-F238E27FC236}">
-                <a16:creationId xmlns:a16="http://schemas.microsoft.com/office/drawing/2014/main" id="{D0EBDD17-E857-FAD9-ECF4-2CDFD6B87B2B}"/>
-              </a:ext>
-            </a:extLst>
-          </p:cNvPr>
-          <p:cNvSpPr/>
-          <p:nvPr/>
-        </p:nvSpPr>
-        <p:spPr>
-          <a:xfrm>
-            <a:off x="4870173" y="9953343"/>
-            <a:ext cx="1272301" cy="393700"/>
-          </a:xfrm>
-          <a:prstGeom prst="rect">
-            <a:avLst/>
-          </a:prstGeom>
-          <a:ln w="19050">
-            <a:solidFill>
-              <a:schemeClr val="tx1"/>
-            </a:solidFill>
-          </a:ln>
-        </p:spPr>
-        <p:style>
-          <a:lnRef idx="2">
-            <a:schemeClr val="accent1"/>
-          </a:lnRef>
-          <a:fillRef idx="1">
-            <a:schemeClr val="lt1"/>
-          </a:fillRef>
-          <a:effectRef idx="0">
-            <a:schemeClr val="accent1"/>
-          </a:effectRef>
-          <a:fontRef idx="minor">
-            <a:schemeClr val="dk1"/>
-          </a:fontRef>
-        </p:style>
-        <p:txBody>
-          <a:bodyPr rtlCol="0" anchor="ctr"/>
-          <a:lstStyle/>
-          <a:p>
-            <a:pPr algn="ctr"/>
-            <a:r>
-              <a:rPr lang="en-US" b="1" dirty="0">
-                <a:latin typeface="Raleway" pitchFamily="2" charset="0"/>
-                <a:cs typeface="Posterama" panose="020B0504020200020000" pitchFamily="34" charset="0"/>
-              </a:rPr>
-              <a:t>Result</a:t>
-            </a:r>
-            <a:endParaRPr lang="en-GB" b="1" dirty="0">
-              <a:latin typeface="Raleway" pitchFamily="2" charset="0"/>
-              <a:cs typeface="Posterama" panose="020B0504020200020000" pitchFamily="34" charset="0"/>
-            </a:endParaRPr>
-          </a:p>
-        </p:txBody>
-      </p:sp>
-      <p:cxnSp>
-        <p:nvCxnSpPr>
-          <p:cNvPr id="47" name="Straight Arrow Connector 46">
-            <a:extLst>
-              <a:ext uri="{FF2B5EF4-FFF2-40B4-BE49-F238E27FC236}">
-                <a16:creationId xmlns:a16="http://schemas.microsoft.com/office/drawing/2014/main" id="{9A29C1C3-045C-E477-9C9C-368BABC9DC23}"/>
-              </a:ext>
-            </a:extLst>
-          </p:cNvPr>
-          <p:cNvCxnSpPr>
-            <a:cxnSpLocks/>
-          </p:cNvCxnSpPr>
-          <p:nvPr/>
-        </p:nvCxnSpPr>
-        <p:spPr>
-          <a:xfrm>
-            <a:off x="5483504" y="9507483"/>
-            <a:ext cx="0" cy="445860"/>
-          </a:xfrm>
-          <a:prstGeom prst="straightConnector1">
-            <a:avLst/>
-          </a:prstGeom>
-          <a:ln>
-            <a:tailEnd type="triangle"/>
-          </a:ln>
-        </p:spPr>
-        <p:style>
-          <a:lnRef idx="3">
-            <a:schemeClr val="accent1"/>
-          </a:lnRef>
-          <a:fillRef idx="0">
-            <a:schemeClr val="accent1"/>
-          </a:fillRef>
-          <a:effectRef idx="2">
-            <a:schemeClr val="accent1"/>
-          </a:effectRef>
-          <a:fontRef idx="minor">
-            <a:schemeClr val="tx1"/>
-          </a:fontRef>
-        </p:style>
-      </p:cxnSp>
-      <p:cxnSp>
-        <p:nvCxnSpPr>
-          <p:cNvPr id="48" name="Straight Arrow Connector 47">
-            <a:extLst>
-              <a:ext uri="{FF2B5EF4-FFF2-40B4-BE49-F238E27FC236}">
-                <a16:creationId xmlns:a16="http://schemas.microsoft.com/office/drawing/2014/main" id="{73DE3673-D041-6C3D-F22F-5B45B2F6FF1B}"/>
-              </a:ext>
-            </a:extLst>
-          </p:cNvPr>
-          <p:cNvCxnSpPr>
-            <a:cxnSpLocks/>
-          </p:cNvCxnSpPr>
-          <p:nvPr/>
-        </p:nvCxnSpPr>
-        <p:spPr>
-          <a:xfrm flipV="1">
-            <a:off x="3046115" y="11499144"/>
-            <a:ext cx="1245754" cy="280073"/>
-          </a:xfrm>
-          <a:prstGeom prst="straightConnector1">
-            <a:avLst/>
-          </a:prstGeom>
-          <a:ln>
-            <a:tailEnd type="triangle"/>
-          </a:ln>
-        </p:spPr>
-        <p:style>
-          <a:lnRef idx="3">
-            <a:schemeClr val="accent1"/>
-          </a:lnRef>
-          <a:fillRef idx="0">
-            <a:schemeClr val="accent1"/>
-          </a:fillRef>
-          <a:effectRef idx="2">
-            <a:schemeClr val="accent1"/>
-          </a:effectRef>
-          <a:fontRef idx="minor">
-            <a:schemeClr val="tx1"/>
-          </a:fontRef>
-        </p:style>
-      </p:cxnSp>
-      <p:sp>
-        <p:nvSpPr>
-          <p:cNvPr id="5" name="TextBox 4">
-            <a:extLst>
-              <a:ext uri="{FF2B5EF4-FFF2-40B4-BE49-F238E27FC236}">
-                <a16:creationId xmlns:a16="http://schemas.microsoft.com/office/drawing/2014/main" id="{D467D879-2CAF-EB74-F0CE-F506D82A7E60}"/>
-              </a:ext>
-            </a:extLst>
-          </p:cNvPr>
-          <p:cNvSpPr txBox="1"/>
-          <p:nvPr/>
-        </p:nvSpPr>
-        <p:spPr>
-          <a:xfrm>
-            <a:off x="0" y="0"/>
-            <a:ext cx="2603500" cy="523220"/>
-          </a:xfrm>
-          <a:prstGeom prst="rect">
-            <a:avLst/>
-          </a:prstGeom>
-          <a:noFill/>
-        </p:spPr>
-        <p:txBody>
-          <a:bodyPr wrap="square" rtlCol="0">
-            <a:spAutoFit/>
-          </a:bodyPr>
-          <a:lstStyle/>
-          <a:p>
-            <a:r>
-              <a:rPr lang="en-US" sz="2800" dirty="0"/>
-              <a:t>NEW Proposal</a:t>
-            </a:r>
-            <a:endParaRPr lang="en-GB" sz="2800" dirty="0"/>
-          </a:p>
-        </p:txBody>
-      </p:sp>
-      <p:sp>
-        <p:nvSpPr>
-          <p:cNvPr id="12" name="Star: 5 Points 11">
-            <a:extLst>
-              <a:ext uri="{FF2B5EF4-FFF2-40B4-BE49-F238E27FC236}">
-                <a16:creationId xmlns:a16="http://schemas.microsoft.com/office/drawing/2014/main" id="{02A84F7B-65EF-C365-CE3B-DA1A4F4310DE}"/>
-              </a:ext>
-            </a:extLst>
-          </p:cNvPr>
-          <p:cNvSpPr/>
-          <p:nvPr/>
-        </p:nvSpPr>
-        <p:spPr>
-          <a:xfrm>
-            <a:off x="431756" y="3971925"/>
-            <a:ext cx="525671" cy="470504"/>
-          </a:xfrm>
-          <a:prstGeom prst="star5">
-            <a:avLst/>
-          </a:prstGeom>
-        </p:spPr>
-        <p:style>
-          <a:lnRef idx="2">
-            <a:schemeClr val="accent1">
-              <a:shade val="15000"/>
-            </a:schemeClr>
-          </a:lnRef>
-          <a:fillRef idx="1">
-            <a:schemeClr val="accent1"/>
-          </a:fillRef>
-          <a:effectRef idx="0">
-            <a:schemeClr val="accent1"/>
-          </a:effectRef>
-          <a:fontRef idx="minor">
-            <a:schemeClr val="lt1"/>
-          </a:fontRef>
-        </p:style>
-        <p:txBody>
-          <a:bodyPr rtlCol="0" anchor="ctr"/>
-          <a:lstStyle/>
-          <a:p>
-            <a:pPr algn="ctr"/>
-            <a:endParaRPr lang="en-GB"/>
-          </a:p>
-        </p:txBody>
-      </p:sp>
-      <p:cxnSp>
-        <p:nvCxnSpPr>
-          <p:cNvPr id="13" name="Straight Arrow Connector 12">
-            <a:extLst>
-              <a:ext uri="{FF2B5EF4-FFF2-40B4-BE49-F238E27FC236}">
-                <a16:creationId xmlns:a16="http://schemas.microsoft.com/office/drawing/2014/main" id="{5F794447-796E-91E8-B98B-2DC0DF124375}"/>
-              </a:ext>
-            </a:extLst>
-          </p:cNvPr>
-          <p:cNvCxnSpPr>
-            <a:cxnSpLocks/>
-          </p:cNvCxnSpPr>
-          <p:nvPr/>
-        </p:nvCxnSpPr>
-        <p:spPr>
-          <a:xfrm>
-            <a:off x="168920" y="497244"/>
-            <a:ext cx="405690" cy="3398924"/>
-          </a:xfrm>
-          <a:prstGeom prst="straightConnector1">
-            <a:avLst/>
-          </a:prstGeom>
-          <a:ln>
-            <a:tailEnd type="triangle"/>
-          </a:ln>
-        </p:spPr>
-        <p:style>
-          <a:lnRef idx="3">
-            <a:schemeClr val="accent1"/>
-          </a:lnRef>
-          <a:fillRef idx="0">
-            <a:schemeClr val="accent1"/>
-          </a:fillRef>
-          <a:effectRef idx="2">
-            <a:schemeClr val="accent1"/>
-          </a:effectRef>
-          <a:fontRef idx="minor">
-            <a:schemeClr val="tx1"/>
-          </a:fontRef>
-        </p:style>
-      </p:cxnSp>
-    </p:spTree>
-    <p:extLst>
-      <p:ext uri="{BB962C8B-B14F-4D97-AF65-F5344CB8AC3E}">
-        <p14:creationId xmlns:p14="http://schemas.microsoft.com/office/powerpoint/2010/main" val="2048028097"/>
-      </p:ext>
-    </p:extLst>
-  </p:cSld>
-  <p:clrMapOvr>
-    <a:masterClrMapping/>
-  </p:clrMapOvr>
-</p:sld>
-</file>
-
-<file path=ppt/slides/slide3.xml><?xml version="1.0" encoding="utf-8"?>
-<p:sld xmlns:a="http://schemas.openxmlformats.org/drawingml/2006/main" xmlns:r="http://schemas.openxmlformats.org/officeDocument/2006/relationships" xmlns:p="http://schemas.openxmlformats.org/presentationml/2006/main">
-  <p:cSld>
-    <p:spTree>
-      <p:nvGrpSpPr>
-        <p:cNvPr id="1" name="">
-          <a:extLst>
-            <a:ext uri="{FF2B5EF4-FFF2-40B4-BE49-F238E27FC236}">
-              <a16:creationId xmlns:a16="http://schemas.microsoft.com/office/drawing/2014/main" id="{5439C57A-A402-852A-5A46-980E0F9068A7}"/>
-            </a:ext>
-          </a:extLst>
-        </p:cNvPr>
-        <p:cNvGrpSpPr/>
-        <p:nvPr/>
-      </p:nvGrpSpPr>
-      <p:grpSpPr>
-        <a:xfrm>
-          <a:off x="0" y="0"/>
-          <a:ext cx="0" cy="0"/>
-          <a:chOff x="0" y="0"/>
-          <a:chExt cx="0" cy="0"/>
-        </a:xfrm>
-      </p:grpSpPr>
       <p:sp>
         <p:nvSpPr>
           <p:cNvPr id="4" name="Rectangle 3">
@@ -10426,19 +7022,19 @@
           <a:p>
             <a:pPr algn="ctr"/>
             <a:r>
-              <a:rPr lang="en-US" sz="1400" dirty="0">
+              <a:rPr lang="en-US" sz="1200" dirty="0">
                 <a:solidFill>
                   <a:sysClr val="windowText" lastClr="000000"/>
                 </a:solidFill>
                 <a:latin typeface="Abadi" panose="020B0604020104020204" pitchFamily="34" charset="0"/>
               </a:rPr>
-              <a:t>Extract 5’ splice sites from PSI-TABLE to filter loci within +-50 bp of 5’ canonical splice site</a:t>
+              <a:t>Extract 5’ splice sites from PSI-TABLE to filter loci within +-50 bp of 5’ canonical splice site (192,965 SS coords each)</a:t>
             </a:r>
           </a:p>
           <a:p>
             <a:pPr algn="ctr"/>
             <a:r>
-              <a:rPr lang="en-US" sz="1400" dirty="0" err="1">
+              <a:rPr lang="en-US" sz="1200" dirty="0" err="1">
                 <a:solidFill>
                   <a:schemeClr val="accent1"/>
                 </a:solidFill>
@@ -10446,7 +7042,7 @@
               </a:rPr>
               <a:t>Canonical_splice_sites.bed</a:t>
             </a:r>
-            <a:endParaRPr lang="en-US" sz="1400" dirty="0">
+            <a:endParaRPr lang="en-US" sz="1200" dirty="0">
               <a:solidFill>
                 <a:schemeClr val="accent1"/>
               </a:solidFill>
@@ -10456,7 +7052,7 @@
           <a:p>
             <a:pPr algn="ctr"/>
             <a:r>
-              <a:rPr lang="en-US" sz="1400" dirty="0" err="1">
+              <a:rPr lang="en-US" sz="1200" dirty="0" err="1">
                 <a:solidFill>
                   <a:schemeClr val="accent1"/>
                 </a:solidFill>
@@ -10464,7 +7060,7 @@
               </a:rPr>
               <a:t>Wide_canonical_splice_sites.bed</a:t>
             </a:r>
-            <a:endParaRPr lang="en-US" sz="1400" dirty="0">
+            <a:endParaRPr lang="en-US" sz="1200" dirty="0">
               <a:solidFill>
                 <a:schemeClr val="accent1"/>
               </a:solidFill>
@@ -10629,20 +7225,26 @@
           <a:p>
             <a:pPr algn="ctr"/>
             <a:r>
-              <a:rPr lang="en-US" sz="1400" dirty="0" err="1">
+              <a:rPr lang="en-US" sz="1400" dirty="0">
                 <a:solidFill>
                   <a:schemeClr val="accent1"/>
                 </a:solidFill>
                 <a:latin typeface="Abadi" panose="020B0604020104020204" pitchFamily="34" charset="0"/>
               </a:rPr>
-              <a:t>Protein_coding_sites.bed</a:t>
-            </a:r>
-            <a:endParaRPr lang="en-US" sz="1400" dirty="0">
-              <a:solidFill>
-                <a:schemeClr val="accent1"/>
-              </a:solidFill>
-              <a:latin typeface="Abadi" panose="020B0604020104020204" pitchFamily="34" charset="0"/>
-            </a:endParaRPr>
+              <a:t>spliceai_05min_proteincoding.bed</a:t>
+            </a:r>
+          </a:p>
+          <a:p>
+            <a:pPr algn="ctr"/>
+            <a:r>
+              <a:rPr lang="en-US" sz="1400" dirty="0">
+                <a:solidFill>
+                  <a:schemeClr val="tx1"/>
+                </a:solidFill>
+                <a:latin typeface="Abadi" panose="020B0604020104020204" pitchFamily="34" charset="0"/>
+              </a:rPr>
+              <a:t>550,282 splice site inferences</a:t>
+            </a:r>
           </a:p>
         </p:txBody>
       </p:sp>
@@ -10660,7 +7262,7 @@
         </p:nvSpPr>
         <p:spPr>
           <a:xfrm>
-            <a:off x="2127250" y="1843456"/>
+            <a:off x="2127250" y="1805356"/>
             <a:ext cx="2603500" cy="393700"/>
           </a:xfrm>
           <a:prstGeom prst="rect">
@@ -10754,7 +7356,7 @@
           <a:p>
             <a:pPr algn="ctr"/>
             <a:r>
-              <a:rPr lang="en-GB" sz="1400" dirty="0">
+              <a:rPr lang="en-GB" sz="1100" dirty="0">
                 <a:solidFill>
                   <a:sysClr val="windowText" lastClr="000000"/>
                 </a:solidFill>
@@ -10764,7 +7366,7 @@
               <a:t>bedtools intersect -v (no overlap) </a:t>
             </a:r>
             <a:r>
-              <a:rPr lang="en-GB" sz="1400" dirty="0" err="1">
+              <a:rPr lang="en-GB" sz="1100" dirty="0" err="1">
                 <a:solidFill>
                   <a:sysClr val="windowText" lastClr="000000"/>
                 </a:solidFill>
@@ -10774,7 +7376,7 @@
               <a:t>Wide_canonical_splice_sites.bed</a:t>
             </a:r>
             <a:br>
-              <a:rPr lang="en-GB" sz="1400" dirty="0">
+              <a:rPr lang="en-GB" sz="1100" dirty="0">
                 <a:solidFill>
                   <a:sysClr val="windowText" lastClr="000000"/>
                 </a:solidFill>
@@ -10783,7 +7385,7 @@
               </a:rPr>
             </a:br>
             <a:r>
-              <a:rPr lang="en-GB" sz="1400" dirty="0">
+              <a:rPr lang="en-GB" sz="1100" dirty="0">
                 <a:solidFill>
                   <a:sysClr val="windowText" lastClr="000000"/>
                 </a:solidFill>
@@ -10793,7 +7395,7 @@
               <a:t>== </a:t>
             </a:r>
             <a:r>
-              <a:rPr lang="en-GB" sz="1400" dirty="0" err="1">
+              <a:rPr lang="en-GB" sz="1100" dirty="0" err="1">
                 <a:solidFill>
                   <a:schemeClr val="accent1"/>
                 </a:solidFill>
@@ -10802,9 +7404,9 @@
               </a:rPr>
               <a:t>deep_intronic_sites.bed</a:t>
             </a:r>
-            <a:endParaRPr lang="en-GB" sz="1400" dirty="0">
+            <a:endParaRPr lang="en-GB" sz="1100" dirty="0">
               <a:solidFill>
-                <a:sysClr val="windowText" lastClr="000000"/>
+                <a:schemeClr val="accent1"/>
               </a:solidFill>
               <a:latin typeface="SimHei" panose="020B0503020204020204" pitchFamily="49" charset="-122"/>
               <a:ea typeface="SimHei" panose="020B0503020204020204" pitchFamily="49" charset="-122"/>
@@ -10813,7 +7415,26 @@
           <a:p>
             <a:pPr algn="ctr"/>
             <a:r>
-              <a:rPr lang="en-GB" sz="1400" dirty="0">
+              <a:rPr lang="en-US" sz="1100" dirty="0">
+                <a:solidFill>
+                  <a:sysClr val="windowText" lastClr="000000"/>
+                </a:solidFill>
+                <a:latin typeface="Abadi" panose="020B0604020104020204" pitchFamily="34" charset="0"/>
+              </a:rPr>
+              <a:t>367,089 splice site inferences</a:t>
+            </a:r>
+            <a:endParaRPr lang="en-GB" sz="1100" dirty="0">
+              <a:solidFill>
+                <a:schemeClr val="tx1"/>
+              </a:solidFill>
+              <a:latin typeface="SimHei" panose="020B0503020204020204" pitchFamily="49" charset="-122"/>
+              <a:ea typeface="SimHei" panose="020B0503020204020204" pitchFamily="49" charset="-122"/>
+            </a:endParaRPr>
+          </a:p>
+          <a:p>
+            <a:pPr algn="ctr"/>
+            <a:r>
+              <a:rPr lang="en-GB" sz="1100" dirty="0">
                 <a:solidFill>
                   <a:sysClr val="windowText" lastClr="000000"/>
                 </a:solidFill>
@@ -10823,7 +7444,7 @@
               <a:t>bedtools intersect -c (does overlap) </a:t>
             </a:r>
             <a:r>
-              <a:rPr lang="en-GB" sz="1400" dirty="0" err="1">
+              <a:rPr lang="en-GB" sz="1100" dirty="0" err="1">
                 <a:solidFill>
                   <a:sysClr val="windowText" lastClr="000000"/>
                 </a:solidFill>
@@ -10833,7 +7454,7 @@
               <a:t>Wide_canonical_splice_sites.bed</a:t>
             </a:r>
             <a:br>
-              <a:rPr lang="en-GB" sz="1400" dirty="0">
+              <a:rPr lang="en-GB" sz="1100" dirty="0">
                 <a:solidFill>
                   <a:sysClr val="windowText" lastClr="000000"/>
                 </a:solidFill>
@@ -10842,7 +7463,7 @@
               </a:rPr>
             </a:br>
             <a:r>
-              <a:rPr lang="en-GB" sz="1400" dirty="0">
+              <a:rPr lang="en-GB" sz="1100" dirty="0">
                 <a:solidFill>
                   <a:sysClr val="windowText" lastClr="000000"/>
                 </a:solidFill>
@@ -10852,7 +7473,7 @@
               <a:t>== </a:t>
             </a:r>
             <a:r>
-              <a:rPr lang="en-GB" sz="1400" dirty="0" err="1">
+              <a:rPr lang="en-GB" sz="1100" dirty="0" err="1">
                 <a:solidFill>
                   <a:schemeClr val="accent1"/>
                 </a:solidFill>
@@ -10861,9 +7482,28 @@
               </a:rPr>
               <a:t>exonic.bed</a:t>
             </a:r>
-            <a:endParaRPr lang="en-US" sz="1400" dirty="0">
+            <a:endParaRPr lang="en-GB" sz="1100" dirty="0">
               <a:solidFill>
                 <a:schemeClr val="accent1"/>
+              </a:solidFill>
+              <a:latin typeface="SimHei" panose="020B0503020204020204" pitchFamily="49" charset="-122"/>
+              <a:ea typeface="SimHei" panose="020B0503020204020204" pitchFamily="49" charset="-122"/>
+            </a:endParaRPr>
+          </a:p>
+          <a:p>
+            <a:pPr algn="ctr"/>
+            <a:r>
+              <a:rPr lang="en-US" sz="1100" dirty="0">
+                <a:solidFill>
+                  <a:sysClr val="windowText" lastClr="000000"/>
+                </a:solidFill>
+                <a:latin typeface="Abadi" panose="020B0604020104020204" pitchFamily="34" charset="0"/>
+              </a:rPr>
+              <a:t>183,193 splice site inferences</a:t>
+            </a:r>
+            <a:endParaRPr lang="en-GB" sz="1100" dirty="0">
+              <a:solidFill>
+                <a:sysClr val="windowText" lastClr="000000"/>
               </a:solidFill>
               <a:latin typeface="Abadi" panose="020B0604020104020204" pitchFamily="34" charset="0"/>
             </a:endParaRPr>
@@ -10884,7 +7524,7 @@
         </p:nvSpPr>
         <p:spPr>
           <a:xfrm>
-            <a:off x="2127250" y="5045458"/>
+            <a:off x="2127250" y="5007358"/>
             <a:ext cx="2603500" cy="393700"/>
           </a:xfrm>
           <a:prstGeom prst="rect">
@@ -11002,8 +7642,8 @@
         </p:nvSpPr>
         <p:spPr>
           <a:xfrm>
-            <a:off x="192410" y="6734386"/>
-            <a:ext cx="6473179" cy="1132482"/>
+            <a:off x="192410" y="6583419"/>
+            <a:ext cx="6473179" cy="1283449"/>
           </a:xfrm>
           <a:prstGeom prst="rect">
             <a:avLst/>
@@ -11161,12 +7801,27 @@
               </a:rPr>
               <a:t>decoys.bed</a:t>
             </a:r>
-            <a:endParaRPr lang="en-US" sz="1200" dirty="0">
-              <a:solidFill>
-                <a:schemeClr val="tx1"/>
-              </a:solidFill>
-              <a:latin typeface="Abadi" panose="020B0604020104020204" pitchFamily="34" charset="0"/>
-            </a:endParaRPr>
+            <a:r>
+              <a:rPr lang="en-US" sz="1200" dirty="0">
+                <a:solidFill>
+                  <a:schemeClr val="tx1"/>
+                </a:solidFill>
+                <a:latin typeface="Abadi" panose="020B0604020104020204" pitchFamily="34" charset="0"/>
+              </a:rPr>
+              <a:t> </a:t>
+            </a:r>
+          </a:p>
+          <a:p>
+            <a:pPr algn="ctr"/>
+            <a:r>
+              <a:rPr lang="en-US" sz="1200" dirty="0">
+                <a:solidFill>
+                  <a:schemeClr val="tx1"/>
+                </a:solidFill>
+                <a:latin typeface="Abadi" panose="020B0604020104020204" pitchFamily="34" charset="0"/>
+              </a:rPr>
+              <a:t>19,942 decoy sites</a:t>
+            </a:r>
           </a:p>
           <a:p>
             <a:pPr algn="ctr"/>
@@ -11295,12 +7950,23 @@
               </a:rPr>
               <a:t>cryptic_sites.bed</a:t>
             </a:r>
-            <a:endParaRPr lang="en-US" sz="1200" dirty="0">
-              <a:solidFill>
-                <a:schemeClr val="tx1"/>
-              </a:solidFill>
-              <a:latin typeface="Abadi" panose="020B0604020104020204" pitchFamily="34" charset="0"/>
-            </a:endParaRPr>
+            <a:br>
+              <a:rPr lang="en-US" sz="1200" dirty="0">
+                <a:solidFill>
+                  <a:schemeClr val="tx1"/>
+                </a:solidFill>
+                <a:latin typeface="Abadi" panose="020B0604020104020204" pitchFamily="34" charset="0"/>
+              </a:rPr>
+            </a:br>
+            <a:r>
+              <a:rPr lang="en-US" sz="1200" dirty="0">
+                <a:solidFill>
+                  <a:schemeClr val="tx1"/>
+                </a:solidFill>
+                <a:latin typeface="Abadi" panose="020B0604020104020204" pitchFamily="34" charset="0"/>
+              </a:rPr>
+              <a:t>267,309 splice sites</a:t>
+            </a:r>
           </a:p>
         </p:txBody>
       </p:sp>
@@ -11318,8 +7984,8 @@
         </p:nvSpPr>
         <p:spPr>
           <a:xfrm>
-            <a:off x="1388756" y="8188935"/>
-            <a:ext cx="4391691" cy="1876706"/>
+            <a:off x="1057103" y="8043538"/>
+            <a:ext cx="5256572" cy="1688347"/>
           </a:xfrm>
           <a:prstGeom prst="rect">
             <a:avLst/>
@@ -11397,9 +8063,6 @@
               </a:rPr>
               <a:t> PRPF8 predictions </a:t>
             </a:r>
-          </a:p>
-          <a:p>
-            <a:pPr algn="ctr"/>
             <a:r>
               <a:rPr lang="en-US" sz="1200" dirty="0">
                 <a:solidFill>
@@ -11418,9 +8081,6 @@
               </a:rPr>
               <a:t>PRPF8 Peaks </a:t>
             </a:r>
-          </a:p>
-          <a:p>
-            <a:pPr algn="ctr"/>
             <a:r>
               <a:rPr lang="en-US" sz="1200" dirty="0">
                 <a:solidFill>
@@ -11604,6 +8264,24 @@
                 <a:latin typeface="Abadi" panose="020B0604020104020204" pitchFamily="34" charset="0"/>
               </a:rPr>
               <a:t>cryptics_supported.bed</a:t>
+            </a:r>
+            <a:endParaRPr lang="en-US" sz="1200" dirty="0">
+              <a:solidFill>
+                <a:schemeClr val="accent1"/>
+              </a:solidFill>
+              <a:latin typeface="Abadi" panose="020B0604020104020204" pitchFamily="34" charset="0"/>
+            </a:endParaRPr>
+          </a:p>
+          <a:p>
+            <a:pPr algn="ctr"/>
+            <a:r>
+              <a:rPr lang="en-US" sz="1200" dirty="0">
+                <a:solidFill>
+                  <a:schemeClr val="tx1"/>
+                </a:solidFill>
+                <a:latin typeface="Abadi" panose="020B0604020104020204" pitchFamily="34" charset="0"/>
+              </a:rPr>
+              <a:t>191,904 splice sites</a:t>
             </a:r>
             <a:endParaRPr lang="en-US" sz="1200" dirty="0">
               <a:solidFill>
@@ -11631,7 +8309,7 @@
         <p:spPr>
           <a:xfrm>
             <a:off x="2717800" y="6270146"/>
-            <a:ext cx="622300" cy="641477"/>
+            <a:ext cx="125138" cy="373965"/>
           </a:xfrm>
           <a:prstGeom prst="straightConnector1">
             <a:avLst/>
@@ -11669,8 +8347,8 @@
         </p:nvSpPr>
         <p:spPr>
           <a:xfrm>
-            <a:off x="2438455" y="10896599"/>
-            <a:ext cx="2292295" cy="993725"/>
+            <a:off x="192411" y="10394835"/>
+            <a:ext cx="2284090" cy="1606665"/>
           </a:xfrm>
           <a:prstGeom prst="rect">
             <a:avLst/>
@@ -11714,7 +8392,31 @@
             </a:r>
           </a:p>
           <a:p>
-            <a:pPr algn="ctr"/>
+            <a:pPr marL="228600" indent="-228600">
+              <a:buFont typeface="+mj-lt"/>
+              <a:buAutoNum type="arabicPeriod"/>
+            </a:pPr>
+            <a:r>
+              <a:rPr lang="en-US" sz="1200" dirty="0">
+                <a:solidFill>
+                  <a:schemeClr val="tx1"/>
+                </a:solidFill>
+                <a:latin typeface="Abadi" panose="020B0604020104020204" pitchFamily="34" charset="0"/>
+              </a:rPr>
+              <a:t>Loci Feature Table</a:t>
+            </a:r>
+          </a:p>
+          <a:p>
+            <a:pPr lvl="1"/>
+            <a:r>
+              <a:rPr lang="en-US" sz="1200" dirty="0" err="1">
+                <a:solidFill>
+                  <a:schemeClr val="tx1"/>
+                </a:solidFill>
+                <a:latin typeface="Abadi" panose="020B0604020104020204" pitchFamily="34" charset="0"/>
+              </a:rPr>
+              <a:t>Decoys.bed</a:t>
+            </a:r>
             <a:endParaRPr lang="en-US" sz="1200" dirty="0">
               <a:solidFill>
                 <a:schemeClr val="tx1"/>
@@ -11723,10 +8425,7 @@
             </a:endParaRPr>
           </a:p>
           <a:p>
-            <a:pPr marL="228600" indent="-228600">
-              <a:buFont typeface="+mj-lt"/>
-              <a:buAutoNum type="arabicPeriod"/>
-            </a:pPr>
+            <a:pPr lvl="1"/>
             <a:r>
               <a:rPr lang="en-US" sz="1200" dirty="0" err="1">
                 <a:solidFill>
@@ -11734,7 +8433,7 @@
                 </a:solidFill>
                 <a:latin typeface="Abadi" panose="020B0604020104020204" pitchFamily="34" charset="0"/>
               </a:rPr>
-              <a:t>Decoys.bed</a:t>
+              <a:t>Cryptics_supported.bed</a:t>
             </a:r>
             <a:endParaRPr lang="en-US" sz="1200" dirty="0">
               <a:solidFill>
@@ -11749,20 +8448,26 @@
               <a:buAutoNum type="arabicPeriod"/>
             </a:pPr>
             <a:r>
-              <a:rPr lang="en-US" sz="1200" dirty="0" err="1">
+              <a:rPr lang="en-US" sz="1200" dirty="0">
                 <a:solidFill>
                   <a:schemeClr val="tx1"/>
                 </a:solidFill>
                 <a:latin typeface="Abadi" panose="020B0604020104020204" pitchFamily="34" charset="0"/>
               </a:rPr>
-              <a:t>Cryptics_supported.bed</a:t>
-            </a:r>
-            <a:endParaRPr lang="en-US" sz="1200" dirty="0">
-              <a:solidFill>
-                <a:schemeClr val="tx1"/>
-              </a:solidFill>
-              <a:latin typeface="Abadi" panose="020B0604020104020204" pitchFamily="34" charset="0"/>
-            </a:endParaRPr>
+              <a:t>Retained Introns Table</a:t>
+            </a:r>
+          </a:p>
+          <a:p>
+            <a:pPr lvl="1"/>
+            <a:r>
+              <a:rPr lang="en-US" sz="1200" dirty="0">
+                <a:solidFill>
+                  <a:schemeClr val="tx1"/>
+                </a:solidFill>
+                <a:latin typeface="Abadi" panose="020B0604020104020204" pitchFamily="34" charset="0"/>
+              </a:rPr>
+              <a:t>Subgroups (has decoy, has cryptic, neither, both)</a:t>
+            </a:r>
           </a:p>
         </p:txBody>
       </p:sp>
@@ -11780,7 +8485,7 @@
         </p:nvSpPr>
         <p:spPr>
           <a:xfrm>
-            <a:off x="2952943" y="10574533"/>
+            <a:off x="624292" y="10066340"/>
             <a:ext cx="1272301" cy="393700"/>
           </a:xfrm>
           <a:prstGeom prst="rect">
@@ -11840,9 +8545,9 @@
           <p:nvPr/>
         </p:nvCxnSpPr>
         <p:spPr>
-          <a:xfrm>
-            <a:off x="3587804" y="10128673"/>
-            <a:ext cx="0" cy="445860"/>
+          <a:xfrm flipH="1">
+            <a:off x="2373243" y="11341834"/>
+            <a:ext cx="689114" cy="91032"/>
           </a:xfrm>
           <a:prstGeom prst="straightConnector1">
             <a:avLst/>
@@ -11882,8 +8587,8 @@
         </p:nvCxnSpPr>
         <p:spPr>
           <a:xfrm flipH="1">
-            <a:off x="5001413" y="7813171"/>
-            <a:ext cx="154787" cy="1624796"/>
+            <a:off x="5709285" y="7862014"/>
+            <a:ext cx="454123" cy="1047167"/>
           </a:xfrm>
           <a:prstGeom prst="straightConnector1">
             <a:avLst/>
@@ -11907,6 +8612,262 @@
           </a:fontRef>
         </p:style>
       </p:cxnSp>
+      <p:cxnSp>
+        <p:nvCxnSpPr>
+          <p:cNvPr id="3" name="Straight Arrow Connector 2">
+            <a:extLst>
+              <a:ext uri="{FF2B5EF4-FFF2-40B4-BE49-F238E27FC236}">
+                <a16:creationId xmlns:a16="http://schemas.microsoft.com/office/drawing/2014/main" id="{8FD840B3-0833-6599-1CDA-16C7AE8F42FA}"/>
+              </a:ext>
+            </a:extLst>
+          </p:cNvPr>
+          <p:cNvCxnSpPr>
+            <a:cxnSpLocks/>
+          </p:cNvCxnSpPr>
+          <p:nvPr/>
+        </p:nvCxnSpPr>
+        <p:spPr>
+          <a:xfrm>
+            <a:off x="2717800" y="6270146"/>
+            <a:ext cx="1808480" cy="353669"/>
+          </a:xfrm>
+          <a:prstGeom prst="straightConnector1">
+            <a:avLst/>
+          </a:prstGeom>
+          <a:ln>
+            <a:tailEnd type="triangle"/>
+          </a:ln>
+        </p:spPr>
+        <p:style>
+          <a:lnRef idx="3">
+            <a:schemeClr val="accent1"/>
+          </a:lnRef>
+          <a:fillRef idx="0">
+            <a:schemeClr val="accent1"/>
+          </a:fillRef>
+          <a:effectRef idx="2">
+            <a:schemeClr val="accent1"/>
+          </a:effectRef>
+          <a:fontRef idx="minor">
+            <a:schemeClr val="tx1"/>
+          </a:fontRef>
+        </p:style>
+      </p:cxnSp>
+      <p:sp>
+        <p:nvSpPr>
+          <p:cNvPr id="12" name="Rectangle 11">
+            <a:extLst>
+              <a:ext uri="{FF2B5EF4-FFF2-40B4-BE49-F238E27FC236}">
+                <a16:creationId xmlns:a16="http://schemas.microsoft.com/office/drawing/2014/main" id="{C5FEDBBF-5393-D218-FC43-C104DCAF2975}"/>
+              </a:ext>
+            </a:extLst>
+          </p:cNvPr>
+          <p:cNvSpPr/>
+          <p:nvPr/>
+        </p:nvSpPr>
+        <p:spPr>
+          <a:xfrm>
+            <a:off x="2842938" y="10151695"/>
+            <a:ext cx="3822651" cy="1954028"/>
+          </a:xfrm>
+          <a:prstGeom prst="rect">
+            <a:avLst/>
+          </a:prstGeom>
+          <a:solidFill>
+            <a:schemeClr val="accent1">
+              <a:lumMod val="40000"/>
+              <a:lumOff val="60000"/>
+            </a:schemeClr>
+          </a:solidFill>
+        </p:spPr>
+        <p:style>
+          <a:lnRef idx="2">
+            <a:schemeClr val="accent1">
+              <a:shade val="15000"/>
+            </a:schemeClr>
+          </a:lnRef>
+          <a:fillRef idx="1">
+            <a:schemeClr val="accent1"/>
+          </a:fillRef>
+          <a:effectRef idx="0">
+            <a:schemeClr val="accent1"/>
+          </a:effectRef>
+          <a:fontRef idx="minor">
+            <a:schemeClr val="lt1"/>
+          </a:fontRef>
+        </p:style>
+        <p:txBody>
+          <a:bodyPr rtlCol="0" anchor="ctr"/>
+          <a:lstStyle/>
+          <a:p>
+            <a:pPr algn="ctr"/>
+            <a:r>
+              <a:rPr lang="en-US" sz="1200" dirty="0">
+                <a:solidFill>
+                  <a:sysClr val="windowText" lastClr="000000"/>
+                </a:solidFill>
+                <a:latin typeface="Abadi" panose="020B0604020104020204" pitchFamily="34" charset="0"/>
+              </a:rPr>
+              <a:t>Pull FASTA using BED coordinates with SpliceAI_Inference.py to re-score inferences over ±24nt window surrounding the loci, &gt; 0.1 Donor Score</a:t>
+            </a:r>
+          </a:p>
+          <a:p>
+            <a:pPr algn="ctr"/>
+            <a:r>
+              <a:rPr lang="en-US" sz="1200" dirty="0">
+                <a:solidFill>
+                  <a:sysClr val="windowText" lastClr="000000"/>
+                </a:solidFill>
+                <a:latin typeface="Abadi" panose="020B0604020104020204" pitchFamily="34" charset="0"/>
+              </a:rPr>
+              <a:t>7,021 Predicted Decoy Sites </a:t>
+            </a:r>
+          </a:p>
+          <a:p>
+            <a:pPr algn="ctr"/>
+            <a:r>
+              <a:rPr lang="en-US" sz="1200" dirty="0">
+                <a:solidFill>
+                  <a:sysClr val="windowText" lastClr="000000"/>
+                </a:solidFill>
+                <a:latin typeface="Abadi" panose="020B0604020104020204" pitchFamily="34" charset="0"/>
+              </a:rPr>
+              <a:t>18,808 Predicted Cryptic Sites</a:t>
+            </a:r>
+          </a:p>
+          <a:p>
+            <a:pPr marL="171450" indent="-171450" algn="ctr">
+              <a:buFont typeface="Arial" panose="020B0604020202020204" pitchFamily="34" charset="0"/>
+              <a:buChar char="•"/>
+            </a:pPr>
+            <a:endParaRPr lang="en-US" sz="1200" dirty="0">
+              <a:solidFill>
+                <a:sysClr val="windowText" lastClr="000000"/>
+              </a:solidFill>
+              <a:latin typeface="Abadi" panose="020B0604020104020204" pitchFamily="34" charset="0"/>
+            </a:endParaRPr>
+          </a:p>
+          <a:p>
+            <a:pPr algn="ctr"/>
+            <a:r>
+              <a:rPr lang="en-US" sz="1200" dirty="0">
+                <a:solidFill>
+                  <a:schemeClr val="tx1"/>
+                </a:solidFill>
+                <a:latin typeface="Abadi" panose="020B0604020104020204" pitchFamily="34" charset="0"/>
+              </a:rPr>
+              <a:t>Finally</a:t>
+            </a:r>
+            <a:r>
+              <a:rPr lang="en-US" sz="1200" dirty="0">
+                <a:solidFill>
+                  <a:schemeClr val="accent1"/>
+                </a:solidFill>
+                <a:latin typeface="Abadi" panose="020B0604020104020204" pitchFamily="34" charset="0"/>
+              </a:rPr>
+              <a:t> </a:t>
+            </a:r>
+            <a:r>
+              <a:rPr lang="en-US" sz="1200" dirty="0">
+                <a:solidFill>
+                  <a:schemeClr val="tx1"/>
+                </a:solidFill>
+                <a:latin typeface="Abadi" panose="020B0604020104020204" pitchFamily="34" charset="0"/>
+              </a:rPr>
+              <a:t>overlap to remove alternative 5’SS (VAST-DB PSI-TABLE) from both</a:t>
+            </a:r>
+          </a:p>
+          <a:p>
+            <a:pPr algn="ctr"/>
+            <a:r>
+              <a:rPr lang="en-US" sz="1200" dirty="0">
+                <a:solidFill>
+                  <a:schemeClr val="tx1"/>
+                </a:solidFill>
+                <a:latin typeface="Abadi" panose="020B0604020104020204" pitchFamily="34" charset="0"/>
+              </a:rPr>
+              <a:t>Decoys kept 6,506 /  </a:t>
+            </a:r>
+            <a:r>
+              <a:rPr lang="en-US" sz="1200" dirty="0" err="1">
+                <a:solidFill>
+                  <a:schemeClr val="tx1"/>
+                </a:solidFill>
+                <a:latin typeface="Abadi" panose="020B0604020104020204" pitchFamily="34" charset="0"/>
+              </a:rPr>
+              <a:t>Cryptics</a:t>
+            </a:r>
+            <a:r>
+              <a:rPr lang="en-US" sz="1200" dirty="0">
+                <a:solidFill>
+                  <a:schemeClr val="tx1"/>
+                </a:solidFill>
+                <a:latin typeface="Abadi" panose="020B0604020104020204" pitchFamily="34" charset="0"/>
+              </a:rPr>
+              <a:t> kept 17,721</a:t>
+            </a:r>
+          </a:p>
+        </p:txBody>
+      </p:sp>
+      <p:sp>
+        <p:nvSpPr>
+          <p:cNvPr id="14" name="Rectangle 13">
+            <a:extLst>
+              <a:ext uri="{FF2B5EF4-FFF2-40B4-BE49-F238E27FC236}">
+                <a16:creationId xmlns:a16="http://schemas.microsoft.com/office/drawing/2014/main" id="{075A2A3E-627D-B882-477F-0B33901699FE}"/>
+              </a:ext>
+            </a:extLst>
+          </p:cNvPr>
+          <p:cNvSpPr/>
+          <p:nvPr/>
+        </p:nvSpPr>
+        <p:spPr>
+          <a:xfrm>
+            <a:off x="3685389" y="9838422"/>
+            <a:ext cx="2090721" cy="397108"/>
+          </a:xfrm>
+          <a:prstGeom prst="rect">
+            <a:avLst/>
+          </a:prstGeom>
+          <a:ln w="19050">
+            <a:solidFill>
+              <a:schemeClr val="tx1"/>
+            </a:solidFill>
+          </a:ln>
+        </p:spPr>
+        <p:style>
+          <a:lnRef idx="2">
+            <a:schemeClr val="accent1"/>
+          </a:lnRef>
+          <a:fillRef idx="1">
+            <a:schemeClr val="lt1"/>
+          </a:fillRef>
+          <a:effectRef idx="0">
+            <a:schemeClr val="accent1"/>
+          </a:effectRef>
+          <a:fontRef idx="minor">
+            <a:schemeClr val="dk1"/>
+          </a:fontRef>
+        </p:style>
+        <p:txBody>
+          <a:bodyPr rtlCol="0" anchor="ctr"/>
+          <a:lstStyle/>
+          <a:p>
+            <a:pPr algn="ctr"/>
+            <a:r>
+              <a:rPr lang="en-US" b="1" dirty="0">
+                <a:latin typeface="Raleway" pitchFamily="2" charset="0"/>
+                <a:cs typeface="Posterama" panose="020B0504020200020000" pitchFamily="34" charset="0"/>
+              </a:rPr>
+              <a:t>Rescore locus</a:t>
+            </a:r>
+            <a:endParaRPr lang="en-GB" b="1" dirty="0">
+              <a:latin typeface="Raleway" pitchFamily="2" charset="0"/>
+              <a:cs typeface="Posterama" panose="020B0504020200020000" pitchFamily="34" charset="0"/>
+            </a:endParaRPr>
+          </a:p>
+        </p:txBody>
+      </p:sp>
     </p:spTree>
     <p:extLst>
       <p:ext uri="{BB962C8B-B14F-4D97-AF65-F5344CB8AC3E}">

</xml_diff>

<commit_message>
added notebooks for dupe v cryptic and conservation + recount/sashimi script
</commit_message>
<xml_diff>
--- a/figures/datasetgenerationflowchart.pptx
+++ b/figures/datasetgenerationflowchart.pptx
@@ -261,7 +261,7 @@
           <a:p>
             <a:fld id="{0DAF61AA-5A98-4049-A93E-477E5505141A}" type="datetimeFigureOut">
               <a:rPr lang="en-US" smtClean="0"/>
-              <a:t>9/22/2026</a:t>
+              <a:t>9/29/2026</a:t>
             </a:fld>
             <a:endParaRPr lang="en-US" dirty="0"/>
           </a:p>
@@ -461,7 +461,7 @@
           <a:p>
             <a:fld id="{0DAF61AA-5A98-4049-A93E-477E5505141A}" type="datetimeFigureOut">
               <a:rPr lang="en-US" smtClean="0"/>
-              <a:t>9/22/2026</a:t>
+              <a:t>9/29/2026</a:t>
             </a:fld>
             <a:endParaRPr lang="en-US"/>
           </a:p>
@@ -671,7 +671,7 @@
           <a:p>
             <a:fld id="{0DAF61AA-5A98-4049-A93E-477E5505141A}" type="datetimeFigureOut">
               <a:rPr lang="en-US" smtClean="0"/>
-              <a:t>9/22/2026</a:t>
+              <a:t>9/29/2026</a:t>
             </a:fld>
             <a:endParaRPr lang="en-US"/>
           </a:p>
@@ -871,7 +871,7 @@
           <a:p>
             <a:fld id="{0DAF61AA-5A98-4049-A93E-477E5505141A}" type="datetimeFigureOut">
               <a:rPr lang="en-US" smtClean="0"/>
-              <a:t>9/22/2026</a:t>
+              <a:t>9/29/2026</a:t>
             </a:fld>
             <a:endParaRPr lang="en-US"/>
           </a:p>
@@ -1147,7 +1147,7 @@
           <a:p>
             <a:fld id="{0DAF61AA-5A98-4049-A93E-477E5505141A}" type="datetimeFigureOut">
               <a:rPr lang="en-US" smtClean="0"/>
-              <a:t>9/22/2026</a:t>
+              <a:t>9/29/2026</a:t>
             </a:fld>
             <a:endParaRPr lang="en-US"/>
           </a:p>
@@ -1415,7 +1415,7 @@
           <a:p>
             <a:fld id="{0DAF61AA-5A98-4049-A93E-477E5505141A}" type="datetimeFigureOut">
               <a:rPr lang="en-US" smtClean="0"/>
-              <a:t>9/22/2026</a:t>
+              <a:t>9/29/2026</a:t>
             </a:fld>
             <a:endParaRPr lang="en-US"/>
           </a:p>
@@ -1830,7 +1830,7 @@
           <a:p>
             <a:fld id="{0DAF61AA-5A98-4049-A93E-477E5505141A}" type="datetimeFigureOut">
               <a:rPr lang="en-US" smtClean="0"/>
-              <a:t>9/22/2026</a:t>
+              <a:t>9/29/2026</a:t>
             </a:fld>
             <a:endParaRPr lang="en-US"/>
           </a:p>
@@ -1972,7 +1972,7 @@
           <a:p>
             <a:fld id="{0DAF61AA-5A98-4049-A93E-477E5505141A}" type="datetimeFigureOut">
               <a:rPr lang="en-US" smtClean="0"/>
-              <a:t>9/22/2026</a:t>
+              <a:t>9/29/2026</a:t>
             </a:fld>
             <a:endParaRPr lang="en-US"/>
           </a:p>
@@ -2085,7 +2085,7 @@
           <a:p>
             <a:fld id="{0DAF61AA-5A98-4049-A93E-477E5505141A}" type="datetimeFigureOut">
               <a:rPr lang="en-US" smtClean="0"/>
-              <a:t>9/22/2026</a:t>
+              <a:t>9/29/2026</a:t>
             </a:fld>
             <a:endParaRPr lang="en-US"/>
           </a:p>
@@ -2398,7 +2398,7 @@
           <a:p>
             <a:fld id="{0DAF61AA-5A98-4049-A93E-477E5505141A}" type="datetimeFigureOut">
               <a:rPr lang="en-US" smtClean="0"/>
-              <a:t>9/22/2026</a:t>
+              <a:t>9/29/2026</a:t>
             </a:fld>
             <a:endParaRPr lang="en-US"/>
           </a:p>
@@ -2691,7 +2691,7 @@
           <a:p>
             <a:fld id="{0DAF61AA-5A98-4049-A93E-477E5505141A}" type="datetimeFigureOut">
               <a:rPr lang="en-US" smtClean="0"/>
-              <a:t>9/22/2026</a:t>
+              <a:t>9/29/2026</a:t>
             </a:fld>
             <a:endParaRPr lang="en-US"/>
           </a:p>
@@ -6404,7 +6404,7 @@
             <a:fld id="{0DAF61AA-5A98-4049-A93E-477E5505141A}" type="datetimeFigureOut">
               <a:rPr lang="en-US" smtClean="0"/>
               <a:pPr/>
-              <a:t>9/22/2026</a:t>
+              <a:t>9/29/2026</a:t>
             </a:fld>
             <a:endParaRPr lang="en-US" dirty="0"/>
           </a:p>
@@ -8736,18 +8736,6 @@
             </a:r>
           </a:p>
           <a:p>
-            <a:pPr marL="171450" indent="-171450" algn="ctr">
-              <a:buFont typeface="Arial" panose="020B0604020202020204" pitchFamily="34" charset="0"/>
-              <a:buChar char="•"/>
-            </a:pPr>
-            <a:endParaRPr lang="en-US" sz="1200" dirty="0">
-              <a:solidFill>
-                <a:sysClr val="windowText" lastClr="000000"/>
-              </a:solidFill>
-              <a:latin typeface="Abadi" panose="020B0604020104020204" pitchFamily="34" charset="0"/>
-            </a:endParaRPr>
-          </a:p>
-          <a:p>
             <a:pPr algn="ctr"/>
             <a:r>
               <a:rPr lang="en-US" sz="1200" dirty="0">
@@ -8805,6 +8793,66 @@
                 <a:latin typeface="Abadi" panose="020B0604020104020204" pitchFamily="34" charset="0"/>
               </a:rPr>
               <a:t> kept 17,721</a:t>
+            </a:r>
+          </a:p>
+          <a:p>
+            <a:pPr algn="ctr"/>
+            <a:r>
+              <a:rPr lang="en-US" sz="1200" dirty="0">
+                <a:solidFill>
+                  <a:schemeClr val="tx1"/>
+                </a:solidFill>
+                <a:latin typeface="Abadi" panose="020B0604020104020204" pitchFamily="34" charset="0"/>
+              </a:rPr>
+              <a:t>Then remove 3’SS 100 </a:t>
+            </a:r>
+            <a:r>
+              <a:rPr lang="en-US" sz="1200" dirty="0" err="1">
+                <a:solidFill>
+                  <a:schemeClr val="tx1"/>
+                </a:solidFill>
+                <a:latin typeface="Abadi" panose="020B0604020104020204" pitchFamily="34" charset="0"/>
+              </a:rPr>
+              <a:t>nt</a:t>
+            </a:r>
+            <a:r>
+              <a:rPr lang="en-US" sz="1200" dirty="0">
+                <a:solidFill>
+                  <a:schemeClr val="tx1"/>
+                </a:solidFill>
+                <a:latin typeface="Abadi" panose="020B0604020104020204" pitchFamily="34" charset="0"/>
+              </a:rPr>
+              <a:t> BP region</a:t>
+            </a:r>
+          </a:p>
+          <a:p>
+            <a:pPr algn="ctr"/>
+            <a:r>
+              <a:rPr lang="en-US" sz="1200" dirty="0">
+                <a:solidFill>
+                  <a:schemeClr val="tx1"/>
+                </a:solidFill>
+                <a:latin typeface="Abadi" panose="020B0604020104020204" pitchFamily="34" charset="0"/>
+              </a:rPr>
+              <a:t>Decoys kept 5,689 / </a:t>
+            </a:r>
+            <a:r>
+              <a:rPr lang="en-US" sz="1200" dirty="0" err="1">
+                <a:solidFill>
+                  <a:schemeClr val="tx1"/>
+                </a:solidFill>
+                <a:latin typeface="Abadi" panose="020B0604020104020204" pitchFamily="34" charset="0"/>
+              </a:rPr>
+              <a:t>Cryptics</a:t>
+            </a:r>
+            <a:r>
+              <a:rPr lang="en-US" sz="1200" dirty="0">
+                <a:solidFill>
+                  <a:schemeClr val="tx1"/>
+                </a:solidFill>
+                <a:latin typeface="Abadi" panose="020B0604020104020204" pitchFamily="34" charset="0"/>
+              </a:rPr>
+              <a:t> 16,295</a:t>
             </a:r>
           </a:p>
         </p:txBody>

</xml_diff>